<commit_message>
Make divx.payai.network the canonical public domain
</commit_message>
<xml_diff>
--- a/presentation/build/illustrated-v3/finalizer/DivX-illustrated-v3-candidate.pptx
+++ b/presentation/build/illustrated-v3/finalizer/DivX-illustrated-v3-candidate.pptx
@@ -2,21 +2,21 @@
 <file path=ppt/presentation.xml><?xml version="1.0" encoding="utf-8"?>
 <p:presentation xmlns:p="http://schemas.openxmlformats.org/presentationml/2006/main">
   <p:sldMasterIdLst>
-    <p:sldMasterId xmlns:r="http://schemas.openxmlformats.org/officeDocument/2006/relationships" id="2147483648" r:id="Rcba92f13fc4f42e7"/>
+    <p:sldMasterId xmlns:r="http://schemas.openxmlformats.org/officeDocument/2006/relationships" id="2147483648" r:id="Rce5a7016dab0419a"/>
   </p:sldMasterIdLst>
   <p:notesMasterIdLst>
-    <p:notesMasterId xmlns:r="http://schemas.openxmlformats.org/officeDocument/2006/relationships" r:id="Rbe780a52c3e848c5"/>
+    <p:notesMasterId xmlns:r="http://schemas.openxmlformats.org/officeDocument/2006/relationships" r:id="Rd7603cd292064ed8"/>
   </p:notesMasterIdLst>
   <p:sldIdLst>
-    <p:sldId xmlns:r="http://schemas.openxmlformats.org/officeDocument/2006/relationships" id="256" r:id="R82e0cfcf235b4a60"/>
-    <p:sldId xmlns:r="http://schemas.openxmlformats.org/officeDocument/2006/relationships" id="257" r:id="R5251c04de7fe4b4a"/>
-    <p:sldId xmlns:r="http://schemas.openxmlformats.org/officeDocument/2006/relationships" id="258" r:id="Rcdec20e1753746fc"/>
-    <p:sldId xmlns:r="http://schemas.openxmlformats.org/officeDocument/2006/relationships" id="259" r:id="R21e8d371e5fb4948"/>
-    <p:sldId xmlns:r="http://schemas.openxmlformats.org/officeDocument/2006/relationships" id="260" r:id="R3932c6f2c9c64250"/>
-    <p:sldId xmlns:r="http://schemas.openxmlformats.org/officeDocument/2006/relationships" id="261" r:id="R40d4ec8fd34f4cea"/>
-    <p:sldId xmlns:r="http://schemas.openxmlformats.org/officeDocument/2006/relationships" id="262" r:id="R30154cca261641dd"/>
-    <p:sldId xmlns:r="http://schemas.openxmlformats.org/officeDocument/2006/relationships" id="263" r:id="R55190e6033ec45d2"/>
-    <p:sldId xmlns:r="http://schemas.openxmlformats.org/officeDocument/2006/relationships" id="264" r:id="R24b69eb7120f43ea"/>
+    <p:sldId xmlns:r="http://schemas.openxmlformats.org/officeDocument/2006/relationships" id="256" r:id="Rdd5dde7db7d14d97"/>
+    <p:sldId xmlns:r="http://schemas.openxmlformats.org/officeDocument/2006/relationships" id="257" r:id="R9108b5df3f5c4435"/>
+    <p:sldId xmlns:r="http://schemas.openxmlformats.org/officeDocument/2006/relationships" id="258" r:id="R024d3b33159f4069"/>
+    <p:sldId xmlns:r="http://schemas.openxmlformats.org/officeDocument/2006/relationships" id="259" r:id="Rb1b7a284241b4313"/>
+    <p:sldId xmlns:r="http://schemas.openxmlformats.org/officeDocument/2006/relationships" id="260" r:id="Rab242021e155491f"/>
+    <p:sldId xmlns:r="http://schemas.openxmlformats.org/officeDocument/2006/relationships" id="261" r:id="R5a7598864dd94f2d"/>
+    <p:sldId xmlns:r="http://schemas.openxmlformats.org/officeDocument/2006/relationships" id="262" r:id="R8ddcec5423c4451f"/>
+    <p:sldId xmlns:r="http://schemas.openxmlformats.org/officeDocument/2006/relationships" id="263" r:id="R8cbcf6a630d24f17"/>
+    <p:sldId xmlns:r="http://schemas.openxmlformats.org/officeDocument/2006/relationships" id="264" r:id="Raffa7e28f8b1445d"/>
   </p:sldIdLst>
   <p:sldSz cx="12192000" cy="6858000"/>
   <p:notesSz cx="6858000" cy="9144000"/>
@@ -1020,7 +1020,7 @@
           </a:p>
           <a:p xmlns:a="http://schemas.openxmlformats.org/drawingml/2006/main">
             <a:r>
-              <a:t>Sources and evidence: https://dividendx.payai.network/demos/ | https://dividendx.payai.network/app/ | https://solscan.io/account/2EpQ2iKz921Ce2rremdnFrqG15DQq3Y2rSXbgixceDQE?cluster=devnet | planning/mainnet-readiness-2026-09-20.md | planning/guided-lazy-entry-review-2026-09-21.md</a:t>
+              <a:t>Sources and evidence: https://divx.payai.network/demos/ | https://divx.payai.network/app/ | https://solscan.io/account/2EpQ2iKz921Ce2rremdnFrqG15DQq3Y2rSXbgixceDQE?cluster=devnet | planning/mainnet-readiness-2026-09-20.md | planning/guided-lazy-entry-review-2026-09-21.md</a:t>
             </a:r>
           </a:p>
         </p:txBody>
@@ -1090,7 +1090,7 @@
           <a:lstStyle xmlns:a="http://schemas.openxmlformats.org/drawingml/2006/main"/>
           <a:p xmlns:a="http://schemas.openxmlformats.org/drawingml/2006/main">
             <a:r>
-              <a:t>Narration: The annual program, transaction SDK and guided demo are working. Before mainnet, we need complete issuer records, reviewed settlement operations, independent security review and legal and issuer checks. More liquidity, rolling dividend strategies and other networks come later. Try the guided demo at dividendx.payai.network. No wallet or real funds are needed.</a:t>
+              <a:t>Narration: The annual program, transaction SDK and guided demo are working. Before mainnet, we need complete issuer records, reviewed settlement operations, independent security review and legal and issuer checks. More liquidity, rolling dividend strategies and other networks come later. Try the guided demo at divx.payai.network. No wallet or real funds are needed.</a:t>
             </a:r>
           </a:p>
           <a:p xmlns:a="http://schemas.openxmlformats.org/drawingml/2006/main">
@@ -1100,7 +1100,7 @@
           </a:p>
           <a:p xmlns:a="http://schemas.openxmlformats.org/drawingml/2006/main">
             <a:r>
-              <a:t>Sources and evidence: planning/mainnet-readiness-2026-09-20.md | https://dividendx.payai.network/ | https://github.com/notorious-d-e-v/dividendx-stocklana | https://hackathons.solana.com/hackathons/stocklana</a:t>
+              <a:t>Sources and evidence: planning/mainnet-readiness-2026-09-20.md | https://divx.payai.network/ | https://github.com/notorious-d-e-v/dividendx-stocklana | https://hackathons.solana.com/hackathons/stocklana</a:t>
             </a:r>
           </a:p>
         </p:txBody>
@@ -1168,7 +1168,7 @@
   </p:cSld>
   <p:clrMap bg1="lt1" tx1="dk1" bg2="lt2" tx2="dk2" accent1="accent1" accent2="accent2" accent3="accent3" accent4="accent4" accent5="accent5" accent6="accent6" hlink="hlink" folHlink="folHlink"/>
   <p:sldLayoutIdLst>
-    <p:sldLayoutId xmlns:r="http://schemas.openxmlformats.org/officeDocument/2006/relationships" id="2147483649" r:id="Rbb6ca425f4614a07"/>
+    <p:sldLayoutId xmlns:r="http://schemas.openxmlformats.org/officeDocument/2006/relationships" id="2147483649" r:id="R4efe8309c0df45b1"/>
   </p:sldLayoutIdLst>
   <p:txStyles>
     <p:titleStyle>
@@ -1719,7 +1719,7 @@
           <p:cNvPr id="9" name="">
             <a:extLst xmlns:a="http://schemas.openxmlformats.org/drawingml/2006/main">
               <a:ext uri="{FF2B5EF4-FFF2-40B4-BE49-F238E27FC236}">
-                <a16:creationId xmlns:a16="http://schemas.microsoft.com/office/drawing/2014/main" id="{C9A5874A-45A1-4C2D-9D69-E48C0C89B785}"/>
+                <a16:creationId xmlns:a16="http://schemas.microsoft.com/office/drawing/2014/main" id="{6648D554-4D37-4CB0-8541-AE60561033EE}"/>
               </a:ext>
             </a:extLst>
           </p:cNvPr>
@@ -1750,7 +1750,7 @@
           <p:cNvPr id="2" name="">
             <a:extLst xmlns:a="http://schemas.openxmlformats.org/drawingml/2006/main">
               <a:ext uri="{FF2B5EF4-FFF2-40B4-BE49-F238E27FC236}">
-                <a16:creationId xmlns:a16="http://schemas.microsoft.com/office/drawing/2014/main" id="{54BCE8E8-8647-4C5A-8E3C-BF9F587112B5}"/>
+                <a16:creationId xmlns:a16="http://schemas.microsoft.com/office/drawing/2014/main" id="{29B83D4F-4166-4C98-A6ED-95D407B70684}"/>
               </a:ext>
             </a:extLst>
           </p:cNvPr>
@@ -1781,7 +1781,7 @@
           <p:cNvPr id="3" name="">
             <a:extLst xmlns:a="http://schemas.openxmlformats.org/drawingml/2006/main">
               <a:ext uri="{FF2B5EF4-FFF2-40B4-BE49-F238E27FC236}">
-                <a16:creationId xmlns:a16="http://schemas.microsoft.com/office/drawing/2014/main" id="{D53B4178-E501-4384-8A9E-DC88824B67EF}"/>
+                <a16:creationId xmlns:a16="http://schemas.microsoft.com/office/drawing/2014/main" id="{62645D37-C8E6-46E4-ACC8-0F4E22112756}"/>
               </a:ext>
             </a:extLst>
           </p:cNvPr>
@@ -1842,7 +1842,7 @@
           <p:cNvPr id="4" name="">
             <a:extLst xmlns:a="http://schemas.openxmlformats.org/drawingml/2006/main">
               <a:ext uri="{FF2B5EF4-FFF2-40B4-BE49-F238E27FC236}">
-                <a16:creationId xmlns:a16="http://schemas.microsoft.com/office/drawing/2014/main" id="{F9A15AB3-D7C2-4B53-9621-2F789EBB05BD}"/>
+                <a16:creationId xmlns:a16="http://schemas.microsoft.com/office/drawing/2014/main" id="{CCBDEDEC-96D4-49DB-B9B8-C8089B3CE28B}"/>
               </a:ext>
             </a:extLst>
           </p:cNvPr>
@@ -1903,7 +1903,7 @@
           <p:cNvPr id="5" name="">
             <a:extLst xmlns:a="http://schemas.openxmlformats.org/drawingml/2006/main">
               <a:ext uri="{FF2B5EF4-FFF2-40B4-BE49-F238E27FC236}">
-                <a16:creationId xmlns:a16="http://schemas.microsoft.com/office/drawing/2014/main" id="{14832CA6-F348-420B-B4DB-647B4E08A97B}"/>
+                <a16:creationId xmlns:a16="http://schemas.microsoft.com/office/drawing/2014/main" id="{7FC9C1D1-8AE9-4F26-B410-3F77E183DD61}"/>
               </a:ext>
             </a:extLst>
           </p:cNvPr>
@@ -1972,7 +1972,7 @@
           <p:cNvPr id="6" name="">
             <a:extLst xmlns:a="http://schemas.openxmlformats.org/drawingml/2006/main">
               <a:ext uri="{FF2B5EF4-FFF2-40B4-BE49-F238E27FC236}">
-                <a16:creationId xmlns:a16="http://schemas.microsoft.com/office/drawing/2014/main" id="{0D96C9F1-DB96-4D95-9333-A2DC9D6083CF}"/>
+                <a16:creationId xmlns:a16="http://schemas.microsoft.com/office/drawing/2014/main" id="{E28CF3AC-A541-4B00-8428-32D0F0C5F4B7}"/>
               </a:ext>
             </a:extLst>
           </p:cNvPr>
@@ -2033,7 +2033,7 @@
           <p:cNvPr id="7" name="">
             <a:extLst xmlns:a="http://schemas.openxmlformats.org/drawingml/2006/main">
               <a:ext uri="{FF2B5EF4-FFF2-40B4-BE49-F238E27FC236}">
-                <a16:creationId xmlns:a16="http://schemas.microsoft.com/office/drawing/2014/main" id="{0FCFAEE7-28D5-4F72-ADB4-2F777B6A363D}"/>
+                <a16:creationId xmlns:a16="http://schemas.microsoft.com/office/drawing/2014/main" id="{D8EEABA3-6C06-4980-8436-D736D12C2FB1}"/>
               </a:ext>
             </a:extLst>
           </p:cNvPr>
@@ -2064,7 +2064,7 @@
           <p:cNvPr id="8" name="">
             <a:extLst xmlns:a="http://schemas.openxmlformats.org/drawingml/2006/main">
               <a:ext uri="{FF2B5EF4-FFF2-40B4-BE49-F238E27FC236}">
-                <a16:creationId xmlns:a16="http://schemas.microsoft.com/office/drawing/2014/main" id="{A50BE675-0B49-4330-9E18-9645F168411E}"/>
+                <a16:creationId xmlns:a16="http://schemas.microsoft.com/office/drawing/2014/main" id="{6E503A62-F563-4280-B5AF-D8F9FC4F0B59}"/>
               </a:ext>
             </a:extLst>
           </p:cNvPr>
@@ -2123,7 +2123,7 @@
     </p:spTree>
     <p:extLst>
       <p:ext uri="{BB962C8B-B14F-4D97-AF65-F5344CB8AC3E}">
-        <p14:creationId xmlns:p14="http://schemas.microsoft.com/office/powerpoint/2010/main" val="329597336"/>
+        <p14:creationId xmlns:p14="http://schemas.microsoft.com/office/powerpoint/2010/main" val="51863632"/>
       </p:ext>
     </p:extLst>
   </p:cSld>
@@ -2154,7 +2154,7 @@
           <p:cNvPr id="30" name="">
             <a:extLst xmlns:a="http://schemas.openxmlformats.org/drawingml/2006/main">
               <a:ext uri="{FF2B5EF4-FFF2-40B4-BE49-F238E27FC236}">
-                <a16:creationId xmlns:a16="http://schemas.microsoft.com/office/drawing/2014/main" id="{3F1A6A90-9358-4E4D-A428-6C5A4C40F2B9}"/>
+                <a16:creationId xmlns:a16="http://schemas.microsoft.com/office/drawing/2014/main" id="{2C610038-ECC8-446F-BA04-4525F458E1CD}"/>
               </a:ext>
             </a:extLst>
           </p:cNvPr>
@@ -2185,7 +2185,7 @@
           <p:cNvPr id="2" name="">
             <a:extLst xmlns:a="http://schemas.openxmlformats.org/drawingml/2006/main">
               <a:ext uri="{FF2B5EF4-FFF2-40B4-BE49-F238E27FC236}">
-                <a16:creationId xmlns:a16="http://schemas.microsoft.com/office/drawing/2014/main" id="{464AD90D-CDFB-40A1-895A-A28EFE03DD18}"/>
+                <a16:creationId xmlns:a16="http://schemas.microsoft.com/office/drawing/2014/main" id="{F98D2FBB-7627-449C-80C2-67C43FDCFB04}"/>
               </a:ext>
             </a:extLst>
           </p:cNvPr>
@@ -2216,7 +2216,7 @@
           <p:cNvPr id="3" name="">
             <a:extLst xmlns:a="http://schemas.openxmlformats.org/drawingml/2006/main">
               <a:ext uri="{FF2B5EF4-FFF2-40B4-BE49-F238E27FC236}">
-                <a16:creationId xmlns:a16="http://schemas.microsoft.com/office/drawing/2014/main" id="{466242E6-728B-4179-A435-1E6B9AF120AC}"/>
+                <a16:creationId xmlns:a16="http://schemas.microsoft.com/office/drawing/2014/main" id="{574F4BF5-ED60-4DAD-AB11-31CB1DB2E076}"/>
               </a:ext>
             </a:extLst>
           </p:cNvPr>
@@ -2277,7 +2277,7 @@
           <p:cNvPr id="4" name="">
             <a:extLst xmlns:a="http://schemas.openxmlformats.org/drawingml/2006/main">
               <a:ext uri="{FF2B5EF4-FFF2-40B4-BE49-F238E27FC236}">
-                <a16:creationId xmlns:a16="http://schemas.microsoft.com/office/drawing/2014/main" id="{E2512A2A-0D71-4D87-9F27-CA10CAC37502}"/>
+                <a16:creationId xmlns:a16="http://schemas.microsoft.com/office/drawing/2014/main" id="{1428CEE2-8B41-450A-9C12-964581FF1416}"/>
               </a:ext>
             </a:extLst>
           </p:cNvPr>
@@ -2338,7 +2338,7 @@
           <p:cNvPr id="5" name="">
             <a:extLst xmlns:a="http://schemas.openxmlformats.org/drawingml/2006/main">
               <a:ext uri="{FF2B5EF4-FFF2-40B4-BE49-F238E27FC236}">
-                <a16:creationId xmlns:a16="http://schemas.microsoft.com/office/drawing/2014/main" id="{FBA23709-6EA2-4810-B3BB-DB44D20A0E49}"/>
+                <a16:creationId xmlns:a16="http://schemas.microsoft.com/office/drawing/2014/main" id="{383E3009-6236-4C52-976F-CCE6CD67FEAF}"/>
               </a:ext>
             </a:extLst>
           </p:cNvPr>
@@ -2399,7 +2399,7 @@
           <p:cNvPr id="6" name="">
             <a:extLst xmlns:a="http://schemas.openxmlformats.org/drawingml/2006/main">
               <a:ext uri="{FF2B5EF4-FFF2-40B4-BE49-F238E27FC236}">
-                <a16:creationId xmlns:a16="http://schemas.microsoft.com/office/drawing/2014/main" id="{AA863D6A-F336-48E3-8A0F-FD6B899E5FBE}"/>
+                <a16:creationId xmlns:a16="http://schemas.microsoft.com/office/drawing/2014/main" id="{33A13362-4C2C-424A-B95E-F4C2AEBE9D32}"/>
               </a:ext>
             </a:extLst>
           </p:cNvPr>
@@ -2460,7 +2460,7 @@
           <p:cNvPr id="7" name="">
             <a:extLst xmlns:a="http://schemas.openxmlformats.org/drawingml/2006/main">
               <a:ext uri="{FF2B5EF4-FFF2-40B4-BE49-F238E27FC236}">
-                <a16:creationId xmlns:a16="http://schemas.microsoft.com/office/drawing/2014/main" id="{A2116144-FBD7-4152-A536-0BEF758CFC1A}"/>
+                <a16:creationId xmlns:a16="http://schemas.microsoft.com/office/drawing/2014/main" id="{98DAB798-FD7C-4FA0-A1E6-720FE06473E7}"/>
               </a:ext>
             </a:extLst>
           </p:cNvPr>
@@ -2521,7 +2521,7 @@
           <p:cNvPr id="8" name="">
             <a:extLst xmlns:a="http://schemas.openxmlformats.org/drawingml/2006/main">
               <a:ext uri="{FF2B5EF4-FFF2-40B4-BE49-F238E27FC236}">
-                <a16:creationId xmlns:a16="http://schemas.microsoft.com/office/drawing/2014/main" id="{5B17704F-FF74-49F1-AA3F-5EF04AC15FAD}"/>
+                <a16:creationId xmlns:a16="http://schemas.microsoft.com/office/drawing/2014/main" id="{22F0604F-8352-4C3D-BA1C-AA2355ECE960}"/>
               </a:ext>
             </a:extLst>
           </p:cNvPr>
@@ -2582,7 +2582,7 @@
           <p:cNvPr id="9" name="">
             <a:extLst xmlns:a="http://schemas.openxmlformats.org/drawingml/2006/main">
               <a:ext uri="{FF2B5EF4-FFF2-40B4-BE49-F238E27FC236}">
-                <a16:creationId xmlns:a16="http://schemas.microsoft.com/office/drawing/2014/main" id="{AAB44539-9CF7-4EA8-AF8E-561CA10F4E5B}"/>
+                <a16:creationId xmlns:a16="http://schemas.microsoft.com/office/drawing/2014/main" id="{1CA4BCFB-6691-476F-98F7-1FC1C4DB2EE9}"/>
               </a:ext>
             </a:extLst>
           </p:cNvPr>
@@ -2643,7 +2643,7 @@
           <p:cNvPr id="10" name="">
             <a:extLst xmlns:a="http://schemas.openxmlformats.org/drawingml/2006/main">
               <a:ext uri="{FF2B5EF4-FFF2-40B4-BE49-F238E27FC236}">
-                <a16:creationId xmlns:a16="http://schemas.microsoft.com/office/drawing/2014/main" id="{06B9D2DA-2CB3-49B6-B7E5-6A6821239180}"/>
+                <a16:creationId xmlns:a16="http://schemas.microsoft.com/office/drawing/2014/main" id="{D1AFD158-0B6B-4270-8C6B-FC31627DD837}"/>
               </a:ext>
             </a:extLst>
           </p:cNvPr>
@@ -2704,7 +2704,7 @@
           <p:cNvPr id="11" name="">
             <a:extLst xmlns:a="http://schemas.openxmlformats.org/drawingml/2006/main">
               <a:ext uri="{FF2B5EF4-FFF2-40B4-BE49-F238E27FC236}">
-                <a16:creationId xmlns:a16="http://schemas.microsoft.com/office/drawing/2014/main" id="{717904CF-D428-435D-8486-542F9FDF6C74}"/>
+                <a16:creationId xmlns:a16="http://schemas.microsoft.com/office/drawing/2014/main" id="{6E624088-180C-4D6C-AF71-D21D75BF778B}"/>
               </a:ext>
             </a:extLst>
           </p:cNvPr>
@@ -2765,7 +2765,7 @@
           <p:cNvPr id="12" name="">
             <a:extLst xmlns:a="http://schemas.openxmlformats.org/drawingml/2006/main">
               <a:ext uri="{FF2B5EF4-FFF2-40B4-BE49-F238E27FC236}">
-                <a16:creationId xmlns:a16="http://schemas.microsoft.com/office/drawing/2014/main" id="{B485A91C-5F26-4955-B53E-73DB59B8DFB4}"/>
+                <a16:creationId xmlns:a16="http://schemas.microsoft.com/office/drawing/2014/main" id="{C3A851A6-A581-490F-8F9E-455510A2A721}"/>
               </a:ext>
             </a:extLst>
           </p:cNvPr>
@@ -2826,7 +2826,7 @@
           <p:cNvPr id="13" name="">
             <a:extLst xmlns:a="http://schemas.openxmlformats.org/drawingml/2006/main">
               <a:ext uri="{FF2B5EF4-FFF2-40B4-BE49-F238E27FC236}">
-                <a16:creationId xmlns:a16="http://schemas.microsoft.com/office/drawing/2014/main" id="{E6EECDB1-9549-4B13-9222-46FE1038CB0E}"/>
+                <a16:creationId xmlns:a16="http://schemas.microsoft.com/office/drawing/2014/main" id="{77909E8B-348B-48B9-926B-D447183FD7FC}"/>
               </a:ext>
             </a:extLst>
           </p:cNvPr>
@@ -2857,7 +2857,7 @@
           <p:cNvPr id="14" name="">
             <a:extLst xmlns:a="http://schemas.openxmlformats.org/drawingml/2006/main">
               <a:ext uri="{FF2B5EF4-FFF2-40B4-BE49-F238E27FC236}">
-                <a16:creationId xmlns:a16="http://schemas.microsoft.com/office/drawing/2014/main" id="{9D5093B7-4B6D-494C-8C32-B23D74BE0C49}"/>
+                <a16:creationId xmlns:a16="http://schemas.microsoft.com/office/drawing/2014/main" id="{D378AEA0-3CF1-480F-A597-C7DE0D01C41A}"/>
               </a:ext>
             </a:extLst>
           </p:cNvPr>
@@ -2918,7 +2918,7 @@
           <p:cNvPr id="15" name="Stock holder">
             <a:extLst xmlns:a="http://schemas.openxmlformats.org/drawingml/2006/main">
               <a:ext uri="{FF2B5EF4-FFF2-40B4-BE49-F238E27FC236}">
-                <a16:creationId xmlns:a16="http://schemas.microsoft.com/office/drawing/2014/main" id="{472C9A3B-C798-47AF-8C7F-85C5B400F0DB}"/>
+                <a16:creationId xmlns:a16="http://schemas.microsoft.com/office/drawing/2014/main" id="{BB4DD0B6-6CDF-4533-A9AD-AEF3664CC8CF}"/>
               </a:ext>
             </a:extLst>
           </p:cNvPr>
@@ -2953,7 +2953,7 @@
           <p:cNvPr id="16" name="">
             <a:extLst xmlns:a="http://schemas.openxmlformats.org/drawingml/2006/main">
               <a:ext uri="{FF2B5EF4-FFF2-40B4-BE49-F238E27FC236}">
-                <a16:creationId xmlns:a16="http://schemas.microsoft.com/office/drawing/2014/main" id="{DC2276D5-08BB-4E79-9828-EF0185FAA782}"/>
+                <a16:creationId xmlns:a16="http://schemas.microsoft.com/office/drawing/2014/main" id="{238E9234-167F-4E03-A356-698F969195B9}"/>
               </a:ext>
             </a:extLst>
           </p:cNvPr>
@@ -3014,7 +3014,7 @@
           <p:cNvPr id="17" name="Buyer">
             <a:extLst xmlns:a="http://schemas.openxmlformats.org/drawingml/2006/main">
               <a:ext uri="{FF2B5EF4-FFF2-40B4-BE49-F238E27FC236}">
-                <a16:creationId xmlns:a16="http://schemas.microsoft.com/office/drawing/2014/main" id="{41EBF98A-7E5A-42A5-A9DB-ED123594B35A}"/>
+                <a16:creationId xmlns:a16="http://schemas.microsoft.com/office/drawing/2014/main" id="{1341022F-ABFF-4315-BEAE-2B36559B002C}"/>
               </a:ext>
             </a:extLst>
           </p:cNvPr>
@@ -3049,7 +3049,7 @@
           <p:cNvPr id="18" name="">
             <a:extLst xmlns:a="http://schemas.openxmlformats.org/drawingml/2006/main">
               <a:ext uri="{FF2B5EF4-FFF2-40B4-BE49-F238E27FC236}">
-                <a16:creationId xmlns:a16="http://schemas.microsoft.com/office/drawing/2014/main" id="{622E9D22-42F3-458B-A0EC-5492EC843441}"/>
+                <a16:creationId xmlns:a16="http://schemas.microsoft.com/office/drawing/2014/main" id="{C57C2C72-2D21-44DA-84DC-D14F243D10F6}"/>
               </a:ext>
             </a:extLst>
           </p:cNvPr>
@@ -3110,7 +3110,7 @@
           <p:cNvPr id="19" name="Dividend right label">
             <a:extLst xmlns:a="http://schemas.openxmlformats.org/drawingml/2006/main">
               <a:ext uri="{FF2B5EF4-FFF2-40B4-BE49-F238E27FC236}">
-                <a16:creationId xmlns:a16="http://schemas.microsoft.com/office/drawing/2014/main" id="{13456272-9437-4A2A-8F77-F86D7EC6C093}"/>
+                <a16:creationId xmlns:a16="http://schemas.microsoft.com/office/drawing/2014/main" id="{977EDBF9-572E-4AEB-B30C-32D96A10931B}"/>
               </a:ext>
             </a:extLst>
           </p:cNvPr>
@@ -3145,7 +3145,7 @@
           <p:cNvPr id="20" name="">
             <a:extLst xmlns:a="http://schemas.openxmlformats.org/drawingml/2006/main">
               <a:ext uri="{FF2B5EF4-FFF2-40B4-BE49-F238E27FC236}">
-                <a16:creationId xmlns:a16="http://schemas.microsoft.com/office/drawing/2014/main" id="{B45A18A3-6516-4327-8D57-1516085551B2}"/>
+                <a16:creationId xmlns:a16="http://schemas.microsoft.com/office/drawing/2014/main" id="{5AD953EC-9499-4E29-AE89-60484EB9BC3E}"/>
               </a:ext>
             </a:extLst>
           </p:cNvPr>
@@ -3206,7 +3206,7 @@
           <p:cNvPr id="21" name="Payment label">
             <a:extLst xmlns:a="http://schemas.openxmlformats.org/drawingml/2006/main">
               <a:ext uri="{FF2B5EF4-FFF2-40B4-BE49-F238E27FC236}">
-                <a16:creationId xmlns:a16="http://schemas.microsoft.com/office/drawing/2014/main" id="{37D35F31-5259-40DA-A158-1B9147005902}"/>
+                <a16:creationId xmlns:a16="http://schemas.microsoft.com/office/drawing/2014/main" id="{E76470D5-0A79-4802-84ED-05029C840E84}"/>
               </a:ext>
             </a:extLst>
           </p:cNvPr>
@@ -3241,7 +3241,7 @@
           <p:cNvPr id="22" name="">
             <a:extLst xmlns:a="http://schemas.openxmlformats.org/drawingml/2006/main">
               <a:ext uri="{FF2B5EF4-FFF2-40B4-BE49-F238E27FC236}">
-                <a16:creationId xmlns:a16="http://schemas.microsoft.com/office/drawing/2014/main" id="{BD2B7EA3-7473-48E1-B4B7-F82D2C7B3D2C}"/>
+                <a16:creationId xmlns:a16="http://schemas.microsoft.com/office/drawing/2014/main" id="{4D2CB2F9-0D29-4915-AE1A-C5E10D86194F}"/>
               </a:ext>
             </a:extLst>
           </p:cNvPr>
@@ -3404,7 +3404,7 @@
           <p:cNvPr id="27" name="Retained PT">
             <a:extLst xmlns:a="http://schemas.openxmlformats.org/drawingml/2006/main">
               <a:ext uri="{FF2B5EF4-FFF2-40B4-BE49-F238E27FC236}">
-                <a16:creationId xmlns:a16="http://schemas.microsoft.com/office/drawing/2014/main" id="{D32D7D4C-75E1-4D39-AAAA-5E45CC3E5239}"/>
+                <a16:creationId xmlns:a16="http://schemas.microsoft.com/office/drawing/2014/main" id="{B3DD4E21-199B-4E0C-BAEA-885C35129865}"/>
               </a:ext>
             </a:extLst>
           </p:cNvPr>
@@ -3437,7 +3437,7 @@
           <p:cNvPr id="28" name="">
             <a:extLst xmlns:a="http://schemas.openxmlformats.org/drawingml/2006/main">
               <a:ext uri="{FF2B5EF4-FFF2-40B4-BE49-F238E27FC236}">
-                <a16:creationId xmlns:a16="http://schemas.microsoft.com/office/drawing/2014/main" id="{802F0AB2-284E-4E0C-A887-34F131C46C17}"/>
+                <a16:creationId xmlns:a16="http://schemas.microsoft.com/office/drawing/2014/main" id="{977FCF33-E280-46BB-B8E9-B8609573D850}"/>
               </a:ext>
             </a:extLst>
           </p:cNvPr>
@@ -3498,7 +3498,7 @@
           <p:cNvPr id="29" name="">
             <a:extLst xmlns:a="http://schemas.openxmlformats.org/drawingml/2006/main">
               <a:ext uri="{FF2B5EF4-FFF2-40B4-BE49-F238E27FC236}">
-                <a16:creationId xmlns:a16="http://schemas.microsoft.com/office/drawing/2014/main" id="{E6810572-70FF-45D2-AECE-F2BB6ACB63F5}"/>
+                <a16:creationId xmlns:a16="http://schemas.microsoft.com/office/drawing/2014/main" id="{7A0D9763-EB79-4736-9933-DDD28F7F5D1D}"/>
               </a:ext>
             </a:extLst>
           </p:cNvPr>
@@ -3557,7 +3557,7 @@
     </p:spTree>
     <p:extLst>
       <p:ext uri="{BB962C8B-B14F-4D97-AF65-F5344CB8AC3E}">
-        <p14:creationId xmlns:p14="http://schemas.microsoft.com/office/powerpoint/2010/main" val="238684046"/>
+        <p14:creationId xmlns:p14="http://schemas.microsoft.com/office/powerpoint/2010/main" val="965860808"/>
       </p:ext>
     </p:extLst>
   </p:cSld>
@@ -3588,7 +3588,7 @@
           <p:cNvPr id="14" name="">
             <a:extLst xmlns:a="http://schemas.openxmlformats.org/drawingml/2006/main">
               <a:ext uri="{FF2B5EF4-FFF2-40B4-BE49-F238E27FC236}">
-                <a16:creationId xmlns:a16="http://schemas.microsoft.com/office/drawing/2014/main" id="{522F20DB-8C78-48DF-A99B-600A4190690D}"/>
+                <a16:creationId xmlns:a16="http://schemas.microsoft.com/office/drawing/2014/main" id="{2FA69C95-FA0B-4731-BA56-00314D3FD208}"/>
               </a:ext>
             </a:extLst>
           </p:cNvPr>
@@ -3619,7 +3619,7 @@
           <p:cNvPr id="2" name="">
             <a:extLst xmlns:a="http://schemas.openxmlformats.org/drawingml/2006/main">
               <a:ext uri="{FF2B5EF4-FFF2-40B4-BE49-F238E27FC236}">
-                <a16:creationId xmlns:a16="http://schemas.microsoft.com/office/drawing/2014/main" id="{3470A9CC-A2D2-454C-A343-C98716C4B947}"/>
+                <a16:creationId xmlns:a16="http://schemas.microsoft.com/office/drawing/2014/main" id="{A163455D-70DE-4535-86E1-E4CA7320F45D}"/>
               </a:ext>
             </a:extLst>
           </p:cNvPr>
@@ -3650,7 +3650,7 @@
           <p:cNvPr id="3" name="">
             <a:extLst xmlns:a="http://schemas.openxmlformats.org/drawingml/2006/main">
               <a:ext uri="{FF2B5EF4-FFF2-40B4-BE49-F238E27FC236}">
-                <a16:creationId xmlns:a16="http://schemas.microsoft.com/office/drawing/2014/main" id="{06C9272D-5DE7-447B-A1DC-DC49DF3BD923}"/>
+                <a16:creationId xmlns:a16="http://schemas.microsoft.com/office/drawing/2014/main" id="{733B68E9-0D9A-4899-8AEB-269E478F04CC}"/>
               </a:ext>
             </a:extLst>
           </p:cNvPr>
@@ -3711,7 +3711,7 @@
           <p:cNvPr id="4" name="">
             <a:extLst xmlns:a="http://schemas.openxmlformats.org/drawingml/2006/main">
               <a:ext uri="{FF2B5EF4-FFF2-40B4-BE49-F238E27FC236}">
-                <a16:creationId xmlns:a16="http://schemas.microsoft.com/office/drawing/2014/main" id="{5D9442F9-04B1-45B3-904A-A904DC223B1B}"/>
+                <a16:creationId xmlns:a16="http://schemas.microsoft.com/office/drawing/2014/main" id="{E621F4F4-66FD-479C-AB0F-A1A7F598D2A9}"/>
               </a:ext>
             </a:extLst>
           </p:cNvPr>
@@ -3772,7 +3772,7 @@
           <p:cNvPr id="5" name="">
             <a:extLst xmlns:a="http://schemas.openxmlformats.org/drawingml/2006/main">
               <a:ext uri="{FF2B5EF4-FFF2-40B4-BE49-F238E27FC236}">
-                <a16:creationId xmlns:a16="http://schemas.microsoft.com/office/drawing/2014/main" id="{06083990-6523-4590-AA67-9BD80BB071C5}"/>
+                <a16:creationId xmlns:a16="http://schemas.microsoft.com/office/drawing/2014/main" id="{9E6C3C71-F821-4D6F-BC63-42892C6EE175}"/>
               </a:ext>
             </a:extLst>
           </p:cNvPr>
@@ -3837,7 +3837,7 @@
           <p:nvPr/>
         </p:nvPicPr>
         <p:blipFill>
-          <a:blip xmlns:r="http://schemas.openxmlformats.org/officeDocument/2006/relationships" xmlns:a="http://schemas.openxmlformats.org/drawingml/2006/main" r:embed="R699f5096b74d4308"/>
+          <a:blip xmlns:r="http://schemas.openxmlformats.org/officeDocument/2006/relationships" xmlns:a="http://schemas.openxmlformats.org/drawingml/2006/main" r:embed="R3822230d660c4c64"/>
           <a:stretch xmlns:a="http://schemas.openxmlformats.org/drawingml/2006/main"/>
         </p:blipFill>
         <p:spPr>
@@ -3855,7 +3855,7 @@
           <p:cNvPr id="7" name="">
             <a:extLst xmlns:a="http://schemas.openxmlformats.org/drawingml/2006/main">
               <a:ext uri="{FF2B5EF4-FFF2-40B4-BE49-F238E27FC236}">
-                <a16:creationId xmlns:a16="http://schemas.microsoft.com/office/drawing/2014/main" id="{78FA289D-DCD7-4C45-B4F0-3BCA0909987D}"/>
+                <a16:creationId xmlns:a16="http://schemas.microsoft.com/office/drawing/2014/main" id="{B1175A14-4EF9-4BBB-96DB-9AD23428A09E}"/>
               </a:ext>
             </a:extLst>
           </p:cNvPr>
@@ -3916,7 +3916,7 @@
           <p:cNvPr id="8" name="">
             <a:extLst xmlns:a="http://schemas.openxmlformats.org/drawingml/2006/main">
               <a:ext uri="{FF2B5EF4-FFF2-40B4-BE49-F238E27FC236}">
-                <a16:creationId xmlns:a16="http://schemas.microsoft.com/office/drawing/2014/main" id="{65F7A6F5-3B0F-48D5-B0C4-6DE8F5D03B26}"/>
+                <a16:creationId xmlns:a16="http://schemas.microsoft.com/office/drawing/2014/main" id="{50828CEA-F7E9-4E14-BBFC-BBFC17385A84}"/>
               </a:ext>
             </a:extLst>
           </p:cNvPr>
@@ -3977,7 +3977,7 @@
           <p:cNvPr id="9" name="">
             <a:extLst xmlns:a="http://schemas.openxmlformats.org/drawingml/2006/main">
               <a:ext uri="{FF2B5EF4-FFF2-40B4-BE49-F238E27FC236}">
-                <a16:creationId xmlns:a16="http://schemas.microsoft.com/office/drawing/2014/main" id="{AFD4AD06-5636-49BB-975C-FA385E271F66}"/>
+                <a16:creationId xmlns:a16="http://schemas.microsoft.com/office/drawing/2014/main" id="{8ED2EB29-D3EE-4EBE-8908-1EA1639E7B7E}"/>
               </a:ext>
             </a:extLst>
           </p:cNvPr>
@@ -4038,7 +4038,7 @@
           <p:cNvPr id="10" name="">
             <a:extLst xmlns:a="http://schemas.openxmlformats.org/drawingml/2006/main">
               <a:ext uri="{FF2B5EF4-FFF2-40B4-BE49-F238E27FC236}">
-                <a16:creationId xmlns:a16="http://schemas.microsoft.com/office/drawing/2014/main" id="{EB289021-61B6-40D7-A958-B47FEBBB796C}"/>
+                <a16:creationId xmlns:a16="http://schemas.microsoft.com/office/drawing/2014/main" id="{4F79757C-97E1-4C9F-9F13-208375B1DD21}"/>
               </a:ext>
             </a:extLst>
           </p:cNvPr>
@@ -4099,7 +4099,7 @@
           <p:cNvPr id="11" name="">
             <a:extLst xmlns:a="http://schemas.openxmlformats.org/drawingml/2006/main">
               <a:ext uri="{FF2B5EF4-FFF2-40B4-BE49-F238E27FC236}">
-                <a16:creationId xmlns:a16="http://schemas.microsoft.com/office/drawing/2014/main" id="{34EFB03B-1FD9-4ED0-839F-40C9FCDD7A0B}"/>
+                <a16:creationId xmlns:a16="http://schemas.microsoft.com/office/drawing/2014/main" id="{164C1F0E-6968-4F01-8CF5-FAAC1136AEE4}"/>
               </a:ext>
             </a:extLst>
           </p:cNvPr>
@@ -4160,7 +4160,7 @@
           <p:cNvPr id="12" name="">
             <a:extLst xmlns:a="http://schemas.openxmlformats.org/drawingml/2006/main">
               <a:ext uri="{FF2B5EF4-FFF2-40B4-BE49-F238E27FC236}">
-                <a16:creationId xmlns:a16="http://schemas.microsoft.com/office/drawing/2014/main" id="{C58FFBFB-5463-40EE-8466-22A84EF67DAF}"/>
+                <a16:creationId xmlns:a16="http://schemas.microsoft.com/office/drawing/2014/main" id="{D9E70828-E33B-408D-BD85-AB79712A9A7B}"/>
               </a:ext>
             </a:extLst>
           </p:cNvPr>
@@ -4221,7 +4221,7 @@
           <p:cNvPr id="13" name="">
             <a:extLst xmlns:a="http://schemas.openxmlformats.org/drawingml/2006/main">
               <a:ext uri="{FF2B5EF4-FFF2-40B4-BE49-F238E27FC236}">
-                <a16:creationId xmlns:a16="http://schemas.microsoft.com/office/drawing/2014/main" id="{4F6A98D2-4D69-4A01-BEE6-6B3F8146AF8D}"/>
+                <a16:creationId xmlns:a16="http://schemas.microsoft.com/office/drawing/2014/main" id="{8217BA7B-AEA2-4EA0-9AEF-43A206CCA469}"/>
               </a:ext>
             </a:extLst>
           </p:cNvPr>
@@ -4307,7 +4307,7 @@
     </p:spTree>
     <p:extLst>
       <p:ext uri="{BB962C8B-B14F-4D97-AF65-F5344CB8AC3E}">
-        <p14:creationId xmlns:p14="http://schemas.microsoft.com/office/powerpoint/2010/main" val="767881056"/>
+        <p14:creationId xmlns:p14="http://schemas.microsoft.com/office/powerpoint/2010/main" val="1308839144"/>
       </p:ext>
     </p:extLst>
   </p:cSld>
@@ -4338,7 +4338,7 @@
           <p:cNvPr id="14" name="">
             <a:extLst xmlns:a="http://schemas.openxmlformats.org/drawingml/2006/main">
               <a:ext uri="{FF2B5EF4-FFF2-40B4-BE49-F238E27FC236}">
-                <a16:creationId xmlns:a16="http://schemas.microsoft.com/office/drawing/2014/main" id="{04D5DBFD-CB1C-4085-9228-3880E3143EA5}"/>
+                <a16:creationId xmlns:a16="http://schemas.microsoft.com/office/drawing/2014/main" id="{AEC33539-81B5-42D0-84D0-B8638B0CC087}"/>
               </a:ext>
             </a:extLst>
           </p:cNvPr>
@@ -4369,7 +4369,7 @@
           <p:cNvPr id="2" name="">
             <a:extLst xmlns:a="http://schemas.openxmlformats.org/drawingml/2006/main">
               <a:ext uri="{FF2B5EF4-FFF2-40B4-BE49-F238E27FC236}">
-                <a16:creationId xmlns:a16="http://schemas.microsoft.com/office/drawing/2014/main" id="{E89C0EBC-B297-4209-9EFF-023555D35113}"/>
+                <a16:creationId xmlns:a16="http://schemas.microsoft.com/office/drawing/2014/main" id="{CC7E7525-4251-49AF-B5CE-88CF49FFC5D7}"/>
               </a:ext>
             </a:extLst>
           </p:cNvPr>
@@ -4400,7 +4400,7 @@
           <p:cNvPr id="3" name="">
             <a:extLst xmlns:a="http://schemas.openxmlformats.org/drawingml/2006/main">
               <a:ext uri="{FF2B5EF4-FFF2-40B4-BE49-F238E27FC236}">
-                <a16:creationId xmlns:a16="http://schemas.microsoft.com/office/drawing/2014/main" id="{4FB506FB-51EC-4D42-AE73-D9B8C198BE81}"/>
+                <a16:creationId xmlns:a16="http://schemas.microsoft.com/office/drawing/2014/main" id="{A8F2CDB7-16B3-42C9-982C-E5100C13EDAA}"/>
               </a:ext>
             </a:extLst>
           </p:cNvPr>
@@ -4461,7 +4461,7 @@
           <p:cNvPr id="4" name="">
             <a:extLst xmlns:a="http://schemas.openxmlformats.org/drawingml/2006/main">
               <a:ext uri="{FF2B5EF4-FFF2-40B4-BE49-F238E27FC236}">
-                <a16:creationId xmlns:a16="http://schemas.microsoft.com/office/drawing/2014/main" id="{2A22F161-62D5-40E9-863D-4021BCA0DACE}"/>
+                <a16:creationId xmlns:a16="http://schemas.microsoft.com/office/drawing/2014/main" id="{A44EB30A-2109-4843-866F-0ACD1512B9B2}"/>
               </a:ext>
             </a:extLst>
           </p:cNvPr>
@@ -4522,7 +4522,7 @@
           <p:cNvPr id="5" name="">
             <a:extLst xmlns:a="http://schemas.openxmlformats.org/drawingml/2006/main">
               <a:ext uri="{FF2B5EF4-FFF2-40B4-BE49-F238E27FC236}">
-                <a16:creationId xmlns:a16="http://schemas.microsoft.com/office/drawing/2014/main" id="{EC02CB1B-4FF6-46BA-96E8-11852E79FCB1}"/>
+                <a16:creationId xmlns:a16="http://schemas.microsoft.com/office/drawing/2014/main" id="{5A9E2569-0070-4B08-BFBC-A443D5128C1A}"/>
               </a:ext>
             </a:extLst>
           </p:cNvPr>
@@ -4583,7 +4583,7 @@
           <p:cNvPr id="6" name="">
             <a:extLst xmlns:a="http://schemas.openxmlformats.org/drawingml/2006/main">
               <a:ext uri="{FF2B5EF4-FFF2-40B4-BE49-F238E27FC236}">
-                <a16:creationId xmlns:a16="http://schemas.microsoft.com/office/drawing/2014/main" id="{B4EBADC7-32F7-4E99-A195-B07530989BC3}"/>
+                <a16:creationId xmlns:a16="http://schemas.microsoft.com/office/drawing/2014/main" id="{78814024-ADA8-4A63-8EFC-A9F392982A53}"/>
               </a:ext>
             </a:extLst>
           </p:cNvPr>
@@ -4644,7 +4644,7 @@
           <p:cNvPr id="7" name="">
             <a:extLst xmlns:a="http://schemas.openxmlformats.org/drawingml/2006/main">
               <a:ext uri="{FF2B5EF4-FFF2-40B4-BE49-F238E27FC236}">
-                <a16:creationId xmlns:a16="http://schemas.microsoft.com/office/drawing/2014/main" id="{4A539514-EE1D-4BBC-AD02-51866406A9CB}"/>
+                <a16:creationId xmlns:a16="http://schemas.microsoft.com/office/drawing/2014/main" id="{76343216-694D-4E39-A049-6394766D0503}"/>
               </a:ext>
             </a:extLst>
           </p:cNvPr>
@@ -4705,7 +4705,7 @@
           <p:cNvPr id="8" name="">
             <a:extLst xmlns:a="http://schemas.openxmlformats.org/drawingml/2006/main">
               <a:ext uri="{FF2B5EF4-FFF2-40B4-BE49-F238E27FC236}">
-                <a16:creationId xmlns:a16="http://schemas.microsoft.com/office/drawing/2014/main" id="{CA475113-4EFC-4CA0-B89C-2D715FD6B332}"/>
+                <a16:creationId xmlns:a16="http://schemas.microsoft.com/office/drawing/2014/main" id="{014B2D21-D2A7-4EBE-8B39-B0D2817618AB}"/>
               </a:ext>
             </a:extLst>
           </p:cNvPr>
@@ -4766,7 +4766,7 @@
           <p:cNvPr id="9" name="">
             <a:extLst xmlns:a="http://schemas.openxmlformats.org/drawingml/2006/main">
               <a:ext uri="{FF2B5EF4-FFF2-40B4-BE49-F238E27FC236}">
-                <a16:creationId xmlns:a16="http://schemas.microsoft.com/office/drawing/2014/main" id="{3206335B-E0B4-4D4F-AF29-20D72838928D}"/>
+                <a16:creationId xmlns:a16="http://schemas.microsoft.com/office/drawing/2014/main" id="{BDD07DB9-62AE-4A70-8287-18B1D729B348}"/>
               </a:ext>
             </a:extLst>
           </p:cNvPr>
@@ -4797,7 +4797,7 @@
           <p:cNvPr id="10" name="">
             <a:extLst xmlns:a="http://schemas.openxmlformats.org/drawingml/2006/main">
               <a:ext uri="{FF2B5EF4-FFF2-40B4-BE49-F238E27FC236}">
-                <a16:creationId xmlns:a16="http://schemas.microsoft.com/office/drawing/2014/main" id="{1A420BAF-36B8-4BFE-8592-40CCF77F2C97}"/>
+                <a16:creationId xmlns:a16="http://schemas.microsoft.com/office/drawing/2014/main" id="{13656865-C361-470D-B2D2-5C5D2EDEA312}"/>
               </a:ext>
             </a:extLst>
           </p:cNvPr>
@@ -4858,7 +4858,7 @@
           <p:cNvPr id="11" name="">
             <a:extLst xmlns:a="http://schemas.openxmlformats.org/drawingml/2006/main">
               <a:ext uri="{FF2B5EF4-FFF2-40B4-BE49-F238E27FC236}">
-                <a16:creationId xmlns:a16="http://schemas.microsoft.com/office/drawing/2014/main" id="{07E6FFF6-B355-46ED-8E21-81EC505A7689}"/>
+                <a16:creationId xmlns:a16="http://schemas.microsoft.com/office/drawing/2014/main" id="{86CDD280-A4AC-4402-A3EF-264E02550056}"/>
               </a:ext>
             </a:extLst>
           </p:cNvPr>
@@ -4919,7 +4919,7 @@
           <p:cNvPr id="12" name="">
             <a:extLst xmlns:a="http://schemas.openxmlformats.org/drawingml/2006/main">
               <a:ext uri="{FF2B5EF4-FFF2-40B4-BE49-F238E27FC236}">
-                <a16:creationId xmlns:a16="http://schemas.microsoft.com/office/drawing/2014/main" id="{2A99CB3F-623E-4266-8E0B-5D964577C18F}"/>
+                <a16:creationId xmlns:a16="http://schemas.microsoft.com/office/drawing/2014/main" id="{BD083552-C4CA-4498-93B5-9CA4ABFC5D6B}"/>
               </a:ext>
             </a:extLst>
           </p:cNvPr>
@@ -4980,7 +4980,7 @@
           <p:cNvPr id="13" name="">
             <a:extLst xmlns:a="http://schemas.openxmlformats.org/drawingml/2006/main">
               <a:ext uri="{FF2B5EF4-FFF2-40B4-BE49-F238E27FC236}">
-                <a16:creationId xmlns:a16="http://schemas.microsoft.com/office/drawing/2014/main" id="{76B73C72-D69C-47D2-807B-93C428C15011}"/>
+                <a16:creationId xmlns:a16="http://schemas.microsoft.com/office/drawing/2014/main" id="{FF08C9AD-7FA3-4FE6-90F3-0707FED6EE2D}"/>
               </a:ext>
             </a:extLst>
           </p:cNvPr>
@@ -5047,7 +5047,7 @@
     </p:spTree>
     <p:extLst>
       <p:ext uri="{BB962C8B-B14F-4D97-AF65-F5344CB8AC3E}">
-        <p14:creationId xmlns:p14="http://schemas.microsoft.com/office/powerpoint/2010/main" val="489601405"/>
+        <p14:creationId xmlns:p14="http://schemas.microsoft.com/office/powerpoint/2010/main" val="228003059"/>
       </p:ext>
     </p:extLst>
   </p:cSld>
@@ -5078,7 +5078,7 @@
           <p:cNvPr id="22" name="">
             <a:extLst xmlns:a="http://schemas.openxmlformats.org/drawingml/2006/main">
               <a:ext uri="{FF2B5EF4-FFF2-40B4-BE49-F238E27FC236}">
-                <a16:creationId xmlns:a16="http://schemas.microsoft.com/office/drawing/2014/main" id="{041EC4CF-77F3-499E-AA22-0A210C726587}"/>
+                <a16:creationId xmlns:a16="http://schemas.microsoft.com/office/drawing/2014/main" id="{9F65B8BD-E89D-4867-BCA6-AECF6301ABAC}"/>
               </a:ext>
             </a:extLst>
           </p:cNvPr>
@@ -5109,7 +5109,7 @@
           <p:cNvPr id="2" name="">
             <a:extLst xmlns:a="http://schemas.openxmlformats.org/drawingml/2006/main">
               <a:ext uri="{FF2B5EF4-FFF2-40B4-BE49-F238E27FC236}">
-                <a16:creationId xmlns:a16="http://schemas.microsoft.com/office/drawing/2014/main" id="{8EA4C5CC-BB39-4694-A96F-A84EF98C8C64}"/>
+                <a16:creationId xmlns:a16="http://schemas.microsoft.com/office/drawing/2014/main" id="{23F4B903-6C11-4115-816D-C837D7717013}"/>
               </a:ext>
             </a:extLst>
           </p:cNvPr>
@@ -5140,7 +5140,7 @@
           <p:cNvPr id="3" name="">
             <a:extLst xmlns:a="http://schemas.openxmlformats.org/drawingml/2006/main">
               <a:ext uri="{FF2B5EF4-FFF2-40B4-BE49-F238E27FC236}">
-                <a16:creationId xmlns:a16="http://schemas.microsoft.com/office/drawing/2014/main" id="{223A4617-8F31-4FF7-82F0-E77B0FD1410F}"/>
+                <a16:creationId xmlns:a16="http://schemas.microsoft.com/office/drawing/2014/main" id="{13D9A069-D1FE-45B9-A738-49D4231C26D4}"/>
               </a:ext>
             </a:extLst>
           </p:cNvPr>
@@ -5201,7 +5201,7 @@
           <p:cNvPr id="4" name="">
             <a:extLst xmlns:a="http://schemas.openxmlformats.org/drawingml/2006/main">
               <a:ext uri="{FF2B5EF4-FFF2-40B4-BE49-F238E27FC236}">
-                <a16:creationId xmlns:a16="http://schemas.microsoft.com/office/drawing/2014/main" id="{616E5107-4742-4B4E-AEEA-72D3996405D0}"/>
+                <a16:creationId xmlns:a16="http://schemas.microsoft.com/office/drawing/2014/main" id="{3866F237-0512-485E-B16E-4B0AF5B6F37F}"/>
               </a:ext>
             </a:extLst>
           </p:cNvPr>
@@ -5262,7 +5262,7 @@
           <p:cNvPr id="5" name="">
             <a:extLst xmlns:a="http://schemas.openxmlformats.org/drawingml/2006/main">
               <a:ext uri="{FF2B5EF4-FFF2-40B4-BE49-F238E27FC236}">
-                <a16:creationId xmlns:a16="http://schemas.microsoft.com/office/drawing/2014/main" id="{8D60CB66-75B7-4D4E-A8E3-29BB3B22ECB4}"/>
+                <a16:creationId xmlns:a16="http://schemas.microsoft.com/office/drawing/2014/main" id="{600B5CEE-D2E0-4DED-A69B-C41B60A03DDE}"/>
               </a:ext>
             </a:extLst>
           </p:cNvPr>
@@ -5323,7 +5323,7 @@
           <p:cNvPr id="6" name="">
             <a:extLst xmlns:a="http://schemas.openxmlformats.org/drawingml/2006/main">
               <a:ext uri="{FF2B5EF4-FFF2-40B4-BE49-F238E27FC236}">
-                <a16:creationId xmlns:a16="http://schemas.microsoft.com/office/drawing/2014/main" id="{74E1C7C1-7C6F-419E-99B4-D904144450ED}"/>
+                <a16:creationId xmlns:a16="http://schemas.microsoft.com/office/drawing/2014/main" id="{72D4A476-767F-4390-92B7-F3FA5A41E62F}"/>
               </a:ext>
             </a:extLst>
           </p:cNvPr>
@@ -5384,7 +5384,7 @@
           <p:cNvPr id="7" name="">
             <a:extLst xmlns:a="http://schemas.openxmlformats.org/drawingml/2006/main">
               <a:ext uri="{FF2B5EF4-FFF2-40B4-BE49-F238E27FC236}">
-                <a16:creationId xmlns:a16="http://schemas.microsoft.com/office/drawing/2014/main" id="{B91F4776-7066-4DD8-B184-5FA5B36B9DF1}"/>
+                <a16:creationId xmlns:a16="http://schemas.microsoft.com/office/drawing/2014/main" id="{2FB4690D-1D68-46AF-A9C1-DD022E1B686F}"/>
               </a:ext>
             </a:extLst>
           </p:cNvPr>
@@ -5445,7 +5445,7 @@
           <p:cNvPr id="8" name="">
             <a:extLst xmlns:a="http://schemas.openxmlformats.org/drawingml/2006/main">
               <a:ext uri="{FF2B5EF4-FFF2-40B4-BE49-F238E27FC236}">
-                <a16:creationId xmlns:a16="http://schemas.microsoft.com/office/drawing/2014/main" id="{A45DF65B-CB40-4C64-A82E-C30BAACB12BF}"/>
+                <a16:creationId xmlns:a16="http://schemas.microsoft.com/office/drawing/2014/main" id="{E0D73E20-3E37-482E-8F4A-6BA0219C95A0}"/>
               </a:ext>
             </a:extLst>
           </p:cNvPr>
@@ -5506,7 +5506,7 @@
           <p:cNvPr id="9" name="">
             <a:extLst xmlns:a="http://schemas.openxmlformats.org/drawingml/2006/main">
               <a:ext uri="{FF2B5EF4-FFF2-40B4-BE49-F238E27FC236}">
-                <a16:creationId xmlns:a16="http://schemas.microsoft.com/office/drawing/2014/main" id="{8428022F-B461-4B8C-A073-AD5C134B973B}"/>
+                <a16:creationId xmlns:a16="http://schemas.microsoft.com/office/drawing/2014/main" id="{A229BD87-093D-4331-BF43-88E31AA2B429}"/>
               </a:ext>
             </a:extLst>
           </p:cNvPr>
@@ -5537,7 +5537,7 @@
           <p:cNvPr id="10" name="">
             <a:extLst xmlns:a="http://schemas.openxmlformats.org/drawingml/2006/main">
               <a:ext uri="{FF2B5EF4-FFF2-40B4-BE49-F238E27FC236}">
-                <a16:creationId xmlns:a16="http://schemas.microsoft.com/office/drawing/2014/main" id="{2AFFA52B-DA6B-4F71-B3DA-21B743BE1873}"/>
+                <a16:creationId xmlns:a16="http://schemas.microsoft.com/office/drawing/2014/main" id="{82CB04C6-C192-4067-A53D-BFD60752C371}"/>
               </a:ext>
             </a:extLst>
           </p:cNvPr>
@@ -5598,7 +5598,7 @@
           <p:cNvPr id="11" name="">
             <a:extLst xmlns:a="http://schemas.openxmlformats.org/drawingml/2006/main">
               <a:ext uri="{FF2B5EF4-FFF2-40B4-BE49-F238E27FC236}">
-                <a16:creationId xmlns:a16="http://schemas.microsoft.com/office/drawing/2014/main" id="{A2F52DE6-0C86-4E9A-A16B-4BAE45F8A29C}"/>
+                <a16:creationId xmlns:a16="http://schemas.microsoft.com/office/drawing/2014/main" id="{C29DAC3D-E540-4BAB-99DA-90069DE7C738}"/>
               </a:ext>
             </a:extLst>
           </p:cNvPr>
@@ -5659,7 +5659,7 @@
           <p:cNvPr id="12" name="">
             <a:extLst xmlns:a="http://schemas.openxmlformats.org/drawingml/2006/main">
               <a:ext uri="{FF2B5EF4-FFF2-40B4-BE49-F238E27FC236}">
-                <a16:creationId xmlns:a16="http://schemas.microsoft.com/office/drawing/2014/main" id="{79CBDEA9-E6D6-4ACA-BC55-F42FA0CA352F}"/>
+                <a16:creationId xmlns:a16="http://schemas.microsoft.com/office/drawing/2014/main" id="{699E5670-96F1-4AC9-AEB6-FB2B0E099497}"/>
               </a:ext>
             </a:extLst>
           </p:cNvPr>
@@ -5690,7 +5690,7 @@
           <p:cNvPr id="13" name="">
             <a:extLst xmlns:a="http://schemas.openxmlformats.org/drawingml/2006/main">
               <a:ext uri="{FF2B5EF4-FFF2-40B4-BE49-F238E27FC236}">
-                <a16:creationId xmlns:a16="http://schemas.microsoft.com/office/drawing/2014/main" id="{917C4B04-C5A3-453E-A06A-E37FDC6CCE65}"/>
+                <a16:creationId xmlns:a16="http://schemas.microsoft.com/office/drawing/2014/main" id="{9A66A4C3-CBF4-4660-A312-5B13D60D7D16}"/>
               </a:ext>
             </a:extLst>
           </p:cNvPr>
@@ -5751,7 +5751,7 @@
           <p:cNvPr id="14" name="">
             <a:extLst xmlns:a="http://schemas.openxmlformats.org/drawingml/2006/main">
               <a:ext uri="{FF2B5EF4-FFF2-40B4-BE49-F238E27FC236}">
-                <a16:creationId xmlns:a16="http://schemas.microsoft.com/office/drawing/2014/main" id="{435A8FA7-B436-4364-93A1-8CDAD355AE17}"/>
+                <a16:creationId xmlns:a16="http://schemas.microsoft.com/office/drawing/2014/main" id="{C82D9D7D-0AEF-4AC6-934C-6FB38A4ABA05}"/>
               </a:ext>
             </a:extLst>
           </p:cNvPr>
@@ -5812,7 +5812,7 @@
           <p:cNvPr id="15" name="">
             <a:extLst xmlns:a="http://schemas.openxmlformats.org/drawingml/2006/main">
               <a:ext uri="{FF2B5EF4-FFF2-40B4-BE49-F238E27FC236}">
-                <a16:creationId xmlns:a16="http://schemas.microsoft.com/office/drawing/2014/main" id="{696F1CB8-B9DC-4523-8FED-51E8EEA6CAC2}"/>
+                <a16:creationId xmlns:a16="http://schemas.microsoft.com/office/drawing/2014/main" id="{156592F2-8E68-4E5C-9118-5067606CFA8A}"/>
               </a:ext>
             </a:extLst>
           </p:cNvPr>
@@ -5843,7 +5843,7 @@
           <p:cNvPr id="16" name="">
             <a:extLst xmlns:a="http://schemas.openxmlformats.org/drawingml/2006/main">
               <a:ext uri="{FF2B5EF4-FFF2-40B4-BE49-F238E27FC236}">
-                <a16:creationId xmlns:a16="http://schemas.microsoft.com/office/drawing/2014/main" id="{9B15B5E1-CBC9-4435-B605-3E45E6084A5B}"/>
+                <a16:creationId xmlns:a16="http://schemas.microsoft.com/office/drawing/2014/main" id="{A422F3AD-FBCE-4426-9E19-524B28D3A692}"/>
               </a:ext>
             </a:extLst>
           </p:cNvPr>
@@ -5904,7 +5904,7 @@
           <p:cNvPr id="17" name="">
             <a:extLst xmlns:a="http://schemas.openxmlformats.org/drawingml/2006/main">
               <a:ext uri="{FF2B5EF4-FFF2-40B4-BE49-F238E27FC236}">
-                <a16:creationId xmlns:a16="http://schemas.microsoft.com/office/drawing/2014/main" id="{E885CEA4-9849-4761-8F4E-63CCB938EA30}"/>
+                <a16:creationId xmlns:a16="http://schemas.microsoft.com/office/drawing/2014/main" id="{4F23A775-337D-4AD3-A194-3EE1DA21C982}"/>
               </a:ext>
             </a:extLst>
           </p:cNvPr>
@@ -5965,7 +5965,7 @@
           <p:cNvPr id="18" name="">
             <a:extLst xmlns:a="http://schemas.openxmlformats.org/drawingml/2006/main">
               <a:ext uri="{FF2B5EF4-FFF2-40B4-BE49-F238E27FC236}">
-                <a16:creationId xmlns:a16="http://schemas.microsoft.com/office/drawing/2014/main" id="{592C2396-7DF2-46B5-86FE-5604A7933BE9}"/>
+                <a16:creationId xmlns:a16="http://schemas.microsoft.com/office/drawing/2014/main" id="{39DDFDF5-9B0C-40D6-8267-1565A282126B}"/>
               </a:ext>
             </a:extLst>
           </p:cNvPr>
@@ -5996,7 +5996,7 @@
           <p:cNvPr id="19" name="">
             <a:extLst xmlns:a="http://schemas.openxmlformats.org/drawingml/2006/main">
               <a:ext uri="{FF2B5EF4-FFF2-40B4-BE49-F238E27FC236}">
-                <a16:creationId xmlns:a16="http://schemas.microsoft.com/office/drawing/2014/main" id="{0932D3C7-2DDA-4668-ACFD-79A001509B83}"/>
+                <a16:creationId xmlns:a16="http://schemas.microsoft.com/office/drawing/2014/main" id="{2FC179CA-23F0-4AD7-AD7A-4E52FFBDA69F}"/>
               </a:ext>
             </a:extLst>
           </p:cNvPr>
@@ -6057,7 +6057,7 @@
           <p:cNvPr id="20" name="">
             <a:extLst xmlns:a="http://schemas.openxmlformats.org/drawingml/2006/main">
               <a:ext uri="{FF2B5EF4-FFF2-40B4-BE49-F238E27FC236}">
-                <a16:creationId xmlns:a16="http://schemas.microsoft.com/office/drawing/2014/main" id="{7B8BD266-225B-4186-A416-D3E79B76ED4E}"/>
+                <a16:creationId xmlns:a16="http://schemas.microsoft.com/office/drawing/2014/main" id="{9D910161-3AD0-4B23-9C25-A60C50DA86A0}"/>
               </a:ext>
             </a:extLst>
           </p:cNvPr>
@@ -6118,7 +6118,7 @@
           <p:cNvPr id="21" name="">
             <a:extLst xmlns:a="http://schemas.openxmlformats.org/drawingml/2006/main">
               <a:ext uri="{FF2B5EF4-FFF2-40B4-BE49-F238E27FC236}">
-                <a16:creationId xmlns:a16="http://schemas.microsoft.com/office/drawing/2014/main" id="{69A4AD73-4A28-4D7C-814C-4F2E188ED479}"/>
+                <a16:creationId xmlns:a16="http://schemas.microsoft.com/office/drawing/2014/main" id="{25B2CB95-A8D7-41B5-B218-DAE6B9864429}"/>
               </a:ext>
             </a:extLst>
           </p:cNvPr>
@@ -6177,7 +6177,7 @@
     </p:spTree>
     <p:extLst>
       <p:ext uri="{BB962C8B-B14F-4D97-AF65-F5344CB8AC3E}">
-        <p14:creationId xmlns:p14="http://schemas.microsoft.com/office/powerpoint/2010/main" val="289023299"/>
+        <p14:creationId xmlns:p14="http://schemas.microsoft.com/office/powerpoint/2010/main" val="1979531115"/>
       </p:ext>
     </p:extLst>
   </p:cSld>
@@ -6208,7 +6208,7 @@
           <p:cNvPr id="13" name="">
             <a:extLst xmlns:a="http://schemas.openxmlformats.org/drawingml/2006/main">
               <a:ext uri="{FF2B5EF4-FFF2-40B4-BE49-F238E27FC236}">
-                <a16:creationId xmlns:a16="http://schemas.microsoft.com/office/drawing/2014/main" id="{F724CC4D-BAA9-49C3-A451-AF7E207BE396}"/>
+                <a16:creationId xmlns:a16="http://schemas.microsoft.com/office/drawing/2014/main" id="{43E07749-EAAA-4A77-A512-FFADE559EF81}"/>
               </a:ext>
             </a:extLst>
           </p:cNvPr>
@@ -6239,7 +6239,7 @@
           <p:cNvPr id="2" name="">
             <a:extLst xmlns:a="http://schemas.openxmlformats.org/drawingml/2006/main">
               <a:ext uri="{FF2B5EF4-FFF2-40B4-BE49-F238E27FC236}">
-                <a16:creationId xmlns:a16="http://schemas.microsoft.com/office/drawing/2014/main" id="{8B0923BA-8B28-40C2-B781-949C4662E5AA}"/>
+                <a16:creationId xmlns:a16="http://schemas.microsoft.com/office/drawing/2014/main" id="{8A2C69E5-B4E5-46F0-822C-835197E7634C}"/>
               </a:ext>
             </a:extLst>
           </p:cNvPr>
@@ -6270,7 +6270,7 @@
           <p:cNvPr id="3" name="">
             <a:extLst xmlns:a="http://schemas.openxmlformats.org/drawingml/2006/main">
               <a:ext uri="{FF2B5EF4-FFF2-40B4-BE49-F238E27FC236}">
-                <a16:creationId xmlns:a16="http://schemas.microsoft.com/office/drawing/2014/main" id="{2D670367-018E-4C0D-BCF1-4953B5D41A68}"/>
+                <a16:creationId xmlns:a16="http://schemas.microsoft.com/office/drawing/2014/main" id="{54DD63C6-D531-4E85-9C1C-EB5750C14B41}"/>
               </a:ext>
             </a:extLst>
           </p:cNvPr>
@@ -6331,7 +6331,7 @@
           <p:cNvPr id="4" name="">
             <a:extLst xmlns:a="http://schemas.openxmlformats.org/drawingml/2006/main">
               <a:ext uri="{FF2B5EF4-FFF2-40B4-BE49-F238E27FC236}">
-                <a16:creationId xmlns:a16="http://schemas.microsoft.com/office/drawing/2014/main" id="{84241B67-6164-4F1F-B9D9-FEF21E5A97AC}"/>
+                <a16:creationId xmlns:a16="http://schemas.microsoft.com/office/drawing/2014/main" id="{4638030E-C30A-4A2F-8BCE-3F49E2DB77A7}"/>
               </a:ext>
             </a:extLst>
           </p:cNvPr>
@@ -6392,7 +6392,7 @@
           <p:cNvPr id="5" name="">
             <a:extLst xmlns:a="http://schemas.openxmlformats.org/drawingml/2006/main">
               <a:ext uri="{FF2B5EF4-FFF2-40B4-BE49-F238E27FC236}">
-                <a16:creationId xmlns:a16="http://schemas.microsoft.com/office/drawing/2014/main" id="{31B27648-71C2-4F78-A09D-E73E1C12C942}"/>
+                <a16:creationId xmlns:a16="http://schemas.microsoft.com/office/drawing/2014/main" id="{E2488411-7159-4D82-B5F7-F28DD53D76D4}"/>
               </a:ext>
             </a:extLst>
           </p:cNvPr>
@@ -6453,7 +6453,7 @@
           <p:cNvPr id="6" name="">
             <a:extLst xmlns:a="http://schemas.openxmlformats.org/drawingml/2006/main">
               <a:ext uri="{FF2B5EF4-FFF2-40B4-BE49-F238E27FC236}">
-                <a16:creationId xmlns:a16="http://schemas.microsoft.com/office/drawing/2014/main" id="{F3EE193A-11D1-43B0-9C2B-7B9811BD8B4D}"/>
+                <a16:creationId xmlns:a16="http://schemas.microsoft.com/office/drawing/2014/main" id="{09F866E1-C1A1-4ACF-943B-9CF6292DBDA2}"/>
               </a:ext>
             </a:extLst>
           </p:cNvPr>
@@ -6514,7 +6514,7 @@
           <p:cNvPr id="7" name="">
             <a:extLst xmlns:a="http://schemas.openxmlformats.org/drawingml/2006/main">
               <a:ext uri="{FF2B5EF4-FFF2-40B4-BE49-F238E27FC236}">
-                <a16:creationId xmlns:a16="http://schemas.microsoft.com/office/drawing/2014/main" id="{ECEE499B-BED5-4ABD-9FDF-31BFADC3B098}"/>
+                <a16:creationId xmlns:a16="http://schemas.microsoft.com/office/drawing/2014/main" id="{1F4385B3-8B8F-4F51-8F75-727FA7BA1B4C}"/>
               </a:ext>
             </a:extLst>
           </p:cNvPr>
@@ -6575,7 +6575,7 @@
           <p:cNvPr id="8" name="">
             <a:extLst xmlns:a="http://schemas.openxmlformats.org/drawingml/2006/main">
               <a:ext uri="{FF2B5EF4-FFF2-40B4-BE49-F238E27FC236}">
-                <a16:creationId xmlns:a16="http://schemas.microsoft.com/office/drawing/2014/main" id="{7F565146-4129-4B37-9975-EB0CC9924BC1}"/>
+                <a16:creationId xmlns:a16="http://schemas.microsoft.com/office/drawing/2014/main" id="{935B3170-15AD-44A9-A322-CC45FB1BF515}"/>
               </a:ext>
             </a:extLst>
           </p:cNvPr>
@@ -6640,7 +6640,7 @@
           <p:nvPr/>
         </p:nvPicPr>
         <p:blipFill>
-          <a:blip xmlns:r="http://schemas.openxmlformats.org/officeDocument/2006/relationships" xmlns:a="http://schemas.openxmlformats.org/drawingml/2006/main" r:embed="Rc3566186fa1e4530"/>
+          <a:blip xmlns:r="http://schemas.openxmlformats.org/officeDocument/2006/relationships" xmlns:a="http://schemas.openxmlformats.org/drawingml/2006/main" r:embed="Rd9504d619fae4ca6"/>
           <a:stretch xmlns:a="http://schemas.openxmlformats.org/drawingml/2006/main"/>
         </p:blipFill>
         <p:spPr>
@@ -6658,7 +6658,7 @@
           <p:cNvPr id="10" name="">
             <a:extLst xmlns:a="http://schemas.openxmlformats.org/drawingml/2006/main">
               <a:ext uri="{FF2B5EF4-FFF2-40B4-BE49-F238E27FC236}">
-                <a16:creationId xmlns:a16="http://schemas.microsoft.com/office/drawing/2014/main" id="{20297507-EF60-4F96-AC60-EF83BE76C143}"/>
+                <a16:creationId xmlns:a16="http://schemas.microsoft.com/office/drawing/2014/main" id="{E4DD66F7-2C7F-4B23-AF73-83A91187BEE1}"/>
               </a:ext>
             </a:extLst>
           </p:cNvPr>
@@ -6719,7 +6719,7 @@
           <p:cNvPr id="11" name="">
             <a:extLst xmlns:a="http://schemas.openxmlformats.org/drawingml/2006/main">
               <a:ext uri="{FF2B5EF4-FFF2-40B4-BE49-F238E27FC236}">
-                <a16:creationId xmlns:a16="http://schemas.microsoft.com/office/drawing/2014/main" id="{D51DD200-B4CB-4C2F-A357-9B18215AD0A3}"/>
+                <a16:creationId xmlns:a16="http://schemas.microsoft.com/office/drawing/2014/main" id="{650B537C-0C04-4332-89FE-60DDB6858A51}"/>
               </a:ext>
             </a:extLst>
           </p:cNvPr>
@@ -6780,7 +6780,7 @@
           <p:cNvPr id="12" name="">
             <a:extLst xmlns:a="http://schemas.openxmlformats.org/drawingml/2006/main">
               <a:ext uri="{FF2B5EF4-FFF2-40B4-BE49-F238E27FC236}">
-                <a16:creationId xmlns:a16="http://schemas.microsoft.com/office/drawing/2014/main" id="{45F69085-47F1-4E37-A89C-F5DE4E187064}"/>
+                <a16:creationId xmlns:a16="http://schemas.microsoft.com/office/drawing/2014/main" id="{341767FF-884E-4847-92A7-1A0C852D05F8}"/>
               </a:ext>
             </a:extLst>
           </p:cNvPr>
@@ -6839,7 +6839,7 @@
     </p:spTree>
     <p:extLst>
       <p:ext uri="{BB962C8B-B14F-4D97-AF65-F5344CB8AC3E}">
-        <p14:creationId xmlns:p14="http://schemas.microsoft.com/office/powerpoint/2010/main" val="1704851922"/>
+        <p14:creationId xmlns:p14="http://schemas.microsoft.com/office/powerpoint/2010/main" val="420682946"/>
       </p:ext>
     </p:extLst>
   </p:cSld>
@@ -6870,7 +6870,7 @@
           <p:cNvPr id="21" name="">
             <a:extLst xmlns:a="http://schemas.openxmlformats.org/drawingml/2006/main">
               <a:ext uri="{FF2B5EF4-FFF2-40B4-BE49-F238E27FC236}">
-                <a16:creationId xmlns:a16="http://schemas.microsoft.com/office/drawing/2014/main" id="{6ECD65BB-2E5C-4E67-8F8D-88B5A129AFA6}"/>
+                <a16:creationId xmlns:a16="http://schemas.microsoft.com/office/drawing/2014/main" id="{14A0EE5A-F05A-459F-8532-EF988517B363}"/>
               </a:ext>
             </a:extLst>
           </p:cNvPr>
@@ -6901,7 +6901,7 @@
           <p:cNvPr id="2" name="">
             <a:extLst xmlns:a="http://schemas.openxmlformats.org/drawingml/2006/main">
               <a:ext uri="{FF2B5EF4-FFF2-40B4-BE49-F238E27FC236}">
-                <a16:creationId xmlns:a16="http://schemas.microsoft.com/office/drawing/2014/main" id="{0C40B5B4-A36C-4273-A5ED-6F9492A004E3}"/>
+                <a16:creationId xmlns:a16="http://schemas.microsoft.com/office/drawing/2014/main" id="{B66EB0C6-898A-48EC-A889-1D74EC719D5E}"/>
               </a:ext>
             </a:extLst>
           </p:cNvPr>
@@ -6932,7 +6932,7 @@
           <p:cNvPr id="3" name="">
             <a:extLst xmlns:a="http://schemas.openxmlformats.org/drawingml/2006/main">
               <a:ext uri="{FF2B5EF4-FFF2-40B4-BE49-F238E27FC236}">
-                <a16:creationId xmlns:a16="http://schemas.microsoft.com/office/drawing/2014/main" id="{B5D26D01-C0D3-4772-A092-47135DA98DFF}"/>
+                <a16:creationId xmlns:a16="http://schemas.microsoft.com/office/drawing/2014/main" id="{0FC9A7C1-EFC5-4477-8740-966AB0EF4F23}"/>
               </a:ext>
             </a:extLst>
           </p:cNvPr>
@@ -6993,7 +6993,7 @@
           <p:cNvPr id="4" name="">
             <a:extLst xmlns:a="http://schemas.openxmlformats.org/drawingml/2006/main">
               <a:ext uri="{FF2B5EF4-FFF2-40B4-BE49-F238E27FC236}">
-                <a16:creationId xmlns:a16="http://schemas.microsoft.com/office/drawing/2014/main" id="{EAC3B4D9-0786-4E7D-B71F-2A5F6F521411}"/>
+                <a16:creationId xmlns:a16="http://schemas.microsoft.com/office/drawing/2014/main" id="{C8B4B588-3D23-427E-835F-1929C78124B7}"/>
               </a:ext>
             </a:extLst>
           </p:cNvPr>
@@ -7054,7 +7054,7 @@
           <p:cNvPr id="5" name="">
             <a:extLst xmlns:a="http://schemas.openxmlformats.org/drawingml/2006/main">
               <a:ext uri="{FF2B5EF4-FFF2-40B4-BE49-F238E27FC236}">
-                <a16:creationId xmlns:a16="http://schemas.microsoft.com/office/drawing/2014/main" id="{C9508E1E-8CD6-43B0-A863-7320B0E5C0B7}"/>
+                <a16:creationId xmlns:a16="http://schemas.microsoft.com/office/drawing/2014/main" id="{B1879E7C-885F-4A26-9C38-78A8034C97EA}"/>
               </a:ext>
             </a:extLst>
           </p:cNvPr>
@@ -7115,7 +7115,7 @@
           <p:cNvPr id="6" name="">
             <a:extLst xmlns:a="http://schemas.openxmlformats.org/drawingml/2006/main">
               <a:ext uri="{FF2B5EF4-FFF2-40B4-BE49-F238E27FC236}">
-                <a16:creationId xmlns:a16="http://schemas.microsoft.com/office/drawing/2014/main" id="{B5C691F5-297E-4A81-8316-D11F0B828461}"/>
+                <a16:creationId xmlns:a16="http://schemas.microsoft.com/office/drawing/2014/main" id="{F2378623-B7F5-4052-978F-906E7A43F996}"/>
               </a:ext>
             </a:extLst>
           </p:cNvPr>
@@ -7176,7 +7176,7 @@
           <p:cNvPr id="7" name="">
             <a:extLst xmlns:a="http://schemas.openxmlformats.org/drawingml/2006/main">
               <a:ext uri="{FF2B5EF4-FFF2-40B4-BE49-F238E27FC236}">
-                <a16:creationId xmlns:a16="http://schemas.microsoft.com/office/drawing/2014/main" id="{1A63D338-B750-4E7F-AF61-489663E21CD9}"/>
+                <a16:creationId xmlns:a16="http://schemas.microsoft.com/office/drawing/2014/main" id="{170719A4-7156-48EC-A645-6AE58848EB7D}"/>
               </a:ext>
             </a:extLst>
           </p:cNvPr>
@@ -7237,7 +7237,7 @@
           <p:cNvPr id="8" name="">
             <a:extLst xmlns:a="http://schemas.openxmlformats.org/drawingml/2006/main">
               <a:ext uri="{FF2B5EF4-FFF2-40B4-BE49-F238E27FC236}">
-                <a16:creationId xmlns:a16="http://schemas.microsoft.com/office/drawing/2014/main" id="{E080A8B7-1A94-4B3D-B7A8-55029D2031A8}"/>
+                <a16:creationId xmlns:a16="http://schemas.microsoft.com/office/drawing/2014/main" id="{4CD6C9B8-056E-451B-AE6E-D4AAD348E365}"/>
               </a:ext>
             </a:extLst>
           </p:cNvPr>
@@ -7298,7 +7298,7 @@
           <p:cNvPr id="9" name="">
             <a:extLst xmlns:a="http://schemas.openxmlformats.org/drawingml/2006/main">
               <a:ext uri="{FF2B5EF4-FFF2-40B4-BE49-F238E27FC236}">
-                <a16:creationId xmlns:a16="http://schemas.microsoft.com/office/drawing/2014/main" id="{01BE321D-6A01-463B-931D-792E00543103}"/>
+                <a16:creationId xmlns:a16="http://schemas.microsoft.com/office/drawing/2014/main" id="{3162BD11-A50C-4273-8CE3-8EA59EA4E4FB}"/>
               </a:ext>
             </a:extLst>
           </p:cNvPr>
@@ -7329,7 +7329,7 @@
           <p:cNvPr id="10" name="">
             <a:extLst xmlns:a="http://schemas.openxmlformats.org/drawingml/2006/main">
               <a:ext uri="{FF2B5EF4-FFF2-40B4-BE49-F238E27FC236}">
-                <a16:creationId xmlns:a16="http://schemas.microsoft.com/office/drawing/2014/main" id="{AB878863-2388-4751-9189-A26037EAD2F5}"/>
+                <a16:creationId xmlns:a16="http://schemas.microsoft.com/office/drawing/2014/main" id="{48020FE3-2FE6-4967-881E-FBF3BCED213B}"/>
               </a:ext>
             </a:extLst>
           </p:cNvPr>
@@ -7390,7 +7390,7 @@
           <p:cNvPr id="11" name="">
             <a:extLst xmlns:a="http://schemas.openxmlformats.org/drawingml/2006/main">
               <a:ext uri="{FF2B5EF4-FFF2-40B4-BE49-F238E27FC236}">
-                <a16:creationId xmlns:a16="http://schemas.microsoft.com/office/drawing/2014/main" id="{F618785A-176D-470D-890E-93C7B3C10041}"/>
+                <a16:creationId xmlns:a16="http://schemas.microsoft.com/office/drawing/2014/main" id="{E8DAE95F-686A-4D20-8677-C27AC0AB98D1}"/>
               </a:ext>
             </a:extLst>
           </p:cNvPr>
@@ -7451,7 +7451,7 @@
           <p:cNvPr id="12" name="">
             <a:extLst xmlns:a="http://schemas.openxmlformats.org/drawingml/2006/main">
               <a:ext uri="{FF2B5EF4-FFF2-40B4-BE49-F238E27FC236}">
-                <a16:creationId xmlns:a16="http://schemas.microsoft.com/office/drawing/2014/main" id="{557D7F65-45F8-4F78-9FCD-7451FDE26725}"/>
+                <a16:creationId xmlns:a16="http://schemas.microsoft.com/office/drawing/2014/main" id="{09AE8190-217B-4CB2-912D-58A239B9BE22}"/>
               </a:ext>
             </a:extLst>
           </p:cNvPr>
@@ -7482,7 +7482,7 @@
           <p:cNvPr id="13" name="">
             <a:extLst xmlns:a="http://schemas.openxmlformats.org/drawingml/2006/main">
               <a:ext uri="{FF2B5EF4-FFF2-40B4-BE49-F238E27FC236}">
-                <a16:creationId xmlns:a16="http://schemas.microsoft.com/office/drawing/2014/main" id="{9A8BB805-830B-439F-B98D-675F746E8767}"/>
+                <a16:creationId xmlns:a16="http://schemas.microsoft.com/office/drawing/2014/main" id="{680C1C8F-0E17-4040-9D6C-7B874376AEFE}"/>
               </a:ext>
             </a:extLst>
           </p:cNvPr>
@@ -7543,7 +7543,7 @@
           <p:cNvPr id="14" name="">
             <a:extLst xmlns:a="http://schemas.openxmlformats.org/drawingml/2006/main">
               <a:ext uri="{FF2B5EF4-FFF2-40B4-BE49-F238E27FC236}">
-                <a16:creationId xmlns:a16="http://schemas.microsoft.com/office/drawing/2014/main" id="{CDA4575B-2004-4E79-A8CD-C907BF9D3BA3}"/>
+                <a16:creationId xmlns:a16="http://schemas.microsoft.com/office/drawing/2014/main" id="{81CF10B5-ED77-4E15-9EEB-3E31A48E2EAF}"/>
               </a:ext>
             </a:extLst>
           </p:cNvPr>
@@ -7604,7 +7604,7 @@
           <p:cNvPr id="15" name="">
             <a:extLst xmlns:a="http://schemas.openxmlformats.org/drawingml/2006/main">
               <a:ext uri="{FF2B5EF4-FFF2-40B4-BE49-F238E27FC236}">
-                <a16:creationId xmlns:a16="http://schemas.microsoft.com/office/drawing/2014/main" id="{273508B5-685E-45DF-9BC8-11F7667138EB}"/>
+                <a16:creationId xmlns:a16="http://schemas.microsoft.com/office/drawing/2014/main" id="{D1E23F5F-6D0B-4514-8AFE-287BDD34DE85}"/>
               </a:ext>
             </a:extLst>
           </p:cNvPr>
@@ -7635,7 +7635,7 @@
           <p:cNvPr id="16" name="">
             <a:extLst xmlns:a="http://schemas.openxmlformats.org/drawingml/2006/main">
               <a:ext uri="{FF2B5EF4-FFF2-40B4-BE49-F238E27FC236}">
-                <a16:creationId xmlns:a16="http://schemas.microsoft.com/office/drawing/2014/main" id="{CD3F8393-DB8F-4610-A82A-3B4D98037C38}"/>
+                <a16:creationId xmlns:a16="http://schemas.microsoft.com/office/drawing/2014/main" id="{A135E9C7-73A1-4C6D-878E-0D11F9B5D593}"/>
               </a:ext>
             </a:extLst>
           </p:cNvPr>
@@ -7696,7 +7696,7 @@
           <p:cNvPr id="17" name="">
             <a:extLst xmlns:a="http://schemas.openxmlformats.org/drawingml/2006/main">
               <a:ext uri="{FF2B5EF4-FFF2-40B4-BE49-F238E27FC236}">
-                <a16:creationId xmlns:a16="http://schemas.microsoft.com/office/drawing/2014/main" id="{FD7263DF-49B6-46F0-A9A1-4A5AE675EB0E}"/>
+                <a16:creationId xmlns:a16="http://schemas.microsoft.com/office/drawing/2014/main" id="{EDD67867-F181-4EDE-B0FC-A61235DD3AB3}"/>
               </a:ext>
             </a:extLst>
           </p:cNvPr>
@@ -7757,7 +7757,7 @@
           <p:cNvPr id="18" name="">
             <a:extLst xmlns:a="http://schemas.openxmlformats.org/drawingml/2006/main">
               <a:ext uri="{FF2B5EF4-FFF2-40B4-BE49-F238E27FC236}">
-                <a16:creationId xmlns:a16="http://schemas.microsoft.com/office/drawing/2014/main" id="{D2B14BE2-CA9A-4C8B-80DD-82E96C5F5F69}"/>
+                <a16:creationId xmlns:a16="http://schemas.microsoft.com/office/drawing/2014/main" id="{59F83F8D-483A-488E-95F2-6612B1A92350}"/>
               </a:ext>
             </a:extLst>
           </p:cNvPr>
@@ -7788,7 +7788,7 @@
           <p:cNvPr id="19" name="">
             <a:extLst xmlns:a="http://schemas.openxmlformats.org/drawingml/2006/main">
               <a:ext uri="{FF2B5EF4-FFF2-40B4-BE49-F238E27FC236}">
-                <a16:creationId xmlns:a16="http://schemas.microsoft.com/office/drawing/2014/main" id="{22BE5686-C786-4C61-97B4-D8523AA286BC}"/>
+                <a16:creationId xmlns:a16="http://schemas.microsoft.com/office/drawing/2014/main" id="{8BEA964E-410F-458C-8543-CFB65AAF07EB}"/>
               </a:ext>
             </a:extLst>
           </p:cNvPr>
@@ -7849,7 +7849,7 @@
           <p:cNvPr id="20" name="">
             <a:extLst xmlns:a="http://schemas.openxmlformats.org/drawingml/2006/main">
               <a:ext uri="{FF2B5EF4-FFF2-40B4-BE49-F238E27FC236}">
-                <a16:creationId xmlns:a16="http://schemas.microsoft.com/office/drawing/2014/main" id="{ABF2A6DB-A78A-4CD4-B141-DEFAC86CE842}"/>
+                <a16:creationId xmlns:a16="http://schemas.microsoft.com/office/drawing/2014/main" id="{54D1E27A-F778-496B-82F4-FE94ED1B129E}"/>
               </a:ext>
             </a:extLst>
           </p:cNvPr>
@@ -7908,7 +7908,7 @@
     </p:spTree>
     <p:extLst>
       <p:ext uri="{BB962C8B-B14F-4D97-AF65-F5344CB8AC3E}">
-        <p14:creationId xmlns:p14="http://schemas.microsoft.com/office/powerpoint/2010/main" val="664848293"/>
+        <p14:creationId xmlns:p14="http://schemas.microsoft.com/office/powerpoint/2010/main" val="1204431957"/>
       </p:ext>
     </p:extLst>
   </p:cSld>
@@ -7939,7 +7939,7 @@
           <p:cNvPr id="15" name="">
             <a:extLst xmlns:a="http://schemas.openxmlformats.org/drawingml/2006/main">
               <a:ext uri="{FF2B5EF4-FFF2-40B4-BE49-F238E27FC236}">
-                <a16:creationId xmlns:a16="http://schemas.microsoft.com/office/drawing/2014/main" id="{5125E158-9433-4DE1-BC69-35E55B04CE1C}"/>
+                <a16:creationId xmlns:a16="http://schemas.microsoft.com/office/drawing/2014/main" id="{299AD2F1-B3BD-4858-A06E-C3E44E541BE9}"/>
               </a:ext>
             </a:extLst>
           </p:cNvPr>
@@ -7970,7 +7970,7 @@
           <p:cNvPr id="2" name="">
             <a:extLst xmlns:a="http://schemas.openxmlformats.org/drawingml/2006/main">
               <a:ext uri="{FF2B5EF4-FFF2-40B4-BE49-F238E27FC236}">
-                <a16:creationId xmlns:a16="http://schemas.microsoft.com/office/drawing/2014/main" id="{FCFE303C-3514-4FF0-84A8-519C09FCDC58}"/>
+                <a16:creationId xmlns:a16="http://schemas.microsoft.com/office/drawing/2014/main" id="{9BB487C5-E00B-41BB-B176-B034F5416A3D}"/>
               </a:ext>
             </a:extLst>
           </p:cNvPr>
@@ -8001,7 +8001,7 @@
           <p:cNvPr id="3" name="">
             <a:extLst xmlns:a="http://schemas.openxmlformats.org/drawingml/2006/main">
               <a:ext uri="{FF2B5EF4-FFF2-40B4-BE49-F238E27FC236}">
-                <a16:creationId xmlns:a16="http://schemas.microsoft.com/office/drawing/2014/main" id="{2E18B9D0-F3FF-4FEE-8DA1-91273E01F2B9}"/>
+                <a16:creationId xmlns:a16="http://schemas.microsoft.com/office/drawing/2014/main" id="{68942C3C-3ACF-4898-B7C6-33B53425FFA1}"/>
               </a:ext>
             </a:extLst>
           </p:cNvPr>
@@ -8062,7 +8062,7 @@
           <p:cNvPr id="4" name="">
             <a:extLst xmlns:a="http://schemas.openxmlformats.org/drawingml/2006/main">
               <a:ext uri="{FF2B5EF4-FFF2-40B4-BE49-F238E27FC236}">
-                <a16:creationId xmlns:a16="http://schemas.microsoft.com/office/drawing/2014/main" id="{1A9E603C-A8A7-4728-A2B3-DC304CEA86EF}"/>
+                <a16:creationId xmlns:a16="http://schemas.microsoft.com/office/drawing/2014/main" id="{69EEBC91-DE3E-41BF-82E1-DA7A8C4E9C25}"/>
               </a:ext>
             </a:extLst>
           </p:cNvPr>
@@ -8123,7 +8123,7 @@
           <p:cNvPr id="5" name="">
             <a:extLst xmlns:a="http://schemas.openxmlformats.org/drawingml/2006/main">
               <a:ext uri="{FF2B5EF4-FFF2-40B4-BE49-F238E27FC236}">
-                <a16:creationId xmlns:a16="http://schemas.microsoft.com/office/drawing/2014/main" id="{55CA4416-82AA-4719-B592-6EC86C515B69}"/>
+                <a16:creationId xmlns:a16="http://schemas.microsoft.com/office/drawing/2014/main" id="{CE81C59F-D324-421E-AD5C-25DE2FB987DF}"/>
               </a:ext>
             </a:extLst>
           </p:cNvPr>
@@ -8188,7 +8188,7 @@
           <p:nvPr/>
         </p:nvPicPr>
         <p:blipFill>
-          <a:blip xmlns:r="http://schemas.openxmlformats.org/officeDocument/2006/relationships" xmlns:a="http://schemas.openxmlformats.org/drawingml/2006/main" r:embed="R5367d719136f4789"/>
+          <a:blip xmlns:r="http://schemas.openxmlformats.org/officeDocument/2006/relationships" xmlns:a="http://schemas.openxmlformats.org/drawingml/2006/main" r:embed="R3b51eb5c69984651"/>
           <a:stretch xmlns:a="http://schemas.openxmlformats.org/drawingml/2006/main"/>
         </p:blipFill>
         <p:spPr>
@@ -8206,7 +8206,7 @@
           <p:cNvPr id="7" name="">
             <a:extLst xmlns:a="http://schemas.openxmlformats.org/drawingml/2006/main">
               <a:ext uri="{FF2B5EF4-FFF2-40B4-BE49-F238E27FC236}">
-                <a16:creationId xmlns:a16="http://schemas.microsoft.com/office/drawing/2014/main" id="{ECFCC9B9-BA1E-4B62-ADD5-3FA690717334}"/>
+                <a16:creationId xmlns:a16="http://schemas.microsoft.com/office/drawing/2014/main" id="{A141716E-9959-4E75-A6E5-68D104F18930}"/>
               </a:ext>
             </a:extLst>
           </p:cNvPr>
@@ -8267,7 +8267,7 @@
           <p:cNvPr id="8" name="">
             <a:extLst xmlns:a="http://schemas.openxmlformats.org/drawingml/2006/main">
               <a:ext uri="{FF2B5EF4-FFF2-40B4-BE49-F238E27FC236}">
-                <a16:creationId xmlns:a16="http://schemas.microsoft.com/office/drawing/2014/main" id="{FEEF33AF-2A8B-4C44-929F-2B5D0F199E26}"/>
+                <a16:creationId xmlns:a16="http://schemas.microsoft.com/office/drawing/2014/main" id="{62ED4054-B1AD-4336-B250-0073C69A5F15}"/>
               </a:ext>
             </a:extLst>
           </p:cNvPr>
@@ -8328,7 +8328,7 @@
           <p:cNvPr id="9" name="">
             <a:extLst xmlns:a="http://schemas.openxmlformats.org/drawingml/2006/main">
               <a:ext uri="{FF2B5EF4-FFF2-40B4-BE49-F238E27FC236}">
-                <a16:creationId xmlns:a16="http://schemas.microsoft.com/office/drawing/2014/main" id="{D3E5C4EE-53B3-4142-A848-ECBBA726852C}"/>
+                <a16:creationId xmlns:a16="http://schemas.microsoft.com/office/drawing/2014/main" id="{7225D032-EB91-4BD1-9908-877DE802C532}"/>
               </a:ext>
             </a:extLst>
           </p:cNvPr>
@@ -8389,7 +8389,7 @@
           <p:cNvPr id="10" name="">
             <a:extLst xmlns:a="http://schemas.openxmlformats.org/drawingml/2006/main">
               <a:ext uri="{FF2B5EF4-FFF2-40B4-BE49-F238E27FC236}">
-                <a16:creationId xmlns:a16="http://schemas.microsoft.com/office/drawing/2014/main" id="{63CEACC5-FB54-4F2E-B2C5-9BF2FC12B13A}"/>
+                <a16:creationId xmlns:a16="http://schemas.microsoft.com/office/drawing/2014/main" id="{3F788298-1535-483A-B712-CC907505DE13}"/>
               </a:ext>
             </a:extLst>
           </p:cNvPr>
@@ -8450,7 +8450,7 @@
           <p:cNvPr id="11" name="">
             <a:extLst xmlns:a="http://schemas.openxmlformats.org/drawingml/2006/main">
               <a:ext uri="{FF2B5EF4-FFF2-40B4-BE49-F238E27FC236}">
-                <a16:creationId xmlns:a16="http://schemas.microsoft.com/office/drawing/2014/main" id="{1598D49D-AAF5-4219-B74B-D098EEBBBF3D}"/>
+                <a16:creationId xmlns:a16="http://schemas.microsoft.com/office/drawing/2014/main" id="{474A3BF7-4C24-4116-A7A8-FCFDEFA9BB1E}"/>
               </a:ext>
             </a:extLst>
           </p:cNvPr>
@@ -8511,7 +8511,7 @@
           <p:cNvPr id="12" name="">
             <a:extLst xmlns:a="http://schemas.openxmlformats.org/drawingml/2006/main">
               <a:ext uri="{FF2B5EF4-FFF2-40B4-BE49-F238E27FC236}">
-                <a16:creationId xmlns:a16="http://schemas.microsoft.com/office/drawing/2014/main" id="{9D35F8FD-62F2-4A0F-985E-35EFC948F735}"/>
+                <a16:creationId xmlns:a16="http://schemas.microsoft.com/office/drawing/2014/main" id="{A63E160D-8F66-4B02-BDAC-2735C4542A6E}"/>
               </a:ext>
             </a:extLst>
           </p:cNvPr>
@@ -8572,7 +8572,7 @@
           <p:cNvPr id="13" name="">
             <a:extLst xmlns:a="http://schemas.openxmlformats.org/drawingml/2006/main">
               <a:ext uri="{FF2B5EF4-FFF2-40B4-BE49-F238E27FC236}">
-                <a16:creationId xmlns:a16="http://schemas.microsoft.com/office/drawing/2014/main" id="{51AA0972-9B7B-43EC-AC62-00E9C3C400BA}"/>
+                <a16:creationId xmlns:a16="http://schemas.microsoft.com/office/drawing/2014/main" id="{9CACFCF5-73B2-48F0-9DF0-1E8AA825AFB4}"/>
               </a:ext>
             </a:extLst>
           </p:cNvPr>
@@ -8660,7 +8660,7 @@
           <p:cNvPr id="14" name="">
             <a:extLst xmlns:a="http://schemas.openxmlformats.org/drawingml/2006/main">
               <a:ext uri="{FF2B5EF4-FFF2-40B4-BE49-F238E27FC236}">
-                <a16:creationId xmlns:a16="http://schemas.microsoft.com/office/drawing/2014/main" id="{9A40CB8B-09F0-4D08-8C88-5FBC49E422CE}"/>
+                <a16:creationId xmlns:a16="http://schemas.microsoft.com/office/drawing/2014/main" id="{61445DF5-A2B0-42E0-9F48-34B3389BBB8C}"/>
               </a:ext>
             </a:extLst>
           </p:cNvPr>
@@ -8719,7 +8719,7 @@
     </p:spTree>
     <p:extLst>
       <p:ext uri="{BB962C8B-B14F-4D97-AF65-F5344CB8AC3E}">
-        <p14:creationId xmlns:p14="http://schemas.microsoft.com/office/powerpoint/2010/main" val="161250711"/>
+        <p14:creationId xmlns:p14="http://schemas.microsoft.com/office/powerpoint/2010/main" val="704744169"/>
       </p:ext>
     </p:extLst>
   </p:cSld>
@@ -8750,7 +8750,7 @@
           <p:cNvPr id="16" name="">
             <a:extLst xmlns:a="http://schemas.openxmlformats.org/drawingml/2006/main">
               <a:ext uri="{FF2B5EF4-FFF2-40B4-BE49-F238E27FC236}">
-                <a16:creationId xmlns:a16="http://schemas.microsoft.com/office/drawing/2014/main" id="{EBAC8066-EBE7-4BAD-AFE6-2B3D5655BF4E}"/>
+                <a16:creationId xmlns:a16="http://schemas.microsoft.com/office/drawing/2014/main" id="{26D821BB-B0F2-4D52-8127-87BE1109E61C}"/>
               </a:ext>
             </a:extLst>
           </p:cNvPr>
@@ -8781,7 +8781,7 @@
           <p:cNvPr id="2" name="">
             <a:extLst xmlns:a="http://schemas.openxmlformats.org/drawingml/2006/main">
               <a:ext uri="{FF2B5EF4-FFF2-40B4-BE49-F238E27FC236}">
-                <a16:creationId xmlns:a16="http://schemas.microsoft.com/office/drawing/2014/main" id="{29B57260-1661-4CD4-993F-862CA3E2E08C}"/>
+                <a16:creationId xmlns:a16="http://schemas.microsoft.com/office/drawing/2014/main" id="{A2CC938E-6991-44F2-AD2B-1B96F54AC5FB}"/>
               </a:ext>
             </a:extLst>
           </p:cNvPr>
@@ -8812,7 +8812,7 @@
           <p:cNvPr id="3" name="">
             <a:extLst xmlns:a="http://schemas.openxmlformats.org/drawingml/2006/main">
               <a:ext uri="{FF2B5EF4-FFF2-40B4-BE49-F238E27FC236}">
-                <a16:creationId xmlns:a16="http://schemas.microsoft.com/office/drawing/2014/main" id="{5A4D3D5A-BAD1-4F10-B165-7F74C0C9C2AA}"/>
+                <a16:creationId xmlns:a16="http://schemas.microsoft.com/office/drawing/2014/main" id="{82E402EA-7B64-422E-963C-A92B121E684A}"/>
               </a:ext>
             </a:extLst>
           </p:cNvPr>
@@ -8873,7 +8873,7 @@
           <p:cNvPr id="4" name="">
             <a:extLst xmlns:a="http://schemas.openxmlformats.org/drawingml/2006/main">
               <a:ext uri="{FF2B5EF4-FFF2-40B4-BE49-F238E27FC236}">
-                <a16:creationId xmlns:a16="http://schemas.microsoft.com/office/drawing/2014/main" id="{0E4B7514-9C73-4DEF-B2FA-6851789EDFCD}"/>
+                <a16:creationId xmlns:a16="http://schemas.microsoft.com/office/drawing/2014/main" id="{34A9C352-69E6-48CE-A683-2EBBD4FE98EF}"/>
               </a:ext>
             </a:extLst>
           </p:cNvPr>
@@ -8934,7 +8934,7 @@
           <p:cNvPr id="5" name="">
             <a:extLst xmlns:a="http://schemas.openxmlformats.org/drawingml/2006/main">
               <a:ext uri="{FF2B5EF4-FFF2-40B4-BE49-F238E27FC236}">
-                <a16:creationId xmlns:a16="http://schemas.microsoft.com/office/drawing/2014/main" id="{6D95F6C1-BE8A-42B2-928D-995EAE23125F}"/>
+                <a16:creationId xmlns:a16="http://schemas.microsoft.com/office/drawing/2014/main" id="{229B2765-2433-4E5C-9B65-2E53BC430F23}"/>
               </a:ext>
             </a:extLst>
           </p:cNvPr>
@@ -8995,7 +8995,7 @@
           <p:cNvPr id="6" name="">
             <a:extLst xmlns:a="http://schemas.openxmlformats.org/drawingml/2006/main">
               <a:ext uri="{FF2B5EF4-FFF2-40B4-BE49-F238E27FC236}">
-                <a16:creationId xmlns:a16="http://schemas.microsoft.com/office/drawing/2014/main" id="{53A3CF1B-A9AB-45A5-A2EC-A1B015B8D1AA}"/>
+                <a16:creationId xmlns:a16="http://schemas.microsoft.com/office/drawing/2014/main" id="{A494EADC-814E-4E22-8A84-C85D9363EC03}"/>
               </a:ext>
             </a:extLst>
           </p:cNvPr>
@@ -9056,7 +9056,7 @@
           <p:cNvPr id="7" name="">
             <a:extLst xmlns:a="http://schemas.openxmlformats.org/drawingml/2006/main">
               <a:ext uri="{FF2B5EF4-FFF2-40B4-BE49-F238E27FC236}">
-                <a16:creationId xmlns:a16="http://schemas.microsoft.com/office/drawing/2014/main" id="{1A5C0943-C42D-4FB5-85DA-FD2B70020791}"/>
+                <a16:creationId xmlns:a16="http://schemas.microsoft.com/office/drawing/2014/main" id="{1FE951A2-3249-41C6-9544-06B85455FED7}"/>
               </a:ext>
             </a:extLst>
           </p:cNvPr>
@@ -9171,7 +9171,7 @@
           <p:cNvPr id="8" name="">
             <a:extLst xmlns:a="http://schemas.openxmlformats.org/drawingml/2006/main">
               <a:ext uri="{FF2B5EF4-FFF2-40B4-BE49-F238E27FC236}">
-                <a16:creationId xmlns:a16="http://schemas.microsoft.com/office/drawing/2014/main" id="{9F6D1755-868E-4B3E-B2E0-3DF2186879AD}"/>
+                <a16:creationId xmlns:a16="http://schemas.microsoft.com/office/drawing/2014/main" id="{2DF49F1E-7BE0-48EC-958A-1FEFEAF897D4}"/>
               </a:ext>
             </a:extLst>
           </p:cNvPr>
@@ -9202,7 +9202,7 @@
           <p:cNvPr id="9" name="">
             <a:extLst xmlns:a="http://schemas.openxmlformats.org/drawingml/2006/main">
               <a:ext uri="{FF2B5EF4-FFF2-40B4-BE49-F238E27FC236}">
-                <a16:creationId xmlns:a16="http://schemas.microsoft.com/office/drawing/2014/main" id="{B4F34D84-5399-463A-8052-57B192321867}"/>
+                <a16:creationId xmlns:a16="http://schemas.microsoft.com/office/drawing/2014/main" id="{7A23CAA3-CA8B-4C2B-AF34-B36310F9D2DE}"/>
               </a:ext>
             </a:extLst>
           </p:cNvPr>
@@ -9263,7 +9263,7 @@
           <p:cNvPr id="10" name="">
             <a:extLst xmlns:a="http://schemas.openxmlformats.org/drawingml/2006/main">
               <a:ext uri="{FF2B5EF4-FFF2-40B4-BE49-F238E27FC236}">
-                <a16:creationId xmlns:a16="http://schemas.microsoft.com/office/drawing/2014/main" id="{D9F75444-225E-4C4F-9659-33075D714F21}"/>
+                <a16:creationId xmlns:a16="http://schemas.microsoft.com/office/drawing/2014/main" id="{24B2F1AB-783B-44BC-9940-263844491F7B}"/>
               </a:ext>
             </a:extLst>
           </p:cNvPr>
@@ -9378,7 +9378,7 @@
           <p:cNvPr id="11" name="">
             <a:extLst xmlns:a="http://schemas.openxmlformats.org/drawingml/2006/main">
               <a:ext uri="{FF2B5EF4-FFF2-40B4-BE49-F238E27FC236}">
-                <a16:creationId xmlns:a16="http://schemas.microsoft.com/office/drawing/2014/main" id="{9476A1E1-CCF6-4F77-AB39-D96A4721AE98}"/>
+                <a16:creationId xmlns:a16="http://schemas.microsoft.com/office/drawing/2014/main" id="{62389484-007C-4A8A-AB3E-05EDC4095A05}"/>
               </a:ext>
             </a:extLst>
           </p:cNvPr>
@@ -9439,7 +9439,7 @@
           <p:cNvPr id="12" name="">
             <a:extLst xmlns:a="http://schemas.openxmlformats.org/drawingml/2006/main">
               <a:ext uri="{FF2B5EF4-FFF2-40B4-BE49-F238E27FC236}">
-                <a16:creationId xmlns:a16="http://schemas.microsoft.com/office/drawing/2014/main" id="{940FFA9E-CA23-4588-B00F-1777508A1176}"/>
+                <a16:creationId xmlns:a16="http://schemas.microsoft.com/office/drawing/2014/main" id="{70F2C8BD-1A6A-4A75-AA33-C4FE8DE9E7B5}"/>
               </a:ext>
             </a:extLst>
           </p:cNvPr>
@@ -9470,7 +9470,7 @@
           <p:cNvPr id="13" name="">
             <a:extLst xmlns:a="http://schemas.openxmlformats.org/drawingml/2006/main">
               <a:ext uri="{FF2B5EF4-FFF2-40B4-BE49-F238E27FC236}">
-                <a16:creationId xmlns:a16="http://schemas.microsoft.com/office/drawing/2014/main" id="{07E897D5-EAC2-467F-AC08-EC558607CD08}"/>
+                <a16:creationId xmlns:a16="http://schemas.microsoft.com/office/drawing/2014/main" id="{59C925B8-1FB6-4F4B-A27F-87443A9D15EE}"/>
               </a:ext>
             </a:extLst>
           </p:cNvPr>
@@ -9531,7 +9531,7 @@
           <p:cNvPr id="14" name="">
             <a:extLst xmlns:a="http://schemas.openxmlformats.org/drawingml/2006/main">
               <a:ext uri="{FF2B5EF4-FFF2-40B4-BE49-F238E27FC236}">
-                <a16:creationId xmlns:a16="http://schemas.microsoft.com/office/drawing/2014/main" id="{FFE5466E-4A4F-4D6C-8278-DF2DF0B8B81B}"/>
+                <a16:creationId xmlns:a16="http://schemas.microsoft.com/office/drawing/2014/main" id="{1552F4E2-D237-4C19-BD6C-0B198D106F19}"/>
               </a:ext>
             </a:extLst>
           </p:cNvPr>
@@ -9582,7 +9582,7 @@
                 <a:ea typeface="Helvetica Neue"/>
                 <a:cs typeface="Helvetica Neue"/>
               </a:rPr>
-              <a:t>dividendx.payai.network</a:t>
+              <a:t>divx.payai.network</a:t>
             </a:r>
           </a:p>
         </p:txBody>
@@ -9592,7 +9592,7 @@
           <p:cNvPr id="15" name="">
             <a:extLst xmlns:a="http://schemas.openxmlformats.org/drawingml/2006/main">
               <a:ext uri="{FF2B5EF4-FFF2-40B4-BE49-F238E27FC236}">
-                <a16:creationId xmlns:a16="http://schemas.microsoft.com/office/drawing/2014/main" id="{2940629A-7B12-4A94-B66A-0CDA59181362}"/>
+                <a16:creationId xmlns:a16="http://schemas.microsoft.com/office/drawing/2014/main" id="{E6B0DD01-290D-4CBE-9AA0-FB6B341A14BD}"/>
               </a:ext>
             </a:extLst>
           </p:cNvPr>
@@ -9651,7 +9651,7 @@
     </p:spTree>
     <p:extLst>
       <p:ext uri="{BB962C8B-B14F-4D97-AF65-F5344CB8AC3E}">
-        <p14:creationId xmlns:p14="http://schemas.microsoft.com/office/powerpoint/2010/main" val="182389321"/>
+        <p14:creationId xmlns:p14="http://schemas.microsoft.com/office/powerpoint/2010/main" val="964827560"/>
       </p:ext>
     </p:extLst>
   </p:cSld>

</xml_diff>

<commit_message>
Use divx.payai.network as the canonical public URL (#13)
* Make divx.payai.network the canonical public domain

* Record new-domain production and compatibility acceptance

---------

Co-authored-by: Notorious D.E.V <189247757+notorious-d-e-v@users.noreply.github.com>
</commit_message>
<xml_diff>
--- a/presentation/build/illustrated-v3/finalizer/DivX-illustrated-v3-candidate.pptx
+++ b/presentation/build/illustrated-v3/finalizer/DivX-illustrated-v3-candidate.pptx
@@ -2,21 +2,21 @@
 <file path=ppt/presentation.xml><?xml version="1.0" encoding="utf-8"?>
 <p:presentation xmlns:p="http://schemas.openxmlformats.org/presentationml/2006/main">
   <p:sldMasterIdLst>
-    <p:sldMasterId xmlns:r="http://schemas.openxmlformats.org/officeDocument/2006/relationships" id="2147483648" r:id="Rcba92f13fc4f42e7"/>
+    <p:sldMasterId xmlns:r="http://schemas.openxmlformats.org/officeDocument/2006/relationships" id="2147483648" r:id="Rce5a7016dab0419a"/>
   </p:sldMasterIdLst>
   <p:notesMasterIdLst>
-    <p:notesMasterId xmlns:r="http://schemas.openxmlformats.org/officeDocument/2006/relationships" r:id="Rbe780a52c3e848c5"/>
+    <p:notesMasterId xmlns:r="http://schemas.openxmlformats.org/officeDocument/2006/relationships" r:id="Rd7603cd292064ed8"/>
   </p:notesMasterIdLst>
   <p:sldIdLst>
-    <p:sldId xmlns:r="http://schemas.openxmlformats.org/officeDocument/2006/relationships" id="256" r:id="R82e0cfcf235b4a60"/>
-    <p:sldId xmlns:r="http://schemas.openxmlformats.org/officeDocument/2006/relationships" id="257" r:id="R5251c04de7fe4b4a"/>
-    <p:sldId xmlns:r="http://schemas.openxmlformats.org/officeDocument/2006/relationships" id="258" r:id="Rcdec20e1753746fc"/>
-    <p:sldId xmlns:r="http://schemas.openxmlformats.org/officeDocument/2006/relationships" id="259" r:id="R21e8d371e5fb4948"/>
-    <p:sldId xmlns:r="http://schemas.openxmlformats.org/officeDocument/2006/relationships" id="260" r:id="R3932c6f2c9c64250"/>
-    <p:sldId xmlns:r="http://schemas.openxmlformats.org/officeDocument/2006/relationships" id="261" r:id="R40d4ec8fd34f4cea"/>
-    <p:sldId xmlns:r="http://schemas.openxmlformats.org/officeDocument/2006/relationships" id="262" r:id="R30154cca261641dd"/>
-    <p:sldId xmlns:r="http://schemas.openxmlformats.org/officeDocument/2006/relationships" id="263" r:id="R55190e6033ec45d2"/>
-    <p:sldId xmlns:r="http://schemas.openxmlformats.org/officeDocument/2006/relationships" id="264" r:id="R24b69eb7120f43ea"/>
+    <p:sldId xmlns:r="http://schemas.openxmlformats.org/officeDocument/2006/relationships" id="256" r:id="Rdd5dde7db7d14d97"/>
+    <p:sldId xmlns:r="http://schemas.openxmlformats.org/officeDocument/2006/relationships" id="257" r:id="R9108b5df3f5c4435"/>
+    <p:sldId xmlns:r="http://schemas.openxmlformats.org/officeDocument/2006/relationships" id="258" r:id="R024d3b33159f4069"/>
+    <p:sldId xmlns:r="http://schemas.openxmlformats.org/officeDocument/2006/relationships" id="259" r:id="Rb1b7a284241b4313"/>
+    <p:sldId xmlns:r="http://schemas.openxmlformats.org/officeDocument/2006/relationships" id="260" r:id="Rab242021e155491f"/>
+    <p:sldId xmlns:r="http://schemas.openxmlformats.org/officeDocument/2006/relationships" id="261" r:id="R5a7598864dd94f2d"/>
+    <p:sldId xmlns:r="http://schemas.openxmlformats.org/officeDocument/2006/relationships" id="262" r:id="R8ddcec5423c4451f"/>
+    <p:sldId xmlns:r="http://schemas.openxmlformats.org/officeDocument/2006/relationships" id="263" r:id="R8cbcf6a630d24f17"/>
+    <p:sldId xmlns:r="http://schemas.openxmlformats.org/officeDocument/2006/relationships" id="264" r:id="Raffa7e28f8b1445d"/>
   </p:sldIdLst>
   <p:sldSz cx="12192000" cy="6858000"/>
   <p:notesSz cx="6858000" cy="9144000"/>
@@ -1020,7 +1020,7 @@
           </a:p>
           <a:p xmlns:a="http://schemas.openxmlformats.org/drawingml/2006/main">
             <a:r>
-              <a:t>Sources and evidence: https://dividendx.payai.network/demos/ | https://dividendx.payai.network/app/ | https://solscan.io/account/2EpQ2iKz921Ce2rremdnFrqG15DQq3Y2rSXbgixceDQE?cluster=devnet | planning/mainnet-readiness-2026-09-20.md | planning/guided-lazy-entry-review-2026-09-21.md</a:t>
+              <a:t>Sources and evidence: https://divx.payai.network/demos/ | https://divx.payai.network/app/ | https://solscan.io/account/2EpQ2iKz921Ce2rremdnFrqG15DQq3Y2rSXbgixceDQE?cluster=devnet | planning/mainnet-readiness-2026-09-20.md | planning/guided-lazy-entry-review-2026-09-21.md</a:t>
             </a:r>
           </a:p>
         </p:txBody>
@@ -1090,7 +1090,7 @@
           <a:lstStyle xmlns:a="http://schemas.openxmlformats.org/drawingml/2006/main"/>
           <a:p xmlns:a="http://schemas.openxmlformats.org/drawingml/2006/main">
             <a:r>
-              <a:t>Narration: The annual program, transaction SDK and guided demo are working. Before mainnet, we need complete issuer records, reviewed settlement operations, independent security review and legal and issuer checks. More liquidity, rolling dividend strategies and other networks come later. Try the guided demo at dividendx.payai.network. No wallet or real funds are needed.</a:t>
+              <a:t>Narration: The annual program, transaction SDK and guided demo are working. Before mainnet, we need complete issuer records, reviewed settlement operations, independent security review and legal and issuer checks. More liquidity, rolling dividend strategies and other networks come later. Try the guided demo at divx.payai.network. No wallet or real funds are needed.</a:t>
             </a:r>
           </a:p>
           <a:p xmlns:a="http://schemas.openxmlformats.org/drawingml/2006/main">
@@ -1100,7 +1100,7 @@
           </a:p>
           <a:p xmlns:a="http://schemas.openxmlformats.org/drawingml/2006/main">
             <a:r>
-              <a:t>Sources and evidence: planning/mainnet-readiness-2026-09-20.md | https://dividendx.payai.network/ | https://github.com/notorious-d-e-v/dividendx-stocklana | https://hackathons.solana.com/hackathons/stocklana</a:t>
+              <a:t>Sources and evidence: planning/mainnet-readiness-2026-09-20.md | https://divx.payai.network/ | https://github.com/notorious-d-e-v/dividendx-stocklana | https://hackathons.solana.com/hackathons/stocklana</a:t>
             </a:r>
           </a:p>
         </p:txBody>
@@ -1168,7 +1168,7 @@
   </p:cSld>
   <p:clrMap bg1="lt1" tx1="dk1" bg2="lt2" tx2="dk2" accent1="accent1" accent2="accent2" accent3="accent3" accent4="accent4" accent5="accent5" accent6="accent6" hlink="hlink" folHlink="folHlink"/>
   <p:sldLayoutIdLst>
-    <p:sldLayoutId xmlns:r="http://schemas.openxmlformats.org/officeDocument/2006/relationships" id="2147483649" r:id="Rbb6ca425f4614a07"/>
+    <p:sldLayoutId xmlns:r="http://schemas.openxmlformats.org/officeDocument/2006/relationships" id="2147483649" r:id="R4efe8309c0df45b1"/>
   </p:sldLayoutIdLst>
   <p:txStyles>
     <p:titleStyle>
@@ -1719,7 +1719,7 @@
           <p:cNvPr id="9" name="">
             <a:extLst xmlns:a="http://schemas.openxmlformats.org/drawingml/2006/main">
               <a:ext uri="{FF2B5EF4-FFF2-40B4-BE49-F238E27FC236}">
-                <a16:creationId xmlns:a16="http://schemas.microsoft.com/office/drawing/2014/main" id="{C9A5874A-45A1-4C2D-9D69-E48C0C89B785}"/>
+                <a16:creationId xmlns:a16="http://schemas.microsoft.com/office/drawing/2014/main" id="{6648D554-4D37-4CB0-8541-AE60561033EE}"/>
               </a:ext>
             </a:extLst>
           </p:cNvPr>
@@ -1750,7 +1750,7 @@
           <p:cNvPr id="2" name="">
             <a:extLst xmlns:a="http://schemas.openxmlformats.org/drawingml/2006/main">
               <a:ext uri="{FF2B5EF4-FFF2-40B4-BE49-F238E27FC236}">
-                <a16:creationId xmlns:a16="http://schemas.microsoft.com/office/drawing/2014/main" id="{54BCE8E8-8647-4C5A-8E3C-BF9F587112B5}"/>
+                <a16:creationId xmlns:a16="http://schemas.microsoft.com/office/drawing/2014/main" id="{29B83D4F-4166-4C98-A6ED-95D407B70684}"/>
               </a:ext>
             </a:extLst>
           </p:cNvPr>
@@ -1781,7 +1781,7 @@
           <p:cNvPr id="3" name="">
             <a:extLst xmlns:a="http://schemas.openxmlformats.org/drawingml/2006/main">
               <a:ext uri="{FF2B5EF4-FFF2-40B4-BE49-F238E27FC236}">
-                <a16:creationId xmlns:a16="http://schemas.microsoft.com/office/drawing/2014/main" id="{D53B4178-E501-4384-8A9E-DC88824B67EF}"/>
+                <a16:creationId xmlns:a16="http://schemas.microsoft.com/office/drawing/2014/main" id="{62645D37-C8E6-46E4-ACC8-0F4E22112756}"/>
               </a:ext>
             </a:extLst>
           </p:cNvPr>
@@ -1842,7 +1842,7 @@
           <p:cNvPr id="4" name="">
             <a:extLst xmlns:a="http://schemas.openxmlformats.org/drawingml/2006/main">
               <a:ext uri="{FF2B5EF4-FFF2-40B4-BE49-F238E27FC236}">
-                <a16:creationId xmlns:a16="http://schemas.microsoft.com/office/drawing/2014/main" id="{F9A15AB3-D7C2-4B53-9621-2F789EBB05BD}"/>
+                <a16:creationId xmlns:a16="http://schemas.microsoft.com/office/drawing/2014/main" id="{CCBDEDEC-96D4-49DB-B9B8-C8089B3CE28B}"/>
               </a:ext>
             </a:extLst>
           </p:cNvPr>
@@ -1903,7 +1903,7 @@
           <p:cNvPr id="5" name="">
             <a:extLst xmlns:a="http://schemas.openxmlformats.org/drawingml/2006/main">
               <a:ext uri="{FF2B5EF4-FFF2-40B4-BE49-F238E27FC236}">
-                <a16:creationId xmlns:a16="http://schemas.microsoft.com/office/drawing/2014/main" id="{14832CA6-F348-420B-B4DB-647B4E08A97B}"/>
+                <a16:creationId xmlns:a16="http://schemas.microsoft.com/office/drawing/2014/main" id="{7FC9C1D1-8AE9-4F26-B410-3F77E183DD61}"/>
               </a:ext>
             </a:extLst>
           </p:cNvPr>
@@ -1972,7 +1972,7 @@
           <p:cNvPr id="6" name="">
             <a:extLst xmlns:a="http://schemas.openxmlformats.org/drawingml/2006/main">
               <a:ext uri="{FF2B5EF4-FFF2-40B4-BE49-F238E27FC236}">
-                <a16:creationId xmlns:a16="http://schemas.microsoft.com/office/drawing/2014/main" id="{0D96C9F1-DB96-4D95-9333-A2DC9D6083CF}"/>
+                <a16:creationId xmlns:a16="http://schemas.microsoft.com/office/drawing/2014/main" id="{E28CF3AC-A541-4B00-8428-32D0F0C5F4B7}"/>
               </a:ext>
             </a:extLst>
           </p:cNvPr>
@@ -2033,7 +2033,7 @@
           <p:cNvPr id="7" name="">
             <a:extLst xmlns:a="http://schemas.openxmlformats.org/drawingml/2006/main">
               <a:ext uri="{FF2B5EF4-FFF2-40B4-BE49-F238E27FC236}">
-                <a16:creationId xmlns:a16="http://schemas.microsoft.com/office/drawing/2014/main" id="{0FCFAEE7-28D5-4F72-ADB4-2F777B6A363D}"/>
+                <a16:creationId xmlns:a16="http://schemas.microsoft.com/office/drawing/2014/main" id="{D8EEABA3-6C06-4980-8436-D736D12C2FB1}"/>
               </a:ext>
             </a:extLst>
           </p:cNvPr>
@@ -2064,7 +2064,7 @@
           <p:cNvPr id="8" name="">
             <a:extLst xmlns:a="http://schemas.openxmlformats.org/drawingml/2006/main">
               <a:ext uri="{FF2B5EF4-FFF2-40B4-BE49-F238E27FC236}">
-                <a16:creationId xmlns:a16="http://schemas.microsoft.com/office/drawing/2014/main" id="{A50BE675-0B49-4330-9E18-9645F168411E}"/>
+                <a16:creationId xmlns:a16="http://schemas.microsoft.com/office/drawing/2014/main" id="{6E503A62-F563-4280-B5AF-D8F9FC4F0B59}"/>
               </a:ext>
             </a:extLst>
           </p:cNvPr>
@@ -2123,7 +2123,7 @@
     </p:spTree>
     <p:extLst>
       <p:ext uri="{BB962C8B-B14F-4D97-AF65-F5344CB8AC3E}">
-        <p14:creationId xmlns:p14="http://schemas.microsoft.com/office/powerpoint/2010/main" val="329597336"/>
+        <p14:creationId xmlns:p14="http://schemas.microsoft.com/office/powerpoint/2010/main" val="51863632"/>
       </p:ext>
     </p:extLst>
   </p:cSld>
@@ -2154,7 +2154,7 @@
           <p:cNvPr id="30" name="">
             <a:extLst xmlns:a="http://schemas.openxmlformats.org/drawingml/2006/main">
               <a:ext uri="{FF2B5EF4-FFF2-40B4-BE49-F238E27FC236}">
-                <a16:creationId xmlns:a16="http://schemas.microsoft.com/office/drawing/2014/main" id="{3F1A6A90-9358-4E4D-A428-6C5A4C40F2B9}"/>
+                <a16:creationId xmlns:a16="http://schemas.microsoft.com/office/drawing/2014/main" id="{2C610038-ECC8-446F-BA04-4525F458E1CD}"/>
               </a:ext>
             </a:extLst>
           </p:cNvPr>
@@ -2185,7 +2185,7 @@
           <p:cNvPr id="2" name="">
             <a:extLst xmlns:a="http://schemas.openxmlformats.org/drawingml/2006/main">
               <a:ext uri="{FF2B5EF4-FFF2-40B4-BE49-F238E27FC236}">
-                <a16:creationId xmlns:a16="http://schemas.microsoft.com/office/drawing/2014/main" id="{464AD90D-CDFB-40A1-895A-A28EFE03DD18}"/>
+                <a16:creationId xmlns:a16="http://schemas.microsoft.com/office/drawing/2014/main" id="{F98D2FBB-7627-449C-80C2-67C43FDCFB04}"/>
               </a:ext>
             </a:extLst>
           </p:cNvPr>
@@ -2216,7 +2216,7 @@
           <p:cNvPr id="3" name="">
             <a:extLst xmlns:a="http://schemas.openxmlformats.org/drawingml/2006/main">
               <a:ext uri="{FF2B5EF4-FFF2-40B4-BE49-F238E27FC236}">
-                <a16:creationId xmlns:a16="http://schemas.microsoft.com/office/drawing/2014/main" id="{466242E6-728B-4179-A435-1E6B9AF120AC}"/>
+                <a16:creationId xmlns:a16="http://schemas.microsoft.com/office/drawing/2014/main" id="{574F4BF5-ED60-4DAD-AB11-31CB1DB2E076}"/>
               </a:ext>
             </a:extLst>
           </p:cNvPr>
@@ -2277,7 +2277,7 @@
           <p:cNvPr id="4" name="">
             <a:extLst xmlns:a="http://schemas.openxmlformats.org/drawingml/2006/main">
               <a:ext uri="{FF2B5EF4-FFF2-40B4-BE49-F238E27FC236}">
-                <a16:creationId xmlns:a16="http://schemas.microsoft.com/office/drawing/2014/main" id="{E2512A2A-0D71-4D87-9F27-CA10CAC37502}"/>
+                <a16:creationId xmlns:a16="http://schemas.microsoft.com/office/drawing/2014/main" id="{1428CEE2-8B41-450A-9C12-964581FF1416}"/>
               </a:ext>
             </a:extLst>
           </p:cNvPr>
@@ -2338,7 +2338,7 @@
           <p:cNvPr id="5" name="">
             <a:extLst xmlns:a="http://schemas.openxmlformats.org/drawingml/2006/main">
               <a:ext uri="{FF2B5EF4-FFF2-40B4-BE49-F238E27FC236}">
-                <a16:creationId xmlns:a16="http://schemas.microsoft.com/office/drawing/2014/main" id="{FBA23709-6EA2-4810-B3BB-DB44D20A0E49}"/>
+                <a16:creationId xmlns:a16="http://schemas.microsoft.com/office/drawing/2014/main" id="{383E3009-6236-4C52-976F-CCE6CD67FEAF}"/>
               </a:ext>
             </a:extLst>
           </p:cNvPr>
@@ -2399,7 +2399,7 @@
           <p:cNvPr id="6" name="">
             <a:extLst xmlns:a="http://schemas.openxmlformats.org/drawingml/2006/main">
               <a:ext uri="{FF2B5EF4-FFF2-40B4-BE49-F238E27FC236}">
-                <a16:creationId xmlns:a16="http://schemas.microsoft.com/office/drawing/2014/main" id="{AA863D6A-F336-48E3-8A0F-FD6B899E5FBE}"/>
+                <a16:creationId xmlns:a16="http://schemas.microsoft.com/office/drawing/2014/main" id="{33A13362-4C2C-424A-B95E-F4C2AEBE9D32}"/>
               </a:ext>
             </a:extLst>
           </p:cNvPr>
@@ -2460,7 +2460,7 @@
           <p:cNvPr id="7" name="">
             <a:extLst xmlns:a="http://schemas.openxmlformats.org/drawingml/2006/main">
               <a:ext uri="{FF2B5EF4-FFF2-40B4-BE49-F238E27FC236}">
-                <a16:creationId xmlns:a16="http://schemas.microsoft.com/office/drawing/2014/main" id="{A2116144-FBD7-4152-A536-0BEF758CFC1A}"/>
+                <a16:creationId xmlns:a16="http://schemas.microsoft.com/office/drawing/2014/main" id="{98DAB798-FD7C-4FA0-A1E6-720FE06473E7}"/>
               </a:ext>
             </a:extLst>
           </p:cNvPr>
@@ -2521,7 +2521,7 @@
           <p:cNvPr id="8" name="">
             <a:extLst xmlns:a="http://schemas.openxmlformats.org/drawingml/2006/main">
               <a:ext uri="{FF2B5EF4-FFF2-40B4-BE49-F238E27FC236}">
-                <a16:creationId xmlns:a16="http://schemas.microsoft.com/office/drawing/2014/main" id="{5B17704F-FF74-49F1-AA3F-5EF04AC15FAD}"/>
+                <a16:creationId xmlns:a16="http://schemas.microsoft.com/office/drawing/2014/main" id="{22F0604F-8352-4C3D-BA1C-AA2355ECE960}"/>
               </a:ext>
             </a:extLst>
           </p:cNvPr>
@@ -2582,7 +2582,7 @@
           <p:cNvPr id="9" name="">
             <a:extLst xmlns:a="http://schemas.openxmlformats.org/drawingml/2006/main">
               <a:ext uri="{FF2B5EF4-FFF2-40B4-BE49-F238E27FC236}">
-                <a16:creationId xmlns:a16="http://schemas.microsoft.com/office/drawing/2014/main" id="{AAB44539-9CF7-4EA8-AF8E-561CA10F4E5B}"/>
+                <a16:creationId xmlns:a16="http://schemas.microsoft.com/office/drawing/2014/main" id="{1CA4BCFB-6691-476F-98F7-1FC1C4DB2EE9}"/>
               </a:ext>
             </a:extLst>
           </p:cNvPr>
@@ -2643,7 +2643,7 @@
           <p:cNvPr id="10" name="">
             <a:extLst xmlns:a="http://schemas.openxmlformats.org/drawingml/2006/main">
               <a:ext uri="{FF2B5EF4-FFF2-40B4-BE49-F238E27FC236}">
-                <a16:creationId xmlns:a16="http://schemas.microsoft.com/office/drawing/2014/main" id="{06B9D2DA-2CB3-49B6-B7E5-6A6821239180}"/>
+                <a16:creationId xmlns:a16="http://schemas.microsoft.com/office/drawing/2014/main" id="{D1AFD158-0B6B-4270-8C6B-FC31627DD837}"/>
               </a:ext>
             </a:extLst>
           </p:cNvPr>
@@ -2704,7 +2704,7 @@
           <p:cNvPr id="11" name="">
             <a:extLst xmlns:a="http://schemas.openxmlformats.org/drawingml/2006/main">
               <a:ext uri="{FF2B5EF4-FFF2-40B4-BE49-F238E27FC236}">
-                <a16:creationId xmlns:a16="http://schemas.microsoft.com/office/drawing/2014/main" id="{717904CF-D428-435D-8486-542F9FDF6C74}"/>
+                <a16:creationId xmlns:a16="http://schemas.microsoft.com/office/drawing/2014/main" id="{6E624088-180C-4D6C-AF71-D21D75BF778B}"/>
               </a:ext>
             </a:extLst>
           </p:cNvPr>
@@ -2765,7 +2765,7 @@
           <p:cNvPr id="12" name="">
             <a:extLst xmlns:a="http://schemas.openxmlformats.org/drawingml/2006/main">
               <a:ext uri="{FF2B5EF4-FFF2-40B4-BE49-F238E27FC236}">
-                <a16:creationId xmlns:a16="http://schemas.microsoft.com/office/drawing/2014/main" id="{B485A91C-5F26-4955-B53E-73DB59B8DFB4}"/>
+                <a16:creationId xmlns:a16="http://schemas.microsoft.com/office/drawing/2014/main" id="{C3A851A6-A581-490F-8F9E-455510A2A721}"/>
               </a:ext>
             </a:extLst>
           </p:cNvPr>
@@ -2826,7 +2826,7 @@
           <p:cNvPr id="13" name="">
             <a:extLst xmlns:a="http://schemas.openxmlformats.org/drawingml/2006/main">
               <a:ext uri="{FF2B5EF4-FFF2-40B4-BE49-F238E27FC236}">
-                <a16:creationId xmlns:a16="http://schemas.microsoft.com/office/drawing/2014/main" id="{E6EECDB1-9549-4B13-9222-46FE1038CB0E}"/>
+                <a16:creationId xmlns:a16="http://schemas.microsoft.com/office/drawing/2014/main" id="{77909E8B-348B-48B9-926B-D447183FD7FC}"/>
               </a:ext>
             </a:extLst>
           </p:cNvPr>
@@ -2857,7 +2857,7 @@
           <p:cNvPr id="14" name="">
             <a:extLst xmlns:a="http://schemas.openxmlformats.org/drawingml/2006/main">
               <a:ext uri="{FF2B5EF4-FFF2-40B4-BE49-F238E27FC236}">
-                <a16:creationId xmlns:a16="http://schemas.microsoft.com/office/drawing/2014/main" id="{9D5093B7-4B6D-494C-8C32-B23D74BE0C49}"/>
+                <a16:creationId xmlns:a16="http://schemas.microsoft.com/office/drawing/2014/main" id="{D378AEA0-3CF1-480F-A597-C7DE0D01C41A}"/>
               </a:ext>
             </a:extLst>
           </p:cNvPr>
@@ -2918,7 +2918,7 @@
           <p:cNvPr id="15" name="Stock holder">
             <a:extLst xmlns:a="http://schemas.openxmlformats.org/drawingml/2006/main">
               <a:ext uri="{FF2B5EF4-FFF2-40B4-BE49-F238E27FC236}">
-                <a16:creationId xmlns:a16="http://schemas.microsoft.com/office/drawing/2014/main" id="{472C9A3B-C798-47AF-8C7F-85C5B400F0DB}"/>
+                <a16:creationId xmlns:a16="http://schemas.microsoft.com/office/drawing/2014/main" id="{BB4DD0B6-6CDF-4533-A9AD-AEF3664CC8CF}"/>
               </a:ext>
             </a:extLst>
           </p:cNvPr>
@@ -2953,7 +2953,7 @@
           <p:cNvPr id="16" name="">
             <a:extLst xmlns:a="http://schemas.openxmlformats.org/drawingml/2006/main">
               <a:ext uri="{FF2B5EF4-FFF2-40B4-BE49-F238E27FC236}">
-                <a16:creationId xmlns:a16="http://schemas.microsoft.com/office/drawing/2014/main" id="{DC2276D5-08BB-4E79-9828-EF0185FAA782}"/>
+                <a16:creationId xmlns:a16="http://schemas.microsoft.com/office/drawing/2014/main" id="{238E9234-167F-4E03-A356-698F969195B9}"/>
               </a:ext>
             </a:extLst>
           </p:cNvPr>
@@ -3014,7 +3014,7 @@
           <p:cNvPr id="17" name="Buyer">
             <a:extLst xmlns:a="http://schemas.openxmlformats.org/drawingml/2006/main">
               <a:ext uri="{FF2B5EF4-FFF2-40B4-BE49-F238E27FC236}">
-                <a16:creationId xmlns:a16="http://schemas.microsoft.com/office/drawing/2014/main" id="{41EBF98A-7E5A-42A5-A9DB-ED123594B35A}"/>
+                <a16:creationId xmlns:a16="http://schemas.microsoft.com/office/drawing/2014/main" id="{1341022F-ABFF-4315-BEAE-2B36559B002C}"/>
               </a:ext>
             </a:extLst>
           </p:cNvPr>
@@ -3049,7 +3049,7 @@
           <p:cNvPr id="18" name="">
             <a:extLst xmlns:a="http://schemas.openxmlformats.org/drawingml/2006/main">
               <a:ext uri="{FF2B5EF4-FFF2-40B4-BE49-F238E27FC236}">
-                <a16:creationId xmlns:a16="http://schemas.microsoft.com/office/drawing/2014/main" id="{622E9D22-42F3-458B-A0EC-5492EC843441}"/>
+                <a16:creationId xmlns:a16="http://schemas.microsoft.com/office/drawing/2014/main" id="{C57C2C72-2D21-44DA-84DC-D14F243D10F6}"/>
               </a:ext>
             </a:extLst>
           </p:cNvPr>
@@ -3110,7 +3110,7 @@
           <p:cNvPr id="19" name="Dividend right label">
             <a:extLst xmlns:a="http://schemas.openxmlformats.org/drawingml/2006/main">
               <a:ext uri="{FF2B5EF4-FFF2-40B4-BE49-F238E27FC236}">
-                <a16:creationId xmlns:a16="http://schemas.microsoft.com/office/drawing/2014/main" id="{13456272-9437-4A2A-8F77-F86D7EC6C093}"/>
+                <a16:creationId xmlns:a16="http://schemas.microsoft.com/office/drawing/2014/main" id="{977EDBF9-572E-4AEB-B30C-32D96A10931B}"/>
               </a:ext>
             </a:extLst>
           </p:cNvPr>
@@ -3145,7 +3145,7 @@
           <p:cNvPr id="20" name="">
             <a:extLst xmlns:a="http://schemas.openxmlformats.org/drawingml/2006/main">
               <a:ext uri="{FF2B5EF4-FFF2-40B4-BE49-F238E27FC236}">
-                <a16:creationId xmlns:a16="http://schemas.microsoft.com/office/drawing/2014/main" id="{B45A18A3-6516-4327-8D57-1516085551B2}"/>
+                <a16:creationId xmlns:a16="http://schemas.microsoft.com/office/drawing/2014/main" id="{5AD953EC-9499-4E29-AE89-60484EB9BC3E}"/>
               </a:ext>
             </a:extLst>
           </p:cNvPr>
@@ -3206,7 +3206,7 @@
           <p:cNvPr id="21" name="Payment label">
             <a:extLst xmlns:a="http://schemas.openxmlformats.org/drawingml/2006/main">
               <a:ext uri="{FF2B5EF4-FFF2-40B4-BE49-F238E27FC236}">
-                <a16:creationId xmlns:a16="http://schemas.microsoft.com/office/drawing/2014/main" id="{37D35F31-5259-40DA-A158-1B9147005902}"/>
+                <a16:creationId xmlns:a16="http://schemas.microsoft.com/office/drawing/2014/main" id="{E76470D5-0A79-4802-84ED-05029C840E84}"/>
               </a:ext>
             </a:extLst>
           </p:cNvPr>
@@ -3241,7 +3241,7 @@
           <p:cNvPr id="22" name="">
             <a:extLst xmlns:a="http://schemas.openxmlformats.org/drawingml/2006/main">
               <a:ext uri="{FF2B5EF4-FFF2-40B4-BE49-F238E27FC236}">
-                <a16:creationId xmlns:a16="http://schemas.microsoft.com/office/drawing/2014/main" id="{BD2B7EA3-7473-48E1-B4B7-F82D2C7B3D2C}"/>
+                <a16:creationId xmlns:a16="http://schemas.microsoft.com/office/drawing/2014/main" id="{4D2CB2F9-0D29-4915-AE1A-C5E10D86194F}"/>
               </a:ext>
             </a:extLst>
           </p:cNvPr>
@@ -3404,7 +3404,7 @@
           <p:cNvPr id="27" name="Retained PT">
             <a:extLst xmlns:a="http://schemas.openxmlformats.org/drawingml/2006/main">
               <a:ext uri="{FF2B5EF4-FFF2-40B4-BE49-F238E27FC236}">
-                <a16:creationId xmlns:a16="http://schemas.microsoft.com/office/drawing/2014/main" id="{D32D7D4C-75E1-4D39-AAAA-5E45CC3E5239}"/>
+                <a16:creationId xmlns:a16="http://schemas.microsoft.com/office/drawing/2014/main" id="{B3DD4E21-199B-4E0C-BAEA-885C35129865}"/>
               </a:ext>
             </a:extLst>
           </p:cNvPr>
@@ -3437,7 +3437,7 @@
           <p:cNvPr id="28" name="">
             <a:extLst xmlns:a="http://schemas.openxmlformats.org/drawingml/2006/main">
               <a:ext uri="{FF2B5EF4-FFF2-40B4-BE49-F238E27FC236}">
-                <a16:creationId xmlns:a16="http://schemas.microsoft.com/office/drawing/2014/main" id="{802F0AB2-284E-4E0C-A887-34F131C46C17}"/>
+                <a16:creationId xmlns:a16="http://schemas.microsoft.com/office/drawing/2014/main" id="{977FCF33-E280-46BB-B8E9-B8609573D850}"/>
               </a:ext>
             </a:extLst>
           </p:cNvPr>
@@ -3498,7 +3498,7 @@
           <p:cNvPr id="29" name="">
             <a:extLst xmlns:a="http://schemas.openxmlformats.org/drawingml/2006/main">
               <a:ext uri="{FF2B5EF4-FFF2-40B4-BE49-F238E27FC236}">
-                <a16:creationId xmlns:a16="http://schemas.microsoft.com/office/drawing/2014/main" id="{E6810572-70FF-45D2-AECE-F2BB6ACB63F5}"/>
+                <a16:creationId xmlns:a16="http://schemas.microsoft.com/office/drawing/2014/main" id="{7A0D9763-EB79-4736-9933-DDD28F7F5D1D}"/>
               </a:ext>
             </a:extLst>
           </p:cNvPr>
@@ -3557,7 +3557,7 @@
     </p:spTree>
     <p:extLst>
       <p:ext uri="{BB962C8B-B14F-4D97-AF65-F5344CB8AC3E}">
-        <p14:creationId xmlns:p14="http://schemas.microsoft.com/office/powerpoint/2010/main" val="238684046"/>
+        <p14:creationId xmlns:p14="http://schemas.microsoft.com/office/powerpoint/2010/main" val="965860808"/>
       </p:ext>
     </p:extLst>
   </p:cSld>
@@ -3588,7 +3588,7 @@
           <p:cNvPr id="14" name="">
             <a:extLst xmlns:a="http://schemas.openxmlformats.org/drawingml/2006/main">
               <a:ext uri="{FF2B5EF4-FFF2-40B4-BE49-F238E27FC236}">
-                <a16:creationId xmlns:a16="http://schemas.microsoft.com/office/drawing/2014/main" id="{522F20DB-8C78-48DF-A99B-600A4190690D}"/>
+                <a16:creationId xmlns:a16="http://schemas.microsoft.com/office/drawing/2014/main" id="{2FA69C95-FA0B-4731-BA56-00314D3FD208}"/>
               </a:ext>
             </a:extLst>
           </p:cNvPr>
@@ -3619,7 +3619,7 @@
           <p:cNvPr id="2" name="">
             <a:extLst xmlns:a="http://schemas.openxmlformats.org/drawingml/2006/main">
               <a:ext uri="{FF2B5EF4-FFF2-40B4-BE49-F238E27FC236}">
-                <a16:creationId xmlns:a16="http://schemas.microsoft.com/office/drawing/2014/main" id="{3470A9CC-A2D2-454C-A343-C98716C4B947}"/>
+                <a16:creationId xmlns:a16="http://schemas.microsoft.com/office/drawing/2014/main" id="{A163455D-70DE-4535-86E1-E4CA7320F45D}"/>
               </a:ext>
             </a:extLst>
           </p:cNvPr>
@@ -3650,7 +3650,7 @@
           <p:cNvPr id="3" name="">
             <a:extLst xmlns:a="http://schemas.openxmlformats.org/drawingml/2006/main">
               <a:ext uri="{FF2B5EF4-FFF2-40B4-BE49-F238E27FC236}">
-                <a16:creationId xmlns:a16="http://schemas.microsoft.com/office/drawing/2014/main" id="{06C9272D-5DE7-447B-A1DC-DC49DF3BD923}"/>
+                <a16:creationId xmlns:a16="http://schemas.microsoft.com/office/drawing/2014/main" id="{733B68E9-0D9A-4899-8AEB-269E478F04CC}"/>
               </a:ext>
             </a:extLst>
           </p:cNvPr>
@@ -3711,7 +3711,7 @@
           <p:cNvPr id="4" name="">
             <a:extLst xmlns:a="http://schemas.openxmlformats.org/drawingml/2006/main">
               <a:ext uri="{FF2B5EF4-FFF2-40B4-BE49-F238E27FC236}">
-                <a16:creationId xmlns:a16="http://schemas.microsoft.com/office/drawing/2014/main" id="{5D9442F9-04B1-45B3-904A-A904DC223B1B}"/>
+                <a16:creationId xmlns:a16="http://schemas.microsoft.com/office/drawing/2014/main" id="{E621F4F4-66FD-479C-AB0F-A1A7F598D2A9}"/>
               </a:ext>
             </a:extLst>
           </p:cNvPr>
@@ -3772,7 +3772,7 @@
           <p:cNvPr id="5" name="">
             <a:extLst xmlns:a="http://schemas.openxmlformats.org/drawingml/2006/main">
               <a:ext uri="{FF2B5EF4-FFF2-40B4-BE49-F238E27FC236}">
-                <a16:creationId xmlns:a16="http://schemas.microsoft.com/office/drawing/2014/main" id="{06083990-6523-4590-AA67-9BD80BB071C5}"/>
+                <a16:creationId xmlns:a16="http://schemas.microsoft.com/office/drawing/2014/main" id="{9E6C3C71-F821-4D6F-BC63-42892C6EE175}"/>
               </a:ext>
             </a:extLst>
           </p:cNvPr>
@@ -3837,7 +3837,7 @@
           <p:nvPr/>
         </p:nvPicPr>
         <p:blipFill>
-          <a:blip xmlns:r="http://schemas.openxmlformats.org/officeDocument/2006/relationships" xmlns:a="http://schemas.openxmlformats.org/drawingml/2006/main" r:embed="R699f5096b74d4308"/>
+          <a:blip xmlns:r="http://schemas.openxmlformats.org/officeDocument/2006/relationships" xmlns:a="http://schemas.openxmlformats.org/drawingml/2006/main" r:embed="R3822230d660c4c64"/>
           <a:stretch xmlns:a="http://schemas.openxmlformats.org/drawingml/2006/main"/>
         </p:blipFill>
         <p:spPr>
@@ -3855,7 +3855,7 @@
           <p:cNvPr id="7" name="">
             <a:extLst xmlns:a="http://schemas.openxmlformats.org/drawingml/2006/main">
               <a:ext uri="{FF2B5EF4-FFF2-40B4-BE49-F238E27FC236}">
-                <a16:creationId xmlns:a16="http://schemas.microsoft.com/office/drawing/2014/main" id="{78FA289D-DCD7-4C45-B4F0-3BCA0909987D}"/>
+                <a16:creationId xmlns:a16="http://schemas.microsoft.com/office/drawing/2014/main" id="{B1175A14-4EF9-4BBB-96DB-9AD23428A09E}"/>
               </a:ext>
             </a:extLst>
           </p:cNvPr>
@@ -3916,7 +3916,7 @@
           <p:cNvPr id="8" name="">
             <a:extLst xmlns:a="http://schemas.openxmlformats.org/drawingml/2006/main">
               <a:ext uri="{FF2B5EF4-FFF2-40B4-BE49-F238E27FC236}">
-                <a16:creationId xmlns:a16="http://schemas.microsoft.com/office/drawing/2014/main" id="{65F7A6F5-3B0F-48D5-B0C4-6DE8F5D03B26}"/>
+                <a16:creationId xmlns:a16="http://schemas.microsoft.com/office/drawing/2014/main" id="{50828CEA-F7E9-4E14-BBFC-BBFC17385A84}"/>
               </a:ext>
             </a:extLst>
           </p:cNvPr>
@@ -3977,7 +3977,7 @@
           <p:cNvPr id="9" name="">
             <a:extLst xmlns:a="http://schemas.openxmlformats.org/drawingml/2006/main">
               <a:ext uri="{FF2B5EF4-FFF2-40B4-BE49-F238E27FC236}">
-                <a16:creationId xmlns:a16="http://schemas.microsoft.com/office/drawing/2014/main" id="{AFD4AD06-5636-49BB-975C-FA385E271F66}"/>
+                <a16:creationId xmlns:a16="http://schemas.microsoft.com/office/drawing/2014/main" id="{8ED2EB29-D3EE-4EBE-8908-1EA1639E7B7E}"/>
               </a:ext>
             </a:extLst>
           </p:cNvPr>
@@ -4038,7 +4038,7 @@
           <p:cNvPr id="10" name="">
             <a:extLst xmlns:a="http://schemas.openxmlformats.org/drawingml/2006/main">
               <a:ext uri="{FF2B5EF4-FFF2-40B4-BE49-F238E27FC236}">
-                <a16:creationId xmlns:a16="http://schemas.microsoft.com/office/drawing/2014/main" id="{EB289021-61B6-40D7-A958-B47FEBBB796C}"/>
+                <a16:creationId xmlns:a16="http://schemas.microsoft.com/office/drawing/2014/main" id="{4F79757C-97E1-4C9F-9F13-208375B1DD21}"/>
               </a:ext>
             </a:extLst>
           </p:cNvPr>
@@ -4099,7 +4099,7 @@
           <p:cNvPr id="11" name="">
             <a:extLst xmlns:a="http://schemas.openxmlformats.org/drawingml/2006/main">
               <a:ext uri="{FF2B5EF4-FFF2-40B4-BE49-F238E27FC236}">
-                <a16:creationId xmlns:a16="http://schemas.microsoft.com/office/drawing/2014/main" id="{34EFB03B-1FD9-4ED0-839F-40C9FCDD7A0B}"/>
+                <a16:creationId xmlns:a16="http://schemas.microsoft.com/office/drawing/2014/main" id="{164C1F0E-6968-4F01-8CF5-FAAC1136AEE4}"/>
               </a:ext>
             </a:extLst>
           </p:cNvPr>
@@ -4160,7 +4160,7 @@
           <p:cNvPr id="12" name="">
             <a:extLst xmlns:a="http://schemas.openxmlformats.org/drawingml/2006/main">
               <a:ext uri="{FF2B5EF4-FFF2-40B4-BE49-F238E27FC236}">
-                <a16:creationId xmlns:a16="http://schemas.microsoft.com/office/drawing/2014/main" id="{C58FFBFB-5463-40EE-8466-22A84EF67DAF}"/>
+                <a16:creationId xmlns:a16="http://schemas.microsoft.com/office/drawing/2014/main" id="{D9E70828-E33B-408D-BD85-AB79712A9A7B}"/>
               </a:ext>
             </a:extLst>
           </p:cNvPr>
@@ -4221,7 +4221,7 @@
           <p:cNvPr id="13" name="">
             <a:extLst xmlns:a="http://schemas.openxmlformats.org/drawingml/2006/main">
               <a:ext uri="{FF2B5EF4-FFF2-40B4-BE49-F238E27FC236}">
-                <a16:creationId xmlns:a16="http://schemas.microsoft.com/office/drawing/2014/main" id="{4F6A98D2-4D69-4A01-BEE6-6B3F8146AF8D}"/>
+                <a16:creationId xmlns:a16="http://schemas.microsoft.com/office/drawing/2014/main" id="{8217BA7B-AEA2-4EA0-9AEF-43A206CCA469}"/>
               </a:ext>
             </a:extLst>
           </p:cNvPr>
@@ -4307,7 +4307,7 @@
     </p:spTree>
     <p:extLst>
       <p:ext uri="{BB962C8B-B14F-4D97-AF65-F5344CB8AC3E}">
-        <p14:creationId xmlns:p14="http://schemas.microsoft.com/office/powerpoint/2010/main" val="767881056"/>
+        <p14:creationId xmlns:p14="http://schemas.microsoft.com/office/powerpoint/2010/main" val="1308839144"/>
       </p:ext>
     </p:extLst>
   </p:cSld>
@@ -4338,7 +4338,7 @@
           <p:cNvPr id="14" name="">
             <a:extLst xmlns:a="http://schemas.openxmlformats.org/drawingml/2006/main">
               <a:ext uri="{FF2B5EF4-FFF2-40B4-BE49-F238E27FC236}">
-                <a16:creationId xmlns:a16="http://schemas.microsoft.com/office/drawing/2014/main" id="{04D5DBFD-CB1C-4085-9228-3880E3143EA5}"/>
+                <a16:creationId xmlns:a16="http://schemas.microsoft.com/office/drawing/2014/main" id="{AEC33539-81B5-42D0-84D0-B8638B0CC087}"/>
               </a:ext>
             </a:extLst>
           </p:cNvPr>
@@ -4369,7 +4369,7 @@
           <p:cNvPr id="2" name="">
             <a:extLst xmlns:a="http://schemas.openxmlformats.org/drawingml/2006/main">
               <a:ext uri="{FF2B5EF4-FFF2-40B4-BE49-F238E27FC236}">
-                <a16:creationId xmlns:a16="http://schemas.microsoft.com/office/drawing/2014/main" id="{E89C0EBC-B297-4209-9EFF-023555D35113}"/>
+                <a16:creationId xmlns:a16="http://schemas.microsoft.com/office/drawing/2014/main" id="{CC7E7525-4251-49AF-B5CE-88CF49FFC5D7}"/>
               </a:ext>
             </a:extLst>
           </p:cNvPr>
@@ -4400,7 +4400,7 @@
           <p:cNvPr id="3" name="">
             <a:extLst xmlns:a="http://schemas.openxmlformats.org/drawingml/2006/main">
               <a:ext uri="{FF2B5EF4-FFF2-40B4-BE49-F238E27FC236}">
-                <a16:creationId xmlns:a16="http://schemas.microsoft.com/office/drawing/2014/main" id="{4FB506FB-51EC-4D42-AE73-D9B8C198BE81}"/>
+                <a16:creationId xmlns:a16="http://schemas.microsoft.com/office/drawing/2014/main" id="{A8F2CDB7-16B3-42C9-982C-E5100C13EDAA}"/>
               </a:ext>
             </a:extLst>
           </p:cNvPr>
@@ -4461,7 +4461,7 @@
           <p:cNvPr id="4" name="">
             <a:extLst xmlns:a="http://schemas.openxmlformats.org/drawingml/2006/main">
               <a:ext uri="{FF2B5EF4-FFF2-40B4-BE49-F238E27FC236}">
-                <a16:creationId xmlns:a16="http://schemas.microsoft.com/office/drawing/2014/main" id="{2A22F161-62D5-40E9-863D-4021BCA0DACE}"/>
+                <a16:creationId xmlns:a16="http://schemas.microsoft.com/office/drawing/2014/main" id="{A44EB30A-2109-4843-866F-0ACD1512B9B2}"/>
               </a:ext>
             </a:extLst>
           </p:cNvPr>
@@ -4522,7 +4522,7 @@
           <p:cNvPr id="5" name="">
             <a:extLst xmlns:a="http://schemas.openxmlformats.org/drawingml/2006/main">
               <a:ext uri="{FF2B5EF4-FFF2-40B4-BE49-F238E27FC236}">
-                <a16:creationId xmlns:a16="http://schemas.microsoft.com/office/drawing/2014/main" id="{EC02CB1B-4FF6-46BA-96E8-11852E79FCB1}"/>
+                <a16:creationId xmlns:a16="http://schemas.microsoft.com/office/drawing/2014/main" id="{5A9E2569-0070-4B08-BFBC-A443D5128C1A}"/>
               </a:ext>
             </a:extLst>
           </p:cNvPr>
@@ -4583,7 +4583,7 @@
           <p:cNvPr id="6" name="">
             <a:extLst xmlns:a="http://schemas.openxmlformats.org/drawingml/2006/main">
               <a:ext uri="{FF2B5EF4-FFF2-40B4-BE49-F238E27FC236}">
-                <a16:creationId xmlns:a16="http://schemas.microsoft.com/office/drawing/2014/main" id="{B4EBADC7-32F7-4E99-A195-B07530989BC3}"/>
+                <a16:creationId xmlns:a16="http://schemas.microsoft.com/office/drawing/2014/main" id="{78814024-ADA8-4A63-8EFC-A9F392982A53}"/>
               </a:ext>
             </a:extLst>
           </p:cNvPr>
@@ -4644,7 +4644,7 @@
           <p:cNvPr id="7" name="">
             <a:extLst xmlns:a="http://schemas.openxmlformats.org/drawingml/2006/main">
               <a:ext uri="{FF2B5EF4-FFF2-40B4-BE49-F238E27FC236}">
-                <a16:creationId xmlns:a16="http://schemas.microsoft.com/office/drawing/2014/main" id="{4A539514-EE1D-4BBC-AD02-51866406A9CB}"/>
+                <a16:creationId xmlns:a16="http://schemas.microsoft.com/office/drawing/2014/main" id="{76343216-694D-4E39-A049-6394766D0503}"/>
               </a:ext>
             </a:extLst>
           </p:cNvPr>
@@ -4705,7 +4705,7 @@
           <p:cNvPr id="8" name="">
             <a:extLst xmlns:a="http://schemas.openxmlformats.org/drawingml/2006/main">
               <a:ext uri="{FF2B5EF4-FFF2-40B4-BE49-F238E27FC236}">
-                <a16:creationId xmlns:a16="http://schemas.microsoft.com/office/drawing/2014/main" id="{CA475113-4EFC-4CA0-B89C-2D715FD6B332}"/>
+                <a16:creationId xmlns:a16="http://schemas.microsoft.com/office/drawing/2014/main" id="{014B2D21-D2A7-4EBE-8B39-B0D2817618AB}"/>
               </a:ext>
             </a:extLst>
           </p:cNvPr>
@@ -4766,7 +4766,7 @@
           <p:cNvPr id="9" name="">
             <a:extLst xmlns:a="http://schemas.openxmlformats.org/drawingml/2006/main">
               <a:ext uri="{FF2B5EF4-FFF2-40B4-BE49-F238E27FC236}">
-                <a16:creationId xmlns:a16="http://schemas.microsoft.com/office/drawing/2014/main" id="{3206335B-E0B4-4D4F-AF29-20D72838928D}"/>
+                <a16:creationId xmlns:a16="http://schemas.microsoft.com/office/drawing/2014/main" id="{BDD07DB9-62AE-4A70-8287-18B1D729B348}"/>
               </a:ext>
             </a:extLst>
           </p:cNvPr>
@@ -4797,7 +4797,7 @@
           <p:cNvPr id="10" name="">
             <a:extLst xmlns:a="http://schemas.openxmlformats.org/drawingml/2006/main">
               <a:ext uri="{FF2B5EF4-FFF2-40B4-BE49-F238E27FC236}">
-                <a16:creationId xmlns:a16="http://schemas.microsoft.com/office/drawing/2014/main" id="{1A420BAF-36B8-4BFE-8592-40CCF77F2C97}"/>
+                <a16:creationId xmlns:a16="http://schemas.microsoft.com/office/drawing/2014/main" id="{13656865-C361-470D-B2D2-5C5D2EDEA312}"/>
               </a:ext>
             </a:extLst>
           </p:cNvPr>
@@ -4858,7 +4858,7 @@
           <p:cNvPr id="11" name="">
             <a:extLst xmlns:a="http://schemas.openxmlformats.org/drawingml/2006/main">
               <a:ext uri="{FF2B5EF4-FFF2-40B4-BE49-F238E27FC236}">
-                <a16:creationId xmlns:a16="http://schemas.microsoft.com/office/drawing/2014/main" id="{07E6FFF6-B355-46ED-8E21-81EC505A7689}"/>
+                <a16:creationId xmlns:a16="http://schemas.microsoft.com/office/drawing/2014/main" id="{86CDD280-A4AC-4402-A3EF-264E02550056}"/>
               </a:ext>
             </a:extLst>
           </p:cNvPr>
@@ -4919,7 +4919,7 @@
           <p:cNvPr id="12" name="">
             <a:extLst xmlns:a="http://schemas.openxmlformats.org/drawingml/2006/main">
               <a:ext uri="{FF2B5EF4-FFF2-40B4-BE49-F238E27FC236}">
-                <a16:creationId xmlns:a16="http://schemas.microsoft.com/office/drawing/2014/main" id="{2A99CB3F-623E-4266-8E0B-5D964577C18F}"/>
+                <a16:creationId xmlns:a16="http://schemas.microsoft.com/office/drawing/2014/main" id="{BD083552-C4CA-4498-93B5-9CA4ABFC5D6B}"/>
               </a:ext>
             </a:extLst>
           </p:cNvPr>
@@ -4980,7 +4980,7 @@
           <p:cNvPr id="13" name="">
             <a:extLst xmlns:a="http://schemas.openxmlformats.org/drawingml/2006/main">
               <a:ext uri="{FF2B5EF4-FFF2-40B4-BE49-F238E27FC236}">
-                <a16:creationId xmlns:a16="http://schemas.microsoft.com/office/drawing/2014/main" id="{76B73C72-D69C-47D2-807B-93C428C15011}"/>
+                <a16:creationId xmlns:a16="http://schemas.microsoft.com/office/drawing/2014/main" id="{FF08C9AD-7FA3-4FE6-90F3-0707FED6EE2D}"/>
               </a:ext>
             </a:extLst>
           </p:cNvPr>
@@ -5047,7 +5047,7 @@
     </p:spTree>
     <p:extLst>
       <p:ext uri="{BB962C8B-B14F-4D97-AF65-F5344CB8AC3E}">
-        <p14:creationId xmlns:p14="http://schemas.microsoft.com/office/powerpoint/2010/main" val="489601405"/>
+        <p14:creationId xmlns:p14="http://schemas.microsoft.com/office/powerpoint/2010/main" val="228003059"/>
       </p:ext>
     </p:extLst>
   </p:cSld>
@@ -5078,7 +5078,7 @@
           <p:cNvPr id="22" name="">
             <a:extLst xmlns:a="http://schemas.openxmlformats.org/drawingml/2006/main">
               <a:ext uri="{FF2B5EF4-FFF2-40B4-BE49-F238E27FC236}">
-                <a16:creationId xmlns:a16="http://schemas.microsoft.com/office/drawing/2014/main" id="{041EC4CF-77F3-499E-AA22-0A210C726587}"/>
+                <a16:creationId xmlns:a16="http://schemas.microsoft.com/office/drawing/2014/main" id="{9F65B8BD-E89D-4867-BCA6-AECF6301ABAC}"/>
               </a:ext>
             </a:extLst>
           </p:cNvPr>
@@ -5109,7 +5109,7 @@
           <p:cNvPr id="2" name="">
             <a:extLst xmlns:a="http://schemas.openxmlformats.org/drawingml/2006/main">
               <a:ext uri="{FF2B5EF4-FFF2-40B4-BE49-F238E27FC236}">
-                <a16:creationId xmlns:a16="http://schemas.microsoft.com/office/drawing/2014/main" id="{8EA4C5CC-BB39-4694-A96F-A84EF98C8C64}"/>
+                <a16:creationId xmlns:a16="http://schemas.microsoft.com/office/drawing/2014/main" id="{23F4B903-6C11-4115-816D-C837D7717013}"/>
               </a:ext>
             </a:extLst>
           </p:cNvPr>
@@ -5140,7 +5140,7 @@
           <p:cNvPr id="3" name="">
             <a:extLst xmlns:a="http://schemas.openxmlformats.org/drawingml/2006/main">
               <a:ext uri="{FF2B5EF4-FFF2-40B4-BE49-F238E27FC236}">
-                <a16:creationId xmlns:a16="http://schemas.microsoft.com/office/drawing/2014/main" id="{223A4617-8F31-4FF7-82F0-E77B0FD1410F}"/>
+                <a16:creationId xmlns:a16="http://schemas.microsoft.com/office/drawing/2014/main" id="{13D9A069-D1FE-45B9-A738-49D4231C26D4}"/>
               </a:ext>
             </a:extLst>
           </p:cNvPr>
@@ -5201,7 +5201,7 @@
           <p:cNvPr id="4" name="">
             <a:extLst xmlns:a="http://schemas.openxmlformats.org/drawingml/2006/main">
               <a:ext uri="{FF2B5EF4-FFF2-40B4-BE49-F238E27FC236}">
-                <a16:creationId xmlns:a16="http://schemas.microsoft.com/office/drawing/2014/main" id="{616E5107-4742-4B4E-AEEA-72D3996405D0}"/>
+                <a16:creationId xmlns:a16="http://schemas.microsoft.com/office/drawing/2014/main" id="{3866F237-0512-485E-B16E-4B0AF5B6F37F}"/>
               </a:ext>
             </a:extLst>
           </p:cNvPr>
@@ -5262,7 +5262,7 @@
           <p:cNvPr id="5" name="">
             <a:extLst xmlns:a="http://schemas.openxmlformats.org/drawingml/2006/main">
               <a:ext uri="{FF2B5EF4-FFF2-40B4-BE49-F238E27FC236}">
-                <a16:creationId xmlns:a16="http://schemas.microsoft.com/office/drawing/2014/main" id="{8D60CB66-75B7-4D4E-A8E3-29BB3B22ECB4}"/>
+                <a16:creationId xmlns:a16="http://schemas.microsoft.com/office/drawing/2014/main" id="{600B5CEE-D2E0-4DED-A69B-C41B60A03DDE}"/>
               </a:ext>
             </a:extLst>
           </p:cNvPr>
@@ -5323,7 +5323,7 @@
           <p:cNvPr id="6" name="">
             <a:extLst xmlns:a="http://schemas.openxmlformats.org/drawingml/2006/main">
               <a:ext uri="{FF2B5EF4-FFF2-40B4-BE49-F238E27FC236}">
-                <a16:creationId xmlns:a16="http://schemas.microsoft.com/office/drawing/2014/main" id="{74E1C7C1-7C6F-419E-99B4-D904144450ED}"/>
+                <a16:creationId xmlns:a16="http://schemas.microsoft.com/office/drawing/2014/main" id="{72D4A476-767F-4390-92B7-F3FA5A41E62F}"/>
               </a:ext>
             </a:extLst>
           </p:cNvPr>
@@ -5384,7 +5384,7 @@
           <p:cNvPr id="7" name="">
             <a:extLst xmlns:a="http://schemas.openxmlformats.org/drawingml/2006/main">
               <a:ext uri="{FF2B5EF4-FFF2-40B4-BE49-F238E27FC236}">
-                <a16:creationId xmlns:a16="http://schemas.microsoft.com/office/drawing/2014/main" id="{B91F4776-7066-4DD8-B184-5FA5B36B9DF1}"/>
+                <a16:creationId xmlns:a16="http://schemas.microsoft.com/office/drawing/2014/main" id="{2FB4690D-1D68-46AF-A9C1-DD022E1B686F}"/>
               </a:ext>
             </a:extLst>
           </p:cNvPr>
@@ -5445,7 +5445,7 @@
           <p:cNvPr id="8" name="">
             <a:extLst xmlns:a="http://schemas.openxmlformats.org/drawingml/2006/main">
               <a:ext uri="{FF2B5EF4-FFF2-40B4-BE49-F238E27FC236}">
-                <a16:creationId xmlns:a16="http://schemas.microsoft.com/office/drawing/2014/main" id="{A45DF65B-CB40-4C64-A82E-C30BAACB12BF}"/>
+                <a16:creationId xmlns:a16="http://schemas.microsoft.com/office/drawing/2014/main" id="{E0D73E20-3E37-482E-8F4A-6BA0219C95A0}"/>
               </a:ext>
             </a:extLst>
           </p:cNvPr>
@@ -5506,7 +5506,7 @@
           <p:cNvPr id="9" name="">
             <a:extLst xmlns:a="http://schemas.openxmlformats.org/drawingml/2006/main">
               <a:ext uri="{FF2B5EF4-FFF2-40B4-BE49-F238E27FC236}">
-                <a16:creationId xmlns:a16="http://schemas.microsoft.com/office/drawing/2014/main" id="{8428022F-B461-4B8C-A073-AD5C134B973B}"/>
+                <a16:creationId xmlns:a16="http://schemas.microsoft.com/office/drawing/2014/main" id="{A229BD87-093D-4331-BF43-88E31AA2B429}"/>
               </a:ext>
             </a:extLst>
           </p:cNvPr>
@@ -5537,7 +5537,7 @@
           <p:cNvPr id="10" name="">
             <a:extLst xmlns:a="http://schemas.openxmlformats.org/drawingml/2006/main">
               <a:ext uri="{FF2B5EF4-FFF2-40B4-BE49-F238E27FC236}">
-                <a16:creationId xmlns:a16="http://schemas.microsoft.com/office/drawing/2014/main" id="{2AFFA52B-DA6B-4F71-B3DA-21B743BE1873}"/>
+                <a16:creationId xmlns:a16="http://schemas.microsoft.com/office/drawing/2014/main" id="{82CB04C6-C192-4067-A53D-BFD60752C371}"/>
               </a:ext>
             </a:extLst>
           </p:cNvPr>
@@ -5598,7 +5598,7 @@
           <p:cNvPr id="11" name="">
             <a:extLst xmlns:a="http://schemas.openxmlformats.org/drawingml/2006/main">
               <a:ext uri="{FF2B5EF4-FFF2-40B4-BE49-F238E27FC236}">
-                <a16:creationId xmlns:a16="http://schemas.microsoft.com/office/drawing/2014/main" id="{A2F52DE6-0C86-4E9A-A16B-4BAE45F8A29C}"/>
+                <a16:creationId xmlns:a16="http://schemas.microsoft.com/office/drawing/2014/main" id="{C29DAC3D-E540-4BAB-99DA-90069DE7C738}"/>
               </a:ext>
             </a:extLst>
           </p:cNvPr>
@@ -5659,7 +5659,7 @@
           <p:cNvPr id="12" name="">
             <a:extLst xmlns:a="http://schemas.openxmlformats.org/drawingml/2006/main">
               <a:ext uri="{FF2B5EF4-FFF2-40B4-BE49-F238E27FC236}">
-                <a16:creationId xmlns:a16="http://schemas.microsoft.com/office/drawing/2014/main" id="{79CBDEA9-E6D6-4ACA-BC55-F42FA0CA352F}"/>
+                <a16:creationId xmlns:a16="http://schemas.microsoft.com/office/drawing/2014/main" id="{699E5670-96F1-4AC9-AEB6-FB2B0E099497}"/>
               </a:ext>
             </a:extLst>
           </p:cNvPr>
@@ -5690,7 +5690,7 @@
           <p:cNvPr id="13" name="">
             <a:extLst xmlns:a="http://schemas.openxmlformats.org/drawingml/2006/main">
               <a:ext uri="{FF2B5EF4-FFF2-40B4-BE49-F238E27FC236}">
-                <a16:creationId xmlns:a16="http://schemas.microsoft.com/office/drawing/2014/main" id="{917C4B04-C5A3-453E-A06A-E37FDC6CCE65}"/>
+                <a16:creationId xmlns:a16="http://schemas.microsoft.com/office/drawing/2014/main" id="{9A66A4C3-CBF4-4660-A312-5B13D60D7D16}"/>
               </a:ext>
             </a:extLst>
           </p:cNvPr>
@@ -5751,7 +5751,7 @@
           <p:cNvPr id="14" name="">
             <a:extLst xmlns:a="http://schemas.openxmlformats.org/drawingml/2006/main">
               <a:ext uri="{FF2B5EF4-FFF2-40B4-BE49-F238E27FC236}">
-                <a16:creationId xmlns:a16="http://schemas.microsoft.com/office/drawing/2014/main" id="{435A8FA7-B436-4364-93A1-8CDAD355AE17}"/>
+                <a16:creationId xmlns:a16="http://schemas.microsoft.com/office/drawing/2014/main" id="{C82D9D7D-0AEF-4AC6-934C-6FB38A4ABA05}"/>
               </a:ext>
             </a:extLst>
           </p:cNvPr>
@@ -5812,7 +5812,7 @@
           <p:cNvPr id="15" name="">
             <a:extLst xmlns:a="http://schemas.openxmlformats.org/drawingml/2006/main">
               <a:ext uri="{FF2B5EF4-FFF2-40B4-BE49-F238E27FC236}">
-                <a16:creationId xmlns:a16="http://schemas.microsoft.com/office/drawing/2014/main" id="{696F1CB8-B9DC-4523-8FED-51E8EEA6CAC2}"/>
+                <a16:creationId xmlns:a16="http://schemas.microsoft.com/office/drawing/2014/main" id="{156592F2-8E68-4E5C-9118-5067606CFA8A}"/>
               </a:ext>
             </a:extLst>
           </p:cNvPr>
@@ -5843,7 +5843,7 @@
           <p:cNvPr id="16" name="">
             <a:extLst xmlns:a="http://schemas.openxmlformats.org/drawingml/2006/main">
               <a:ext uri="{FF2B5EF4-FFF2-40B4-BE49-F238E27FC236}">
-                <a16:creationId xmlns:a16="http://schemas.microsoft.com/office/drawing/2014/main" id="{9B15B5E1-CBC9-4435-B605-3E45E6084A5B}"/>
+                <a16:creationId xmlns:a16="http://schemas.microsoft.com/office/drawing/2014/main" id="{A422F3AD-FBCE-4426-9E19-524B28D3A692}"/>
               </a:ext>
             </a:extLst>
           </p:cNvPr>
@@ -5904,7 +5904,7 @@
           <p:cNvPr id="17" name="">
             <a:extLst xmlns:a="http://schemas.openxmlformats.org/drawingml/2006/main">
               <a:ext uri="{FF2B5EF4-FFF2-40B4-BE49-F238E27FC236}">
-                <a16:creationId xmlns:a16="http://schemas.microsoft.com/office/drawing/2014/main" id="{E885CEA4-9849-4761-8F4E-63CCB938EA30}"/>
+                <a16:creationId xmlns:a16="http://schemas.microsoft.com/office/drawing/2014/main" id="{4F23A775-337D-4AD3-A194-3EE1DA21C982}"/>
               </a:ext>
             </a:extLst>
           </p:cNvPr>
@@ -5965,7 +5965,7 @@
           <p:cNvPr id="18" name="">
             <a:extLst xmlns:a="http://schemas.openxmlformats.org/drawingml/2006/main">
               <a:ext uri="{FF2B5EF4-FFF2-40B4-BE49-F238E27FC236}">
-                <a16:creationId xmlns:a16="http://schemas.microsoft.com/office/drawing/2014/main" id="{592C2396-7DF2-46B5-86FE-5604A7933BE9}"/>
+                <a16:creationId xmlns:a16="http://schemas.microsoft.com/office/drawing/2014/main" id="{39DDFDF5-9B0C-40D6-8267-1565A282126B}"/>
               </a:ext>
             </a:extLst>
           </p:cNvPr>
@@ -5996,7 +5996,7 @@
           <p:cNvPr id="19" name="">
             <a:extLst xmlns:a="http://schemas.openxmlformats.org/drawingml/2006/main">
               <a:ext uri="{FF2B5EF4-FFF2-40B4-BE49-F238E27FC236}">
-                <a16:creationId xmlns:a16="http://schemas.microsoft.com/office/drawing/2014/main" id="{0932D3C7-2DDA-4668-ACFD-79A001509B83}"/>
+                <a16:creationId xmlns:a16="http://schemas.microsoft.com/office/drawing/2014/main" id="{2FC179CA-23F0-4AD7-AD7A-4E52FFBDA69F}"/>
               </a:ext>
             </a:extLst>
           </p:cNvPr>
@@ -6057,7 +6057,7 @@
           <p:cNvPr id="20" name="">
             <a:extLst xmlns:a="http://schemas.openxmlformats.org/drawingml/2006/main">
               <a:ext uri="{FF2B5EF4-FFF2-40B4-BE49-F238E27FC236}">
-                <a16:creationId xmlns:a16="http://schemas.microsoft.com/office/drawing/2014/main" id="{7B8BD266-225B-4186-A416-D3E79B76ED4E}"/>
+                <a16:creationId xmlns:a16="http://schemas.microsoft.com/office/drawing/2014/main" id="{9D910161-3AD0-4B23-9C25-A60C50DA86A0}"/>
               </a:ext>
             </a:extLst>
           </p:cNvPr>
@@ -6118,7 +6118,7 @@
           <p:cNvPr id="21" name="">
             <a:extLst xmlns:a="http://schemas.openxmlformats.org/drawingml/2006/main">
               <a:ext uri="{FF2B5EF4-FFF2-40B4-BE49-F238E27FC236}">
-                <a16:creationId xmlns:a16="http://schemas.microsoft.com/office/drawing/2014/main" id="{69A4AD73-4A28-4D7C-814C-4F2E188ED479}"/>
+                <a16:creationId xmlns:a16="http://schemas.microsoft.com/office/drawing/2014/main" id="{25B2CB95-A8D7-41B5-B218-DAE6B9864429}"/>
               </a:ext>
             </a:extLst>
           </p:cNvPr>
@@ -6177,7 +6177,7 @@
     </p:spTree>
     <p:extLst>
       <p:ext uri="{BB962C8B-B14F-4D97-AF65-F5344CB8AC3E}">
-        <p14:creationId xmlns:p14="http://schemas.microsoft.com/office/powerpoint/2010/main" val="289023299"/>
+        <p14:creationId xmlns:p14="http://schemas.microsoft.com/office/powerpoint/2010/main" val="1979531115"/>
       </p:ext>
     </p:extLst>
   </p:cSld>
@@ -6208,7 +6208,7 @@
           <p:cNvPr id="13" name="">
             <a:extLst xmlns:a="http://schemas.openxmlformats.org/drawingml/2006/main">
               <a:ext uri="{FF2B5EF4-FFF2-40B4-BE49-F238E27FC236}">
-                <a16:creationId xmlns:a16="http://schemas.microsoft.com/office/drawing/2014/main" id="{F724CC4D-BAA9-49C3-A451-AF7E207BE396}"/>
+                <a16:creationId xmlns:a16="http://schemas.microsoft.com/office/drawing/2014/main" id="{43E07749-EAAA-4A77-A512-FFADE559EF81}"/>
               </a:ext>
             </a:extLst>
           </p:cNvPr>
@@ -6239,7 +6239,7 @@
           <p:cNvPr id="2" name="">
             <a:extLst xmlns:a="http://schemas.openxmlformats.org/drawingml/2006/main">
               <a:ext uri="{FF2B5EF4-FFF2-40B4-BE49-F238E27FC236}">
-                <a16:creationId xmlns:a16="http://schemas.microsoft.com/office/drawing/2014/main" id="{8B0923BA-8B28-40C2-B781-949C4662E5AA}"/>
+                <a16:creationId xmlns:a16="http://schemas.microsoft.com/office/drawing/2014/main" id="{8A2C69E5-B4E5-46F0-822C-835197E7634C}"/>
               </a:ext>
             </a:extLst>
           </p:cNvPr>
@@ -6270,7 +6270,7 @@
           <p:cNvPr id="3" name="">
             <a:extLst xmlns:a="http://schemas.openxmlformats.org/drawingml/2006/main">
               <a:ext uri="{FF2B5EF4-FFF2-40B4-BE49-F238E27FC236}">
-                <a16:creationId xmlns:a16="http://schemas.microsoft.com/office/drawing/2014/main" id="{2D670367-018E-4C0D-BCF1-4953B5D41A68}"/>
+                <a16:creationId xmlns:a16="http://schemas.microsoft.com/office/drawing/2014/main" id="{54DD63C6-D531-4E85-9C1C-EB5750C14B41}"/>
               </a:ext>
             </a:extLst>
           </p:cNvPr>
@@ -6331,7 +6331,7 @@
           <p:cNvPr id="4" name="">
             <a:extLst xmlns:a="http://schemas.openxmlformats.org/drawingml/2006/main">
               <a:ext uri="{FF2B5EF4-FFF2-40B4-BE49-F238E27FC236}">
-                <a16:creationId xmlns:a16="http://schemas.microsoft.com/office/drawing/2014/main" id="{84241B67-6164-4F1F-B9D9-FEF21E5A97AC}"/>
+                <a16:creationId xmlns:a16="http://schemas.microsoft.com/office/drawing/2014/main" id="{4638030E-C30A-4A2F-8BCE-3F49E2DB77A7}"/>
               </a:ext>
             </a:extLst>
           </p:cNvPr>
@@ -6392,7 +6392,7 @@
           <p:cNvPr id="5" name="">
             <a:extLst xmlns:a="http://schemas.openxmlformats.org/drawingml/2006/main">
               <a:ext uri="{FF2B5EF4-FFF2-40B4-BE49-F238E27FC236}">
-                <a16:creationId xmlns:a16="http://schemas.microsoft.com/office/drawing/2014/main" id="{31B27648-71C2-4F78-A09D-E73E1C12C942}"/>
+                <a16:creationId xmlns:a16="http://schemas.microsoft.com/office/drawing/2014/main" id="{E2488411-7159-4D82-B5F7-F28DD53D76D4}"/>
               </a:ext>
             </a:extLst>
           </p:cNvPr>
@@ -6453,7 +6453,7 @@
           <p:cNvPr id="6" name="">
             <a:extLst xmlns:a="http://schemas.openxmlformats.org/drawingml/2006/main">
               <a:ext uri="{FF2B5EF4-FFF2-40B4-BE49-F238E27FC236}">
-                <a16:creationId xmlns:a16="http://schemas.microsoft.com/office/drawing/2014/main" id="{F3EE193A-11D1-43B0-9C2B-7B9811BD8B4D}"/>
+                <a16:creationId xmlns:a16="http://schemas.microsoft.com/office/drawing/2014/main" id="{09F866E1-C1A1-4ACF-943B-9CF6292DBDA2}"/>
               </a:ext>
             </a:extLst>
           </p:cNvPr>
@@ -6514,7 +6514,7 @@
           <p:cNvPr id="7" name="">
             <a:extLst xmlns:a="http://schemas.openxmlformats.org/drawingml/2006/main">
               <a:ext uri="{FF2B5EF4-FFF2-40B4-BE49-F238E27FC236}">
-                <a16:creationId xmlns:a16="http://schemas.microsoft.com/office/drawing/2014/main" id="{ECEE499B-BED5-4ABD-9FDF-31BFADC3B098}"/>
+                <a16:creationId xmlns:a16="http://schemas.microsoft.com/office/drawing/2014/main" id="{1F4385B3-8B8F-4F51-8F75-727FA7BA1B4C}"/>
               </a:ext>
             </a:extLst>
           </p:cNvPr>
@@ -6575,7 +6575,7 @@
           <p:cNvPr id="8" name="">
             <a:extLst xmlns:a="http://schemas.openxmlformats.org/drawingml/2006/main">
               <a:ext uri="{FF2B5EF4-FFF2-40B4-BE49-F238E27FC236}">
-                <a16:creationId xmlns:a16="http://schemas.microsoft.com/office/drawing/2014/main" id="{7F565146-4129-4B37-9975-EB0CC9924BC1}"/>
+                <a16:creationId xmlns:a16="http://schemas.microsoft.com/office/drawing/2014/main" id="{935B3170-15AD-44A9-A322-CC45FB1BF515}"/>
               </a:ext>
             </a:extLst>
           </p:cNvPr>
@@ -6640,7 +6640,7 @@
           <p:nvPr/>
         </p:nvPicPr>
         <p:blipFill>
-          <a:blip xmlns:r="http://schemas.openxmlformats.org/officeDocument/2006/relationships" xmlns:a="http://schemas.openxmlformats.org/drawingml/2006/main" r:embed="Rc3566186fa1e4530"/>
+          <a:blip xmlns:r="http://schemas.openxmlformats.org/officeDocument/2006/relationships" xmlns:a="http://schemas.openxmlformats.org/drawingml/2006/main" r:embed="Rd9504d619fae4ca6"/>
           <a:stretch xmlns:a="http://schemas.openxmlformats.org/drawingml/2006/main"/>
         </p:blipFill>
         <p:spPr>
@@ -6658,7 +6658,7 @@
           <p:cNvPr id="10" name="">
             <a:extLst xmlns:a="http://schemas.openxmlformats.org/drawingml/2006/main">
               <a:ext uri="{FF2B5EF4-FFF2-40B4-BE49-F238E27FC236}">
-                <a16:creationId xmlns:a16="http://schemas.microsoft.com/office/drawing/2014/main" id="{20297507-EF60-4F96-AC60-EF83BE76C143}"/>
+                <a16:creationId xmlns:a16="http://schemas.microsoft.com/office/drawing/2014/main" id="{E4DD66F7-2C7F-4B23-AF73-83A91187BEE1}"/>
               </a:ext>
             </a:extLst>
           </p:cNvPr>
@@ -6719,7 +6719,7 @@
           <p:cNvPr id="11" name="">
             <a:extLst xmlns:a="http://schemas.openxmlformats.org/drawingml/2006/main">
               <a:ext uri="{FF2B5EF4-FFF2-40B4-BE49-F238E27FC236}">
-                <a16:creationId xmlns:a16="http://schemas.microsoft.com/office/drawing/2014/main" id="{D51DD200-B4CB-4C2F-A357-9B18215AD0A3}"/>
+                <a16:creationId xmlns:a16="http://schemas.microsoft.com/office/drawing/2014/main" id="{650B537C-0C04-4332-89FE-60DDB6858A51}"/>
               </a:ext>
             </a:extLst>
           </p:cNvPr>
@@ -6780,7 +6780,7 @@
           <p:cNvPr id="12" name="">
             <a:extLst xmlns:a="http://schemas.openxmlformats.org/drawingml/2006/main">
               <a:ext uri="{FF2B5EF4-FFF2-40B4-BE49-F238E27FC236}">
-                <a16:creationId xmlns:a16="http://schemas.microsoft.com/office/drawing/2014/main" id="{45F69085-47F1-4E37-A89C-F5DE4E187064}"/>
+                <a16:creationId xmlns:a16="http://schemas.microsoft.com/office/drawing/2014/main" id="{341767FF-884E-4847-92A7-1A0C852D05F8}"/>
               </a:ext>
             </a:extLst>
           </p:cNvPr>
@@ -6839,7 +6839,7 @@
     </p:spTree>
     <p:extLst>
       <p:ext uri="{BB962C8B-B14F-4D97-AF65-F5344CB8AC3E}">
-        <p14:creationId xmlns:p14="http://schemas.microsoft.com/office/powerpoint/2010/main" val="1704851922"/>
+        <p14:creationId xmlns:p14="http://schemas.microsoft.com/office/powerpoint/2010/main" val="420682946"/>
       </p:ext>
     </p:extLst>
   </p:cSld>
@@ -6870,7 +6870,7 @@
           <p:cNvPr id="21" name="">
             <a:extLst xmlns:a="http://schemas.openxmlformats.org/drawingml/2006/main">
               <a:ext uri="{FF2B5EF4-FFF2-40B4-BE49-F238E27FC236}">
-                <a16:creationId xmlns:a16="http://schemas.microsoft.com/office/drawing/2014/main" id="{6ECD65BB-2E5C-4E67-8F8D-88B5A129AFA6}"/>
+                <a16:creationId xmlns:a16="http://schemas.microsoft.com/office/drawing/2014/main" id="{14A0EE5A-F05A-459F-8532-EF988517B363}"/>
               </a:ext>
             </a:extLst>
           </p:cNvPr>
@@ -6901,7 +6901,7 @@
           <p:cNvPr id="2" name="">
             <a:extLst xmlns:a="http://schemas.openxmlformats.org/drawingml/2006/main">
               <a:ext uri="{FF2B5EF4-FFF2-40B4-BE49-F238E27FC236}">
-                <a16:creationId xmlns:a16="http://schemas.microsoft.com/office/drawing/2014/main" id="{0C40B5B4-A36C-4273-A5ED-6F9492A004E3}"/>
+                <a16:creationId xmlns:a16="http://schemas.microsoft.com/office/drawing/2014/main" id="{B66EB0C6-898A-48EC-A889-1D74EC719D5E}"/>
               </a:ext>
             </a:extLst>
           </p:cNvPr>
@@ -6932,7 +6932,7 @@
           <p:cNvPr id="3" name="">
             <a:extLst xmlns:a="http://schemas.openxmlformats.org/drawingml/2006/main">
               <a:ext uri="{FF2B5EF4-FFF2-40B4-BE49-F238E27FC236}">
-                <a16:creationId xmlns:a16="http://schemas.microsoft.com/office/drawing/2014/main" id="{B5D26D01-C0D3-4772-A092-47135DA98DFF}"/>
+                <a16:creationId xmlns:a16="http://schemas.microsoft.com/office/drawing/2014/main" id="{0FC9A7C1-EFC5-4477-8740-966AB0EF4F23}"/>
               </a:ext>
             </a:extLst>
           </p:cNvPr>
@@ -6993,7 +6993,7 @@
           <p:cNvPr id="4" name="">
             <a:extLst xmlns:a="http://schemas.openxmlformats.org/drawingml/2006/main">
               <a:ext uri="{FF2B5EF4-FFF2-40B4-BE49-F238E27FC236}">
-                <a16:creationId xmlns:a16="http://schemas.microsoft.com/office/drawing/2014/main" id="{EAC3B4D9-0786-4E7D-B71F-2A5F6F521411}"/>
+                <a16:creationId xmlns:a16="http://schemas.microsoft.com/office/drawing/2014/main" id="{C8B4B588-3D23-427E-835F-1929C78124B7}"/>
               </a:ext>
             </a:extLst>
           </p:cNvPr>
@@ -7054,7 +7054,7 @@
           <p:cNvPr id="5" name="">
             <a:extLst xmlns:a="http://schemas.openxmlformats.org/drawingml/2006/main">
               <a:ext uri="{FF2B5EF4-FFF2-40B4-BE49-F238E27FC236}">
-                <a16:creationId xmlns:a16="http://schemas.microsoft.com/office/drawing/2014/main" id="{C9508E1E-8CD6-43B0-A863-7320B0E5C0B7}"/>
+                <a16:creationId xmlns:a16="http://schemas.microsoft.com/office/drawing/2014/main" id="{B1879E7C-885F-4A26-9C38-78A8034C97EA}"/>
               </a:ext>
             </a:extLst>
           </p:cNvPr>
@@ -7115,7 +7115,7 @@
           <p:cNvPr id="6" name="">
             <a:extLst xmlns:a="http://schemas.openxmlformats.org/drawingml/2006/main">
               <a:ext uri="{FF2B5EF4-FFF2-40B4-BE49-F238E27FC236}">
-                <a16:creationId xmlns:a16="http://schemas.microsoft.com/office/drawing/2014/main" id="{B5C691F5-297E-4A81-8316-D11F0B828461}"/>
+                <a16:creationId xmlns:a16="http://schemas.microsoft.com/office/drawing/2014/main" id="{F2378623-B7F5-4052-978F-906E7A43F996}"/>
               </a:ext>
             </a:extLst>
           </p:cNvPr>
@@ -7176,7 +7176,7 @@
           <p:cNvPr id="7" name="">
             <a:extLst xmlns:a="http://schemas.openxmlformats.org/drawingml/2006/main">
               <a:ext uri="{FF2B5EF4-FFF2-40B4-BE49-F238E27FC236}">
-                <a16:creationId xmlns:a16="http://schemas.microsoft.com/office/drawing/2014/main" id="{1A63D338-B750-4E7F-AF61-489663E21CD9}"/>
+                <a16:creationId xmlns:a16="http://schemas.microsoft.com/office/drawing/2014/main" id="{170719A4-7156-48EC-A645-6AE58848EB7D}"/>
               </a:ext>
             </a:extLst>
           </p:cNvPr>
@@ -7237,7 +7237,7 @@
           <p:cNvPr id="8" name="">
             <a:extLst xmlns:a="http://schemas.openxmlformats.org/drawingml/2006/main">
               <a:ext uri="{FF2B5EF4-FFF2-40B4-BE49-F238E27FC236}">
-                <a16:creationId xmlns:a16="http://schemas.microsoft.com/office/drawing/2014/main" id="{E080A8B7-1A94-4B3D-B7A8-55029D2031A8}"/>
+                <a16:creationId xmlns:a16="http://schemas.microsoft.com/office/drawing/2014/main" id="{4CD6C9B8-056E-451B-AE6E-D4AAD348E365}"/>
               </a:ext>
             </a:extLst>
           </p:cNvPr>
@@ -7298,7 +7298,7 @@
           <p:cNvPr id="9" name="">
             <a:extLst xmlns:a="http://schemas.openxmlformats.org/drawingml/2006/main">
               <a:ext uri="{FF2B5EF4-FFF2-40B4-BE49-F238E27FC236}">
-                <a16:creationId xmlns:a16="http://schemas.microsoft.com/office/drawing/2014/main" id="{01BE321D-6A01-463B-931D-792E00543103}"/>
+                <a16:creationId xmlns:a16="http://schemas.microsoft.com/office/drawing/2014/main" id="{3162BD11-A50C-4273-8CE3-8EA59EA4E4FB}"/>
               </a:ext>
             </a:extLst>
           </p:cNvPr>
@@ -7329,7 +7329,7 @@
           <p:cNvPr id="10" name="">
             <a:extLst xmlns:a="http://schemas.openxmlformats.org/drawingml/2006/main">
               <a:ext uri="{FF2B5EF4-FFF2-40B4-BE49-F238E27FC236}">
-                <a16:creationId xmlns:a16="http://schemas.microsoft.com/office/drawing/2014/main" id="{AB878863-2388-4751-9189-A26037EAD2F5}"/>
+                <a16:creationId xmlns:a16="http://schemas.microsoft.com/office/drawing/2014/main" id="{48020FE3-2FE6-4967-881E-FBF3BCED213B}"/>
               </a:ext>
             </a:extLst>
           </p:cNvPr>
@@ -7390,7 +7390,7 @@
           <p:cNvPr id="11" name="">
             <a:extLst xmlns:a="http://schemas.openxmlformats.org/drawingml/2006/main">
               <a:ext uri="{FF2B5EF4-FFF2-40B4-BE49-F238E27FC236}">
-                <a16:creationId xmlns:a16="http://schemas.microsoft.com/office/drawing/2014/main" id="{F618785A-176D-470D-890E-93C7B3C10041}"/>
+                <a16:creationId xmlns:a16="http://schemas.microsoft.com/office/drawing/2014/main" id="{E8DAE95F-686A-4D20-8677-C27AC0AB98D1}"/>
               </a:ext>
             </a:extLst>
           </p:cNvPr>
@@ -7451,7 +7451,7 @@
           <p:cNvPr id="12" name="">
             <a:extLst xmlns:a="http://schemas.openxmlformats.org/drawingml/2006/main">
               <a:ext uri="{FF2B5EF4-FFF2-40B4-BE49-F238E27FC236}">
-                <a16:creationId xmlns:a16="http://schemas.microsoft.com/office/drawing/2014/main" id="{557D7F65-45F8-4F78-9FCD-7451FDE26725}"/>
+                <a16:creationId xmlns:a16="http://schemas.microsoft.com/office/drawing/2014/main" id="{09AE8190-217B-4CB2-912D-58A239B9BE22}"/>
               </a:ext>
             </a:extLst>
           </p:cNvPr>
@@ -7482,7 +7482,7 @@
           <p:cNvPr id="13" name="">
             <a:extLst xmlns:a="http://schemas.openxmlformats.org/drawingml/2006/main">
               <a:ext uri="{FF2B5EF4-FFF2-40B4-BE49-F238E27FC236}">
-                <a16:creationId xmlns:a16="http://schemas.microsoft.com/office/drawing/2014/main" id="{9A8BB805-830B-439F-B98D-675F746E8767}"/>
+                <a16:creationId xmlns:a16="http://schemas.microsoft.com/office/drawing/2014/main" id="{680C1C8F-0E17-4040-9D6C-7B874376AEFE}"/>
               </a:ext>
             </a:extLst>
           </p:cNvPr>
@@ -7543,7 +7543,7 @@
           <p:cNvPr id="14" name="">
             <a:extLst xmlns:a="http://schemas.openxmlformats.org/drawingml/2006/main">
               <a:ext uri="{FF2B5EF4-FFF2-40B4-BE49-F238E27FC236}">
-                <a16:creationId xmlns:a16="http://schemas.microsoft.com/office/drawing/2014/main" id="{CDA4575B-2004-4E79-A8CD-C907BF9D3BA3}"/>
+                <a16:creationId xmlns:a16="http://schemas.microsoft.com/office/drawing/2014/main" id="{81CF10B5-ED77-4E15-9EEB-3E31A48E2EAF}"/>
               </a:ext>
             </a:extLst>
           </p:cNvPr>
@@ -7604,7 +7604,7 @@
           <p:cNvPr id="15" name="">
             <a:extLst xmlns:a="http://schemas.openxmlformats.org/drawingml/2006/main">
               <a:ext uri="{FF2B5EF4-FFF2-40B4-BE49-F238E27FC236}">
-                <a16:creationId xmlns:a16="http://schemas.microsoft.com/office/drawing/2014/main" id="{273508B5-685E-45DF-9BC8-11F7667138EB}"/>
+                <a16:creationId xmlns:a16="http://schemas.microsoft.com/office/drawing/2014/main" id="{D1E23F5F-6D0B-4514-8AFE-287BDD34DE85}"/>
               </a:ext>
             </a:extLst>
           </p:cNvPr>
@@ -7635,7 +7635,7 @@
           <p:cNvPr id="16" name="">
             <a:extLst xmlns:a="http://schemas.openxmlformats.org/drawingml/2006/main">
               <a:ext uri="{FF2B5EF4-FFF2-40B4-BE49-F238E27FC236}">
-                <a16:creationId xmlns:a16="http://schemas.microsoft.com/office/drawing/2014/main" id="{CD3F8393-DB8F-4610-A82A-3B4D98037C38}"/>
+                <a16:creationId xmlns:a16="http://schemas.microsoft.com/office/drawing/2014/main" id="{A135E9C7-73A1-4C6D-878E-0D11F9B5D593}"/>
               </a:ext>
             </a:extLst>
           </p:cNvPr>
@@ -7696,7 +7696,7 @@
           <p:cNvPr id="17" name="">
             <a:extLst xmlns:a="http://schemas.openxmlformats.org/drawingml/2006/main">
               <a:ext uri="{FF2B5EF4-FFF2-40B4-BE49-F238E27FC236}">
-                <a16:creationId xmlns:a16="http://schemas.microsoft.com/office/drawing/2014/main" id="{FD7263DF-49B6-46F0-A9A1-4A5AE675EB0E}"/>
+                <a16:creationId xmlns:a16="http://schemas.microsoft.com/office/drawing/2014/main" id="{EDD67867-F181-4EDE-B0FC-A61235DD3AB3}"/>
               </a:ext>
             </a:extLst>
           </p:cNvPr>
@@ -7757,7 +7757,7 @@
           <p:cNvPr id="18" name="">
             <a:extLst xmlns:a="http://schemas.openxmlformats.org/drawingml/2006/main">
               <a:ext uri="{FF2B5EF4-FFF2-40B4-BE49-F238E27FC236}">
-                <a16:creationId xmlns:a16="http://schemas.microsoft.com/office/drawing/2014/main" id="{D2B14BE2-CA9A-4C8B-80DD-82E96C5F5F69}"/>
+                <a16:creationId xmlns:a16="http://schemas.microsoft.com/office/drawing/2014/main" id="{59F83F8D-483A-488E-95F2-6612B1A92350}"/>
               </a:ext>
             </a:extLst>
           </p:cNvPr>
@@ -7788,7 +7788,7 @@
           <p:cNvPr id="19" name="">
             <a:extLst xmlns:a="http://schemas.openxmlformats.org/drawingml/2006/main">
               <a:ext uri="{FF2B5EF4-FFF2-40B4-BE49-F238E27FC236}">
-                <a16:creationId xmlns:a16="http://schemas.microsoft.com/office/drawing/2014/main" id="{22BE5686-C786-4C61-97B4-D8523AA286BC}"/>
+                <a16:creationId xmlns:a16="http://schemas.microsoft.com/office/drawing/2014/main" id="{8BEA964E-410F-458C-8543-CFB65AAF07EB}"/>
               </a:ext>
             </a:extLst>
           </p:cNvPr>
@@ -7849,7 +7849,7 @@
           <p:cNvPr id="20" name="">
             <a:extLst xmlns:a="http://schemas.openxmlformats.org/drawingml/2006/main">
               <a:ext uri="{FF2B5EF4-FFF2-40B4-BE49-F238E27FC236}">
-                <a16:creationId xmlns:a16="http://schemas.microsoft.com/office/drawing/2014/main" id="{ABF2A6DB-A78A-4CD4-B141-DEFAC86CE842}"/>
+                <a16:creationId xmlns:a16="http://schemas.microsoft.com/office/drawing/2014/main" id="{54D1E27A-F778-496B-82F4-FE94ED1B129E}"/>
               </a:ext>
             </a:extLst>
           </p:cNvPr>
@@ -7908,7 +7908,7 @@
     </p:spTree>
     <p:extLst>
       <p:ext uri="{BB962C8B-B14F-4D97-AF65-F5344CB8AC3E}">
-        <p14:creationId xmlns:p14="http://schemas.microsoft.com/office/powerpoint/2010/main" val="664848293"/>
+        <p14:creationId xmlns:p14="http://schemas.microsoft.com/office/powerpoint/2010/main" val="1204431957"/>
       </p:ext>
     </p:extLst>
   </p:cSld>
@@ -7939,7 +7939,7 @@
           <p:cNvPr id="15" name="">
             <a:extLst xmlns:a="http://schemas.openxmlformats.org/drawingml/2006/main">
               <a:ext uri="{FF2B5EF4-FFF2-40B4-BE49-F238E27FC236}">
-                <a16:creationId xmlns:a16="http://schemas.microsoft.com/office/drawing/2014/main" id="{5125E158-9433-4DE1-BC69-35E55B04CE1C}"/>
+                <a16:creationId xmlns:a16="http://schemas.microsoft.com/office/drawing/2014/main" id="{299AD2F1-B3BD-4858-A06E-C3E44E541BE9}"/>
               </a:ext>
             </a:extLst>
           </p:cNvPr>
@@ -7970,7 +7970,7 @@
           <p:cNvPr id="2" name="">
             <a:extLst xmlns:a="http://schemas.openxmlformats.org/drawingml/2006/main">
               <a:ext uri="{FF2B5EF4-FFF2-40B4-BE49-F238E27FC236}">
-                <a16:creationId xmlns:a16="http://schemas.microsoft.com/office/drawing/2014/main" id="{FCFE303C-3514-4FF0-84A8-519C09FCDC58}"/>
+                <a16:creationId xmlns:a16="http://schemas.microsoft.com/office/drawing/2014/main" id="{9BB487C5-E00B-41BB-B176-B034F5416A3D}"/>
               </a:ext>
             </a:extLst>
           </p:cNvPr>
@@ -8001,7 +8001,7 @@
           <p:cNvPr id="3" name="">
             <a:extLst xmlns:a="http://schemas.openxmlformats.org/drawingml/2006/main">
               <a:ext uri="{FF2B5EF4-FFF2-40B4-BE49-F238E27FC236}">
-                <a16:creationId xmlns:a16="http://schemas.microsoft.com/office/drawing/2014/main" id="{2E18B9D0-F3FF-4FEE-8DA1-91273E01F2B9}"/>
+                <a16:creationId xmlns:a16="http://schemas.microsoft.com/office/drawing/2014/main" id="{68942C3C-3ACF-4898-B7C6-33B53425FFA1}"/>
               </a:ext>
             </a:extLst>
           </p:cNvPr>
@@ -8062,7 +8062,7 @@
           <p:cNvPr id="4" name="">
             <a:extLst xmlns:a="http://schemas.openxmlformats.org/drawingml/2006/main">
               <a:ext uri="{FF2B5EF4-FFF2-40B4-BE49-F238E27FC236}">
-                <a16:creationId xmlns:a16="http://schemas.microsoft.com/office/drawing/2014/main" id="{1A9E603C-A8A7-4728-A2B3-DC304CEA86EF}"/>
+                <a16:creationId xmlns:a16="http://schemas.microsoft.com/office/drawing/2014/main" id="{69EEBC91-DE3E-41BF-82E1-DA7A8C4E9C25}"/>
               </a:ext>
             </a:extLst>
           </p:cNvPr>
@@ -8123,7 +8123,7 @@
           <p:cNvPr id="5" name="">
             <a:extLst xmlns:a="http://schemas.openxmlformats.org/drawingml/2006/main">
               <a:ext uri="{FF2B5EF4-FFF2-40B4-BE49-F238E27FC236}">
-                <a16:creationId xmlns:a16="http://schemas.microsoft.com/office/drawing/2014/main" id="{55CA4416-82AA-4719-B592-6EC86C515B69}"/>
+                <a16:creationId xmlns:a16="http://schemas.microsoft.com/office/drawing/2014/main" id="{CE81C59F-D324-421E-AD5C-25DE2FB987DF}"/>
               </a:ext>
             </a:extLst>
           </p:cNvPr>
@@ -8188,7 +8188,7 @@
           <p:nvPr/>
         </p:nvPicPr>
         <p:blipFill>
-          <a:blip xmlns:r="http://schemas.openxmlformats.org/officeDocument/2006/relationships" xmlns:a="http://schemas.openxmlformats.org/drawingml/2006/main" r:embed="R5367d719136f4789"/>
+          <a:blip xmlns:r="http://schemas.openxmlformats.org/officeDocument/2006/relationships" xmlns:a="http://schemas.openxmlformats.org/drawingml/2006/main" r:embed="R3b51eb5c69984651"/>
           <a:stretch xmlns:a="http://schemas.openxmlformats.org/drawingml/2006/main"/>
         </p:blipFill>
         <p:spPr>
@@ -8206,7 +8206,7 @@
           <p:cNvPr id="7" name="">
             <a:extLst xmlns:a="http://schemas.openxmlformats.org/drawingml/2006/main">
               <a:ext uri="{FF2B5EF4-FFF2-40B4-BE49-F238E27FC236}">
-                <a16:creationId xmlns:a16="http://schemas.microsoft.com/office/drawing/2014/main" id="{ECFCC9B9-BA1E-4B62-ADD5-3FA690717334}"/>
+                <a16:creationId xmlns:a16="http://schemas.microsoft.com/office/drawing/2014/main" id="{A141716E-9959-4E75-A6E5-68D104F18930}"/>
               </a:ext>
             </a:extLst>
           </p:cNvPr>
@@ -8267,7 +8267,7 @@
           <p:cNvPr id="8" name="">
             <a:extLst xmlns:a="http://schemas.openxmlformats.org/drawingml/2006/main">
               <a:ext uri="{FF2B5EF4-FFF2-40B4-BE49-F238E27FC236}">
-                <a16:creationId xmlns:a16="http://schemas.microsoft.com/office/drawing/2014/main" id="{FEEF33AF-2A8B-4C44-929F-2B5D0F199E26}"/>
+                <a16:creationId xmlns:a16="http://schemas.microsoft.com/office/drawing/2014/main" id="{62ED4054-B1AD-4336-B250-0073C69A5F15}"/>
               </a:ext>
             </a:extLst>
           </p:cNvPr>
@@ -8328,7 +8328,7 @@
           <p:cNvPr id="9" name="">
             <a:extLst xmlns:a="http://schemas.openxmlformats.org/drawingml/2006/main">
               <a:ext uri="{FF2B5EF4-FFF2-40B4-BE49-F238E27FC236}">
-                <a16:creationId xmlns:a16="http://schemas.microsoft.com/office/drawing/2014/main" id="{D3E5C4EE-53B3-4142-A848-ECBBA726852C}"/>
+                <a16:creationId xmlns:a16="http://schemas.microsoft.com/office/drawing/2014/main" id="{7225D032-EB91-4BD1-9908-877DE802C532}"/>
               </a:ext>
             </a:extLst>
           </p:cNvPr>
@@ -8389,7 +8389,7 @@
           <p:cNvPr id="10" name="">
             <a:extLst xmlns:a="http://schemas.openxmlformats.org/drawingml/2006/main">
               <a:ext uri="{FF2B5EF4-FFF2-40B4-BE49-F238E27FC236}">
-                <a16:creationId xmlns:a16="http://schemas.microsoft.com/office/drawing/2014/main" id="{63CEACC5-FB54-4F2E-B2C5-9BF2FC12B13A}"/>
+                <a16:creationId xmlns:a16="http://schemas.microsoft.com/office/drawing/2014/main" id="{3F788298-1535-483A-B712-CC907505DE13}"/>
               </a:ext>
             </a:extLst>
           </p:cNvPr>
@@ -8450,7 +8450,7 @@
           <p:cNvPr id="11" name="">
             <a:extLst xmlns:a="http://schemas.openxmlformats.org/drawingml/2006/main">
               <a:ext uri="{FF2B5EF4-FFF2-40B4-BE49-F238E27FC236}">
-                <a16:creationId xmlns:a16="http://schemas.microsoft.com/office/drawing/2014/main" id="{1598D49D-AAF5-4219-B74B-D098EEBBBF3D}"/>
+                <a16:creationId xmlns:a16="http://schemas.microsoft.com/office/drawing/2014/main" id="{474A3BF7-4C24-4116-A7A8-FCFDEFA9BB1E}"/>
               </a:ext>
             </a:extLst>
           </p:cNvPr>
@@ -8511,7 +8511,7 @@
           <p:cNvPr id="12" name="">
             <a:extLst xmlns:a="http://schemas.openxmlformats.org/drawingml/2006/main">
               <a:ext uri="{FF2B5EF4-FFF2-40B4-BE49-F238E27FC236}">
-                <a16:creationId xmlns:a16="http://schemas.microsoft.com/office/drawing/2014/main" id="{9D35F8FD-62F2-4A0F-985E-35EFC948F735}"/>
+                <a16:creationId xmlns:a16="http://schemas.microsoft.com/office/drawing/2014/main" id="{A63E160D-8F66-4B02-BDAC-2735C4542A6E}"/>
               </a:ext>
             </a:extLst>
           </p:cNvPr>
@@ -8572,7 +8572,7 @@
           <p:cNvPr id="13" name="">
             <a:extLst xmlns:a="http://schemas.openxmlformats.org/drawingml/2006/main">
               <a:ext uri="{FF2B5EF4-FFF2-40B4-BE49-F238E27FC236}">
-                <a16:creationId xmlns:a16="http://schemas.microsoft.com/office/drawing/2014/main" id="{51AA0972-9B7B-43EC-AC62-00E9C3C400BA}"/>
+                <a16:creationId xmlns:a16="http://schemas.microsoft.com/office/drawing/2014/main" id="{9CACFCF5-73B2-48F0-9DF0-1E8AA825AFB4}"/>
               </a:ext>
             </a:extLst>
           </p:cNvPr>
@@ -8660,7 +8660,7 @@
           <p:cNvPr id="14" name="">
             <a:extLst xmlns:a="http://schemas.openxmlformats.org/drawingml/2006/main">
               <a:ext uri="{FF2B5EF4-FFF2-40B4-BE49-F238E27FC236}">
-                <a16:creationId xmlns:a16="http://schemas.microsoft.com/office/drawing/2014/main" id="{9A40CB8B-09F0-4D08-8C88-5FBC49E422CE}"/>
+                <a16:creationId xmlns:a16="http://schemas.microsoft.com/office/drawing/2014/main" id="{61445DF5-A2B0-42E0-9F48-34B3389BBB8C}"/>
               </a:ext>
             </a:extLst>
           </p:cNvPr>
@@ -8719,7 +8719,7 @@
     </p:spTree>
     <p:extLst>
       <p:ext uri="{BB962C8B-B14F-4D97-AF65-F5344CB8AC3E}">
-        <p14:creationId xmlns:p14="http://schemas.microsoft.com/office/powerpoint/2010/main" val="161250711"/>
+        <p14:creationId xmlns:p14="http://schemas.microsoft.com/office/powerpoint/2010/main" val="704744169"/>
       </p:ext>
     </p:extLst>
   </p:cSld>
@@ -8750,7 +8750,7 @@
           <p:cNvPr id="16" name="">
             <a:extLst xmlns:a="http://schemas.openxmlformats.org/drawingml/2006/main">
               <a:ext uri="{FF2B5EF4-FFF2-40B4-BE49-F238E27FC236}">
-                <a16:creationId xmlns:a16="http://schemas.microsoft.com/office/drawing/2014/main" id="{EBAC8066-EBE7-4BAD-AFE6-2B3D5655BF4E}"/>
+                <a16:creationId xmlns:a16="http://schemas.microsoft.com/office/drawing/2014/main" id="{26D821BB-B0F2-4D52-8127-87BE1109E61C}"/>
               </a:ext>
             </a:extLst>
           </p:cNvPr>
@@ -8781,7 +8781,7 @@
           <p:cNvPr id="2" name="">
             <a:extLst xmlns:a="http://schemas.openxmlformats.org/drawingml/2006/main">
               <a:ext uri="{FF2B5EF4-FFF2-40B4-BE49-F238E27FC236}">
-                <a16:creationId xmlns:a16="http://schemas.microsoft.com/office/drawing/2014/main" id="{29B57260-1661-4CD4-993F-862CA3E2E08C}"/>
+                <a16:creationId xmlns:a16="http://schemas.microsoft.com/office/drawing/2014/main" id="{A2CC938E-6991-44F2-AD2B-1B96F54AC5FB}"/>
               </a:ext>
             </a:extLst>
           </p:cNvPr>
@@ -8812,7 +8812,7 @@
           <p:cNvPr id="3" name="">
             <a:extLst xmlns:a="http://schemas.openxmlformats.org/drawingml/2006/main">
               <a:ext uri="{FF2B5EF4-FFF2-40B4-BE49-F238E27FC236}">
-                <a16:creationId xmlns:a16="http://schemas.microsoft.com/office/drawing/2014/main" id="{5A4D3D5A-BAD1-4F10-B165-7F74C0C9C2AA}"/>
+                <a16:creationId xmlns:a16="http://schemas.microsoft.com/office/drawing/2014/main" id="{82E402EA-7B64-422E-963C-A92B121E684A}"/>
               </a:ext>
             </a:extLst>
           </p:cNvPr>
@@ -8873,7 +8873,7 @@
           <p:cNvPr id="4" name="">
             <a:extLst xmlns:a="http://schemas.openxmlformats.org/drawingml/2006/main">
               <a:ext uri="{FF2B5EF4-FFF2-40B4-BE49-F238E27FC236}">
-                <a16:creationId xmlns:a16="http://schemas.microsoft.com/office/drawing/2014/main" id="{0E4B7514-9C73-4DEF-B2FA-6851789EDFCD}"/>
+                <a16:creationId xmlns:a16="http://schemas.microsoft.com/office/drawing/2014/main" id="{34A9C352-69E6-48CE-A683-2EBBD4FE98EF}"/>
               </a:ext>
             </a:extLst>
           </p:cNvPr>
@@ -8934,7 +8934,7 @@
           <p:cNvPr id="5" name="">
             <a:extLst xmlns:a="http://schemas.openxmlformats.org/drawingml/2006/main">
               <a:ext uri="{FF2B5EF4-FFF2-40B4-BE49-F238E27FC236}">
-                <a16:creationId xmlns:a16="http://schemas.microsoft.com/office/drawing/2014/main" id="{6D95F6C1-BE8A-42B2-928D-995EAE23125F}"/>
+                <a16:creationId xmlns:a16="http://schemas.microsoft.com/office/drawing/2014/main" id="{229B2765-2433-4E5C-9B65-2E53BC430F23}"/>
               </a:ext>
             </a:extLst>
           </p:cNvPr>
@@ -8995,7 +8995,7 @@
           <p:cNvPr id="6" name="">
             <a:extLst xmlns:a="http://schemas.openxmlformats.org/drawingml/2006/main">
               <a:ext uri="{FF2B5EF4-FFF2-40B4-BE49-F238E27FC236}">
-                <a16:creationId xmlns:a16="http://schemas.microsoft.com/office/drawing/2014/main" id="{53A3CF1B-A9AB-45A5-A2EC-A1B015B8D1AA}"/>
+                <a16:creationId xmlns:a16="http://schemas.microsoft.com/office/drawing/2014/main" id="{A494EADC-814E-4E22-8A84-C85D9363EC03}"/>
               </a:ext>
             </a:extLst>
           </p:cNvPr>
@@ -9056,7 +9056,7 @@
           <p:cNvPr id="7" name="">
             <a:extLst xmlns:a="http://schemas.openxmlformats.org/drawingml/2006/main">
               <a:ext uri="{FF2B5EF4-FFF2-40B4-BE49-F238E27FC236}">
-                <a16:creationId xmlns:a16="http://schemas.microsoft.com/office/drawing/2014/main" id="{1A5C0943-C42D-4FB5-85DA-FD2B70020791}"/>
+                <a16:creationId xmlns:a16="http://schemas.microsoft.com/office/drawing/2014/main" id="{1FE951A2-3249-41C6-9544-06B85455FED7}"/>
               </a:ext>
             </a:extLst>
           </p:cNvPr>
@@ -9171,7 +9171,7 @@
           <p:cNvPr id="8" name="">
             <a:extLst xmlns:a="http://schemas.openxmlformats.org/drawingml/2006/main">
               <a:ext uri="{FF2B5EF4-FFF2-40B4-BE49-F238E27FC236}">
-                <a16:creationId xmlns:a16="http://schemas.microsoft.com/office/drawing/2014/main" id="{9F6D1755-868E-4B3E-B2E0-3DF2186879AD}"/>
+                <a16:creationId xmlns:a16="http://schemas.microsoft.com/office/drawing/2014/main" id="{2DF49F1E-7BE0-48EC-958A-1FEFEAF897D4}"/>
               </a:ext>
             </a:extLst>
           </p:cNvPr>
@@ -9202,7 +9202,7 @@
           <p:cNvPr id="9" name="">
             <a:extLst xmlns:a="http://schemas.openxmlformats.org/drawingml/2006/main">
               <a:ext uri="{FF2B5EF4-FFF2-40B4-BE49-F238E27FC236}">
-                <a16:creationId xmlns:a16="http://schemas.microsoft.com/office/drawing/2014/main" id="{B4F34D84-5399-463A-8052-57B192321867}"/>
+                <a16:creationId xmlns:a16="http://schemas.microsoft.com/office/drawing/2014/main" id="{7A23CAA3-CA8B-4C2B-AF34-B36310F9D2DE}"/>
               </a:ext>
             </a:extLst>
           </p:cNvPr>
@@ -9263,7 +9263,7 @@
           <p:cNvPr id="10" name="">
             <a:extLst xmlns:a="http://schemas.openxmlformats.org/drawingml/2006/main">
               <a:ext uri="{FF2B5EF4-FFF2-40B4-BE49-F238E27FC236}">
-                <a16:creationId xmlns:a16="http://schemas.microsoft.com/office/drawing/2014/main" id="{D9F75444-225E-4C4F-9659-33075D714F21}"/>
+                <a16:creationId xmlns:a16="http://schemas.microsoft.com/office/drawing/2014/main" id="{24B2F1AB-783B-44BC-9940-263844491F7B}"/>
               </a:ext>
             </a:extLst>
           </p:cNvPr>
@@ -9378,7 +9378,7 @@
           <p:cNvPr id="11" name="">
             <a:extLst xmlns:a="http://schemas.openxmlformats.org/drawingml/2006/main">
               <a:ext uri="{FF2B5EF4-FFF2-40B4-BE49-F238E27FC236}">
-                <a16:creationId xmlns:a16="http://schemas.microsoft.com/office/drawing/2014/main" id="{9476A1E1-CCF6-4F77-AB39-D96A4721AE98}"/>
+                <a16:creationId xmlns:a16="http://schemas.microsoft.com/office/drawing/2014/main" id="{62389484-007C-4A8A-AB3E-05EDC4095A05}"/>
               </a:ext>
             </a:extLst>
           </p:cNvPr>
@@ -9439,7 +9439,7 @@
           <p:cNvPr id="12" name="">
             <a:extLst xmlns:a="http://schemas.openxmlformats.org/drawingml/2006/main">
               <a:ext uri="{FF2B5EF4-FFF2-40B4-BE49-F238E27FC236}">
-                <a16:creationId xmlns:a16="http://schemas.microsoft.com/office/drawing/2014/main" id="{940FFA9E-CA23-4588-B00F-1777508A1176}"/>
+                <a16:creationId xmlns:a16="http://schemas.microsoft.com/office/drawing/2014/main" id="{70F2C8BD-1A6A-4A75-AA33-C4FE8DE9E7B5}"/>
               </a:ext>
             </a:extLst>
           </p:cNvPr>
@@ -9470,7 +9470,7 @@
           <p:cNvPr id="13" name="">
             <a:extLst xmlns:a="http://schemas.openxmlformats.org/drawingml/2006/main">
               <a:ext uri="{FF2B5EF4-FFF2-40B4-BE49-F238E27FC236}">
-                <a16:creationId xmlns:a16="http://schemas.microsoft.com/office/drawing/2014/main" id="{07E897D5-EAC2-467F-AC08-EC558607CD08}"/>
+                <a16:creationId xmlns:a16="http://schemas.microsoft.com/office/drawing/2014/main" id="{59C925B8-1FB6-4F4B-A27F-87443A9D15EE}"/>
               </a:ext>
             </a:extLst>
           </p:cNvPr>
@@ -9531,7 +9531,7 @@
           <p:cNvPr id="14" name="">
             <a:extLst xmlns:a="http://schemas.openxmlformats.org/drawingml/2006/main">
               <a:ext uri="{FF2B5EF4-FFF2-40B4-BE49-F238E27FC236}">
-                <a16:creationId xmlns:a16="http://schemas.microsoft.com/office/drawing/2014/main" id="{FFE5466E-4A4F-4D6C-8278-DF2DF0B8B81B}"/>
+                <a16:creationId xmlns:a16="http://schemas.microsoft.com/office/drawing/2014/main" id="{1552F4E2-D237-4C19-BD6C-0B198D106F19}"/>
               </a:ext>
             </a:extLst>
           </p:cNvPr>
@@ -9582,7 +9582,7 @@
                 <a:ea typeface="Helvetica Neue"/>
                 <a:cs typeface="Helvetica Neue"/>
               </a:rPr>
-              <a:t>dividendx.payai.network</a:t>
+              <a:t>divx.payai.network</a:t>
             </a:r>
           </a:p>
         </p:txBody>
@@ -9592,7 +9592,7 @@
           <p:cNvPr id="15" name="">
             <a:extLst xmlns:a="http://schemas.openxmlformats.org/drawingml/2006/main">
               <a:ext uri="{FF2B5EF4-FFF2-40B4-BE49-F238E27FC236}">
-                <a16:creationId xmlns:a16="http://schemas.microsoft.com/office/drawing/2014/main" id="{2940629A-7B12-4A94-B66A-0CDA59181362}"/>
+                <a16:creationId xmlns:a16="http://schemas.microsoft.com/office/drawing/2014/main" id="{E6B0DD01-290D-4CBE-9AA0-FB6B341A14BD}"/>
               </a:ext>
             </a:extLst>
           </p:cNvPr>
@@ -9651,7 +9651,7 @@
     </p:spTree>
     <p:extLst>
       <p:ext uri="{BB962C8B-B14F-4D97-AF65-F5344CB8AC3E}">
-        <p14:creationId xmlns:p14="http://schemas.microsoft.com/office/powerpoint/2010/main" val="182389321"/>
+        <p14:creationId xmlns:p14="http://schemas.microsoft.com/office/powerpoint/2010/main" val="964827560"/>
       </p:ext>
     </p:extLst>
   </p:cSld>

</xml_diff>